<commit_message>
Bilingual (JP/EN) contest slides with real device photos
</commit_message>
<xml_diff>
--- a/docs/iroirotokei_contest_slides.pptx
+++ b/docs/iroirotokei_contest_slides.pptx
@@ -15,6 +15,7 @@
     <p:sldId id="263" r:id="rId14"/>
     <p:sldId id="264" r:id="rId15"/>
     <p:sldId id="265" r:id="rId16"/>
+    <p:sldId id="266" r:id="rId17"/>
   </p:sldIdLst>
   <p:sldSz cx="12191695" cy="6858000" type="screen4x3"/>
   <p:notesSz cx="6858000" cy="9144000"/>
@@ -3123,7 +3124,7 @@
       </p:pic>
       <p:pic>
         <p:nvPicPr>
-          <p:cNvPr id="3" name="Picture 2" descr="mock_clock.png"/>
+          <p:cNvPr id="3" name="Picture 2" descr="photo_clock.png"/>
           <p:cNvPicPr>
             <a:picLocks noChangeAspect="1"/>
           </p:cNvPicPr>
@@ -3249,6 +3250,9 @@
               <a:lnSpc>
                 <a:spcPct val="130000"/>
               </a:lnSpc>
+              <a:spcAft>
+                <a:spcPts val="1400"/>
+              </a:spcAft>
             </a:pPr>
             <a:r>
               <a:rPr sz="1700" b="0" i="0">
@@ -3260,6 +3264,24 @@
                 <a:cs typeface="Meiryo"/>
               </a:rPr>
               <a:t>かたむければ水彩のように混ざり、声さえも色になる。</a:t>
+            </a:r>
+          </a:p>
+          <a:p>
+            <a:pPr algn="l">
+              <a:lnSpc>
+                <a:spcPct val="125000"/>
+              </a:lnSpc>
+            </a:pPr>
+            <a:r>
+              <a:rPr sz="1300" b="0" i="0">
+                <a:solidFill>
+                  <a:srgbClr val="A9B4D6"/>
+                </a:solidFill>
+                <a:latin typeface="Meiryo"/>
+                <a:ea typeface="Meiryo"/>
+                <a:cs typeface="Meiryo"/>
+              </a:rPr>
+              <a:t>A clock that drifts through the sky's colors over 24 hours — mix colors, hear them as notes, paint by tilting, and even your voice becomes color.</a:t>
             </a:r>
           </a:p>
         </p:txBody>
@@ -3319,6 +3341,626 @@
         <p:nvPr/>
       </p:nvGrpSpPr>
       <p:grpSpPr/>
+      <p:sp>
+        <p:nvSpPr>
+          <p:cNvPr id="2" name="Rectangle 1"/>
+          <p:cNvSpPr/>
+          <p:nvPr/>
+        </p:nvSpPr>
+        <p:spPr>
+          <a:xfrm>
+            <a:off x="0" y="0"/>
+            <a:ext cx="12191695" cy="6858000"/>
+          </a:xfrm>
+          <a:prstGeom prst="rect">
+            <a:avLst/>
+          </a:prstGeom>
+          <a:solidFill>
+            <a:srgbClr val="0F1430"/>
+          </a:solidFill>
+          <a:ln>
+            <a:noFill/>
+          </a:ln>
+          <a:effectLst/>
+        </p:spPr>
+        <p:style>
+          <a:lnRef idx="1">
+            <a:schemeClr val="accent1"/>
+          </a:lnRef>
+          <a:fillRef idx="3">
+            <a:schemeClr val="accent1"/>
+          </a:fillRef>
+          <a:effectRef idx="2">
+            <a:schemeClr val="accent1"/>
+          </a:effectRef>
+          <a:fontRef idx="minor">
+            <a:schemeClr val="lt1"/>
+          </a:fontRef>
+        </p:style>
+        <p:txBody>
+          <a:bodyPr rtlCol="0" anchor="ctr"/>
+          <a:lstStyle/>
+          <a:p>
+            <a:pPr algn="ctr"/>
+          </a:p>
+        </p:txBody>
+      </p:sp>
+      <p:sp>
+        <p:nvSpPr>
+          <p:cNvPr id="3" name="TextBox 2"/>
+          <p:cNvSpPr txBox="1"/>
+          <p:nvPr/>
+        </p:nvSpPr>
+        <p:spPr>
+          <a:xfrm>
+            <a:off x="822960" y="457200"/>
+            <a:ext cx="10515600" cy="731520"/>
+          </a:xfrm>
+          <a:prstGeom prst="rect">
+            <a:avLst/>
+          </a:prstGeom>
+          <a:noFill/>
+        </p:spPr>
+        <p:txBody>
+          <a:bodyPr wrap="square" anchor="t" lIns="0" rIns="0" tIns="0" bIns="0">
+            <a:spAutoFit/>
+          </a:bodyPr>
+          <a:lstStyle/>
+          <a:p>
+            <a:pPr algn="l"/>
+            <a:r>
+              <a:rPr sz="3000" b="1" i="0">
+                <a:solidFill>
+                  <a:srgbClr val="F2F4FF"/>
+                </a:solidFill>
+                <a:latin typeface="Meiryo"/>
+                <a:ea typeface="Meiryo"/>
+                <a:cs typeface="Meiryo"/>
+              </a:rPr>
+              <a:t>つくりかた — 技術構成</a:t>
+            </a:r>
+          </a:p>
+        </p:txBody>
+      </p:sp>
+      <p:sp>
+        <p:nvSpPr>
+          <p:cNvPr id="4" name="TextBox 3"/>
+          <p:cNvSpPr txBox="1"/>
+          <p:nvPr/>
+        </p:nvSpPr>
+        <p:spPr>
+          <a:xfrm>
+            <a:off x="822960" y="969264"/>
+            <a:ext cx="10515600" cy="365760"/>
+          </a:xfrm>
+          <a:prstGeom prst="rect">
+            <a:avLst/>
+          </a:prstGeom>
+          <a:noFill/>
+        </p:spPr>
+        <p:txBody>
+          <a:bodyPr wrap="square" anchor="t" lIns="0" rIns="0" tIns="0" bIns="0">
+            <a:spAutoFit/>
+          </a:bodyPr>
+          <a:lstStyle/>
+          <a:p>
+            <a:pPr algn="l"/>
+            <a:r>
+              <a:rPr sz="1400" b="0" i="1">
+                <a:solidFill>
+                  <a:srgbClr val="A9B4D6"/>
+                </a:solidFill>
+                <a:latin typeface="Meiryo"/>
+                <a:ea typeface="Meiryo"/>
+                <a:cs typeface="Meiryo"/>
+              </a:rPr>
+              <a:t>How it works — hardware &amp; software</a:t>
+            </a:r>
+          </a:p>
+        </p:txBody>
+      </p:sp>
+      <p:sp>
+        <p:nvSpPr>
+          <p:cNvPr id="5" name="Rounded Rectangle 4"/>
+          <p:cNvSpPr/>
+          <p:nvPr/>
+        </p:nvSpPr>
+        <p:spPr>
+          <a:xfrm>
+            <a:off x="822960" y="1371600"/>
+            <a:ext cx="5257800" cy="4206240"/>
+          </a:xfrm>
+          <a:prstGeom prst="roundRect">
+            <a:avLst>
+              <a:gd name="adj" fmla="val 4500"/>
+            </a:avLst>
+          </a:prstGeom>
+          <a:solidFill>
+            <a:srgbClr val="1B2248"/>
+          </a:solidFill>
+          <a:ln>
+            <a:noFill/>
+          </a:ln>
+          <a:effectLst/>
+        </p:spPr>
+        <p:style>
+          <a:lnRef idx="1">
+            <a:schemeClr val="accent1"/>
+          </a:lnRef>
+          <a:fillRef idx="3">
+            <a:schemeClr val="accent1"/>
+          </a:fillRef>
+          <a:effectRef idx="2">
+            <a:schemeClr val="accent1"/>
+          </a:effectRef>
+          <a:fontRef idx="minor">
+            <a:schemeClr val="lt1"/>
+          </a:fontRef>
+        </p:style>
+        <p:txBody>
+          <a:bodyPr rtlCol="0" anchor="ctr"/>
+          <a:lstStyle/>
+          <a:p>
+            <a:pPr algn="ctr"/>
+          </a:p>
+        </p:txBody>
+      </p:sp>
+      <p:sp>
+        <p:nvSpPr>
+          <p:cNvPr id="6" name="TextBox 5"/>
+          <p:cNvSpPr txBox="1"/>
+          <p:nvPr/>
+        </p:nvSpPr>
+        <p:spPr>
+          <a:xfrm>
+            <a:off x="1188720" y="1645920"/>
+            <a:ext cx="4526280" cy="3657600"/>
+          </a:xfrm>
+          <a:prstGeom prst="rect">
+            <a:avLst/>
+          </a:prstGeom>
+          <a:noFill/>
+        </p:spPr>
+        <p:txBody>
+          <a:bodyPr wrap="square" anchor="t" lIns="0" rIns="0" tIns="0" bIns="0">
+            <a:spAutoFit/>
+          </a:bodyPr>
+          <a:lstStyle/>
+          <a:p>
+            <a:pPr algn="l">
+              <a:spcAft>
+                <a:spcPts val="1000"/>
+              </a:spcAft>
+            </a:pPr>
+            <a:r>
+              <a:rPr sz="1900" b="1" i="0">
+                <a:solidFill>
+                  <a:srgbClr val="F9C46B"/>
+                </a:solidFill>
+                <a:latin typeface="Meiryo"/>
+                <a:ea typeface="Meiryo"/>
+                <a:cs typeface="Meiryo"/>
+              </a:rPr>
+              <a:t>ハードウェア / Hardware</a:t>
+            </a:r>
+          </a:p>
+          <a:p>
+            <a:pPr algn="l">
+              <a:lnSpc>
+                <a:spcPct val="115000"/>
+              </a:lnSpc>
+              <a:spcAft>
+                <a:spcPts val="600"/>
+              </a:spcAft>
+            </a:pPr>
+            <a:r>
+              <a:rPr sz="1400" b="0" i="0">
+                <a:solidFill>
+                  <a:srgbClr val="F2F4FF"/>
+                </a:solidFill>
+                <a:latin typeface="Meiryo"/>
+                <a:ea typeface="Meiryo"/>
+                <a:cs typeface="Meiryo"/>
+              </a:rPr>
+              <a:t>・M5Stack StopWatch (ESP32-S3R8, 240MHz)</a:t>
+            </a:r>
+          </a:p>
+          <a:p>
+            <a:pPr algn="l">
+              <a:lnSpc>
+                <a:spcPct val="115000"/>
+              </a:lnSpc>
+              <a:spcAft>
+                <a:spcPts val="600"/>
+              </a:spcAft>
+            </a:pPr>
+            <a:r>
+              <a:rPr sz="1400" b="0" i="0">
+                <a:solidFill>
+                  <a:srgbClr val="F2F4FF"/>
+                </a:solidFill>
+                <a:latin typeface="Meiryo"/>
+                <a:ea typeface="Meiryo"/>
+                <a:cs typeface="Meiryo"/>
+              </a:rPr>
+              <a:t>・1.75インチ 円形AMOLEDタッチ 466×466</a:t>
+            </a:r>
+          </a:p>
+          <a:p>
+            <a:pPr algn="l">
+              <a:lnSpc>
+                <a:spcPct val="115000"/>
+              </a:lnSpc>
+              <a:spcAft>
+                <a:spcPts val="600"/>
+              </a:spcAft>
+            </a:pPr>
+            <a:r>
+              <a:rPr sz="1400" b="0" i="0">
+                <a:solidFill>
+                  <a:srgbClr val="F2F4FF"/>
+                </a:solidFill>
+                <a:latin typeface="Meiryo"/>
+                <a:ea typeface="Meiryo"/>
+                <a:cs typeface="Meiryo"/>
+              </a:rPr>
+              <a:t>・IMU BMI270 — 傾き検出・シェイク検出</a:t>
+            </a:r>
+          </a:p>
+          <a:p>
+            <a:pPr algn="l">
+              <a:lnSpc>
+                <a:spcPct val="115000"/>
+              </a:lnSpc>
+              <a:spcAft>
+                <a:spcPts val="600"/>
+              </a:spcAft>
+            </a:pPr>
+            <a:r>
+              <a:rPr sz="1400" b="0" i="0">
+                <a:solidFill>
+                  <a:srgbClr val="F2F4FF"/>
+                </a:solidFill>
+                <a:latin typeface="Meiryo"/>
+                <a:ea typeface="Meiryo"/>
+                <a:cs typeface="Meiryo"/>
+              </a:rPr>
+              <a:t>・ES8311 コーデック + 1Wスピーカー + マイク</a:t>
+            </a:r>
+          </a:p>
+          <a:p>
+            <a:pPr algn="l">
+              <a:lnSpc>
+                <a:spcPct val="115000"/>
+              </a:lnSpc>
+              <a:spcAft>
+                <a:spcPts val="600"/>
+              </a:spcAft>
+            </a:pPr>
+            <a:r>
+              <a:rPr sz="1400" b="0" i="0">
+                <a:solidFill>
+                  <a:srgbClr val="F2F4FF"/>
+                </a:solidFill>
+                <a:latin typeface="Meiryo"/>
+                <a:ea typeface="Meiryo"/>
+                <a:cs typeface="Meiryo"/>
+              </a:rPr>
+              <a:t>・RTC RX8130CE + Wi-Fi (時刻はNTPで自動同期)</a:t>
+            </a:r>
+          </a:p>
+          <a:p>
+            <a:pPr algn="l">
+              <a:lnSpc>
+                <a:spcPct val="115000"/>
+              </a:lnSpc>
+              <a:spcAft>
+                <a:spcPts val="600"/>
+              </a:spcAft>
+            </a:pPr>
+            <a:r>
+              <a:rPr sz="1400" b="0" i="0">
+                <a:solidFill>
+                  <a:srgbClr val="F2F4FF"/>
+                </a:solidFill>
+                <a:latin typeface="Meiryo"/>
+                <a:ea typeface="Meiryo"/>
+                <a:cs typeface="Meiryo"/>
+              </a:rPr>
+              <a:t>・Unit Hex (SK6812×37) をPortAに接続可</a:t>
+            </a:r>
+          </a:p>
+          <a:p>
+            <a:pPr algn="l">
+              <a:lnSpc>
+                <a:spcPct val="115000"/>
+              </a:lnSpc>
+              <a:spcAft>
+                <a:spcPts val="600"/>
+              </a:spcAft>
+            </a:pPr>
+            <a:r>
+              <a:rPr sz="1400" b="0" i="0">
+                <a:solidFill>
+                  <a:srgbClr val="F2F4FF"/>
+                </a:solidFill>
+                <a:latin typeface="Meiryo"/>
+                <a:ea typeface="Meiryo"/>
+                <a:cs typeface="Meiryo"/>
+              </a:rPr>
+              <a:t>・3Dプリント製スタンド (Unit Hex組み込み)</a:t>
+            </a:r>
+          </a:p>
+        </p:txBody>
+      </p:sp>
+      <p:sp>
+        <p:nvSpPr>
+          <p:cNvPr id="7" name="Rounded Rectangle 6"/>
+          <p:cNvSpPr/>
+          <p:nvPr/>
+        </p:nvSpPr>
+        <p:spPr>
+          <a:xfrm>
+            <a:off x="6172200" y="1371600"/>
+            <a:ext cx="5257800" cy="4206240"/>
+          </a:xfrm>
+          <a:prstGeom prst="roundRect">
+            <a:avLst>
+              <a:gd name="adj" fmla="val 4500"/>
+            </a:avLst>
+          </a:prstGeom>
+          <a:solidFill>
+            <a:srgbClr val="1B2248"/>
+          </a:solidFill>
+          <a:ln>
+            <a:noFill/>
+          </a:ln>
+          <a:effectLst/>
+        </p:spPr>
+        <p:style>
+          <a:lnRef idx="1">
+            <a:schemeClr val="accent1"/>
+          </a:lnRef>
+          <a:fillRef idx="3">
+            <a:schemeClr val="accent1"/>
+          </a:fillRef>
+          <a:effectRef idx="2">
+            <a:schemeClr val="accent1"/>
+          </a:effectRef>
+          <a:fontRef idx="minor">
+            <a:schemeClr val="lt1"/>
+          </a:fontRef>
+        </p:style>
+        <p:txBody>
+          <a:bodyPr rtlCol="0" anchor="ctr"/>
+          <a:lstStyle/>
+          <a:p>
+            <a:pPr algn="ctr"/>
+          </a:p>
+        </p:txBody>
+      </p:sp>
+      <p:sp>
+        <p:nvSpPr>
+          <p:cNvPr id="8" name="TextBox 7"/>
+          <p:cNvSpPr txBox="1"/>
+          <p:nvPr/>
+        </p:nvSpPr>
+        <p:spPr>
+          <a:xfrm>
+            <a:off x="6537960" y="1645920"/>
+            <a:ext cx="4526280" cy="3657600"/>
+          </a:xfrm>
+          <a:prstGeom prst="rect">
+            <a:avLst/>
+          </a:prstGeom>
+          <a:noFill/>
+        </p:spPr>
+        <p:txBody>
+          <a:bodyPr wrap="square" anchor="t" lIns="0" rIns="0" tIns="0" bIns="0">
+            <a:spAutoFit/>
+          </a:bodyPr>
+          <a:lstStyle/>
+          <a:p>
+            <a:pPr algn="l">
+              <a:spcAft>
+                <a:spcPts val="1000"/>
+              </a:spcAft>
+            </a:pPr>
+            <a:r>
+              <a:rPr sz="1900" b="1" i="0">
+                <a:solidFill>
+                  <a:srgbClr val="F9C46B"/>
+                </a:solidFill>
+                <a:latin typeface="Meiryo"/>
+                <a:ea typeface="Meiryo"/>
+                <a:cs typeface="Meiryo"/>
+              </a:rPr>
+              <a:t>ソフトウェア / Software</a:t>
+            </a:r>
+          </a:p>
+          <a:p>
+            <a:pPr algn="l">
+              <a:lnSpc>
+                <a:spcPct val="115000"/>
+              </a:lnSpc>
+              <a:spcAft>
+                <a:spcPts val="600"/>
+              </a:spcAft>
+            </a:pPr>
+            <a:r>
+              <a:rPr sz="1400" b="0" i="0">
+                <a:solidFill>
+                  <a:srgbClr val="F2F4FF"/>
+                </a:solidFill>
+                <a:latin typeface="Meiryo"/>
+                <a:ea typeface="Meiryo"/>
+                <a:cs typeface="Meiryo"/>
+              </a:rPr>
+              <a:t>・PlatformIO + Arduino + M5Unified / FastLED</a:t>
+            </a:r>
+          </a:p>
+          <a:p>
+            <a:pPr algn="l">
+              <a:lnSpc>
+                <a:spcPct val="115000"/>
+              </a:lnSpc>
+              <a:spcAft>
+                <a:spcPts val="600"/>
+              </a:spcAft>
+            </a:pPr>
+            <a:r>
+              <a:rPr sz="1400" b="0" i="0">
+                <a:solidFill>
+                  <a:srgbClr val="F2F4FF"/>
+                </a:solidFill>
+                <a:latin typeface="Meiryo"/>
+                <a:ea typeface="Meiryo"/>
+                <a:cs typeface="Meiryo"/>
+              </a:rPr>
+              <a:t>・カラーエンジン: 14キーフレームの線形補間</a:t>
+            </a:r>
+          </a:p>
+          <a:p>
+            <a:pPr algn="l">
+              <a:lnSpc>
+                <a:spcPct val="115000"/>
+              </a:lnSpc>
+              <a:spcAft>
+                <a:spcPts val="600"/>
+              </a:spcAft>
+            </a:pPr>
+            <a:r>
+              <a:rPr sz="1400" b="0" i="0">
+                <a:solidFill>
+                  <a:srgbClr val="F2F4FF"/>
+                </a:solidFill>
+                <a:latin typeface="Meiryo"/>
+                <a:ea typeface="Meiryo"/>
+                <a:cs typeface="Meiryo"/>
+              </a:rPr>
+              <a:t>・混色: 累積平均 / 水彩: 58×58格子の拡散 (15fps)</a:t>
+            </a:r>
+          </a:p>
+          <a:p>
+            <a:pPr algn="l">
+              <a:lnSpc>
+                <a:spcPct val="115000"/>
+              </a:lnSpc>
+              <a:spcAft>
+                <a:spcPts val="600"/>
+              </a:spcAft>
+            </a:pPr>
+            <a:r>
+              <a:rPr sz="1400" b="0" i="0">
+                <a:solidFill>
+                  <a:srgbClr val="F2F4FF"/>
+                </a:solidFill>
+                <a:latin typeface="Meiryo"/>
+                <a:ea typeface="Meiryo"/>
+                <a:cs typeface="Meiryo"/>
+              </a:rPr>
+              <a:t>・色→音: 色相→ペンタトニック2オクターブ</a:t>
+            </a:r>
+          </a:p>
+          <a:p>
+            <a:pPr algn="l">
+              <a:lnSpc>
+                <a:spcPct val="115000"/>
+              </a:lnSpc>
+              <a:spcAft>
+                <a:spcPts val="600"/>
+              </a:spcAft>
+            </a:pPr>
+            <a:r>
+              <a:rPr sz="1400" b="0" i="0">
+                <a:solidFill>
+                  <a:srgbClr val="F2F4FF"/>
+                </a:solidFill>
+                <a:latin typeface="Meiryo"/>
+                <a:ea typeface="Meiryo"/>
+                <a:cs typeface="Meiryo"/>
+              </a:rPr>
+              <a:t>・声→色: RMS (大きさ) + ゼロ交差率 (高さ)</a:t>
+            </a:r>
+          </a:p>
+          <a:p>
+            <a:pPr algn="l">
+              <a:lnSpc>
+                <a:spcPct val="115000"/>
+              </a:lnSpc>
+              <a:spcAft>
+                <a:spcPts val="600"/>
+              </a:spcAft>
+            </a:pPr>
+            <a:r>
+              <a:rPr sz="1400" b="0" i="0">
+                <a:solidFill>
+                  <a:srgbClr val="F2F4FF"/>
+                </a:solidFill>
+                <a:latin typeface="Meiryo"/>
+                <a:ea typeface="Meiryo"/>
+                <a:cs typeface="Meiryo"/>
+              </a:rPr>
+              <a:t>・Wi-Fi設定はスマホから / 設定はNVSへ永続化</a:t>
+            </a:r>
+          </a:p>
+        </p:txBody>
+      </p:sp>
+      <p:sp>
+        <p:nvSpPr>
+          <p:cNvPr id="9" name="TextBox 8"/>
+          <p:cNvSpPr txBox="1"/>
+          <p:nvPr/>
+        </p:nvSpPr>
+        <p:spPr>
+          <a:xfrm>
+            <a:off x="822960" y="5897880"/>
+            <a:ext cx="10607040" cy="457200"/>
+          </a:xfrm>
+          <a:prstGeom prst="rect">
+            <a:avLst/>
+          </a:prstGeom>
+          <a:noFill/>
+        </p:spPr>
+        <p:txBody>
+          <a:bodyPr wrap="square" anchor="t" lIns="0" rIns="0" tIns="0" bIns="0">
+            <a:spAutoFit/>
+          </a:bodyPr>
+          <a:lstStyle/>
+          <a:p>
+            <a:pPr algn="ctr"/>
+            <a:r>
+              <a:rPr sz="1400" b="0" i="0">
+                <a:solidFill>
+                  <a:srgbClr val="A9B4D6"/>
+                </a:solidFill>
+                <a:latin typeface="Meiryo"/>
+                <a:ea typeface="Meiryo"/>
+                <a:cs typeface="Meiryo"/>
+              </a:rPr>
+              <a:t>ソースコード・ビルド手順・STLを全公開 / Full source, build steps &amp; STL: github.com/aokko2000/iroirotokei</a:t>
+            </a:r>
+          </a:p>
+        </p:txBody>
+      </p:sp>
+    </p:spTree>
+  </p:cSld>
+  <p:clrMapOvr>
+    <a:masterClrMapping/>
+  </p:clrMapOvr>
+</p:sld>
+</file>
+
+<file path=ppt/slides/slide11.xml><?xml version="1.0" encoding="utf-8"?>
+<p:sld xmlns:a="http://schemas.openxmlformats.org/drawingml/2006/main" xmlns:p="http://schemas.openxmlformats.org/presentationml/2006/main" xmlns:r="http://schemas.openxmlformats.org/officeDocument/2006/relationships">
+  <p:cSld>
+    <p:spTree>
+      <p:nvGrpSpPr>
+        <p:cNvPr id="1" name=""/>
+        <p:cNvGrpSpPr/>
+        <p:nvPr/>
+      </p:nvGrpSpPr>
+      <p:grpSpPr/>
       <p:pic>
         <p:nvPicPr>
           <p:cNvPr id="2" name="Picture 1" descr="bg_night.png"/>
@@ -3367,7 +4009,7 @@
           <a:p>
             <a:pPr algn="ctr">
               <a:spcAft>
-                <a:spcPts val="1600"/>
+                <a:spcPts val="600"/>
               </a:spcAft>
             </a:pPr>
             <a:r>
@@ -3380,6 +4022,24 @@
                 <a:cs typeface="Meiryo"/>
               </a:rPr>
               <a:t>空を、手のひらに。</a:t>
+            </a:r>
+          </a:p>
+          <a:p>
+            <a:pPr algn="ctr">
+              <a:spcAft>
+                <a:spcPts val="1400"/>
+              </a:spcAft>
+            </a:pPr>
+            <a:r>
+              <a:rPr sz="2000" b="0" i="1">
+                <a:solidFill>
+                  <a:srgbClr val="A9B4D6"/>
+                </a:solidFill>
+                <a:latin typeface="Meiryo"/>
+                <a:ea typeface="Meiryo"/>
+                <a:cs typeface="Meiryo"/>
+              </a:rPr>
+              <a:t>The sky, in your palm.</a:t>
             </a:r>
           </a:p>
           <a:p>
@@ -3584,8 +4244,8 @@
         </p:nvSpPr>
         <p:spPr>
           <a:xfrm>
-            <a:off x="822960" y="1234440"/>
-            <a:ext cx="10515600" cy="548640"/>
+            <a:off x="822960" y="1207008"/>
+            <a:ext cx="10515600" cy="640080"/>
           </a:xfrm>
           <a:prstGeom prst="rect">
             <a:avLst/>
@@ -3598,9 +4258,27 @@
           </a:bodyPr>
           <a:lstStyle/>
           <a:p>
+            <a:pPr algn="l">
+              <a:spcAft>
+                <a:spcPts val="300"/>
+              </a:spcAft>
+            </a:pPr>
+            <a:r>
+              <a:rPr sz="1500" b="0" i="0">
+                <a:solidFill>
+                  <a:srgbClr val="A9B4D6"/>
+                </a:solidFill>
+                <a:latin typeface="Meiryo"/>
+                <a:ea typeface="Meiryo"/>
+                <a:cs typeface="Meiryo"/>
+              </a:rPr>
+              <a:t>時計がなかった頃、人は空の色で時を知った。色時計はその感覚をデジタルに取り戻す。</a:t>
+            </a:r>
+          </a:p>
+          <a:p>
             <a:pPr algn="l"/>
             <a:r>
-              <a:rPr sz="1500" b="0" i="0">
+              <a:rPr sz="1250" b="0" i="1">
                 <a:solidFill>
                   <a:srgbClr val="A9B4D6"/>
                 </a:solidFill>
@@ -3608,7 +4286,7 @@
                 <a:ea typeface="Meiryo"/>
                 <a:cs typeface="Meiryo"/>
               </a:rPr>
-              <a:t>時計がなかった頃、人は空の色で時を知った。色時計はその感覚をデジタルに取り戻す。</a:t>
+              <a:t>Feel time as color, not numbers — before clocks, people read the hour from the sky.</a:t>
             </a:r>
           </a:p>
         </p:txBody>
@@ -4176,31 +4854,57 @@
             <a:r>
               <a:rPr sz="3000" b="1" i="0">
                 <a:solidFill>
-                  <a:srgbClr val="FF6350"/>
-                </a:solidFill>
-                <a:latin typeface="Meiryo"/>
-                <a:ea typeface="Meiryo"/>
-                <a:cs typeface="Meiryo"/>
-              </a:rPr>
-              <a:t>①  </a:t>
-            </a:r>
-            <a:r>
-              <a:rPr sz="3000" b="1" i="0">
-                <a:solidFill>
                   <a:srgbClr val="F2F4FF"/>
                 </a:solidFill>
                 <a:latin typeface="Meiryo"/>
                 <a:ea typeface="Meiryo"/>
                 <a:cs typeface="Meiryo"/>
               </a:rPr>
-              <a:t>色時計 — 空を写す文字盤</a:t>
+              <a:t>ぜんぶ、動いています — 実機デモ</a:t>
+            </a:r>
+          </a:p>
+        </p:txBody>
+      </p:sp>
+      <p:sp>
+        <p:nvSpPr>
+          <p:cNvPr id="4" name="TextBox 3"/>
+          <p:cNvSpPr txBox="1"/>
+          <p:nvPr/>
+        </p:nvSpPr>
+        <p:spPr>
+          <a:xfrm>
+            <a:off x="822960" y="969264"/>
+            <a:ext cx="10515600" cy="365760"/>
+          </a:xfrm>
+          <a:prstGeom prst="rect">
+            <a:avLst/>
+          </a:prstGeom>
+          <a:noFill/>
+        </p:spPr>
+        <p:txBody>
+          <a:bodyPr wrap="square" anchor="t" lIns="0" rIns="0" tIns="0" bIns="0">
+            <a:spAutoFit/>
+          </a:bodyPr>
+          <a:lstStyle/>
+          <a:p>
+            <a:pPr algn="l"/>
+            <a:r>
+              <a:rPr sz="1400" b="0" i="1">
+                <a:solidFill>
+                  <a:srgbClr val="A9B4D6"/>
+                </a:solidFill>
+                <a:latin typeface="Meiryo"/>
+                <a:ea typeface="Meiryo"/>
+                <a:cs typeface="Meiryo"/>
+              </a:rPr>
+              <a:t>All of it, running — live demo</a:t>
             </a:r>
           </a:p>
         </p:txBody>
       </p:sp>
       <p:pic>
         <p:nvPicPr>
-          <p:cNvPr id="4" name="Picture 3" descr="mock_clock.png"/>
+          <p:cNvPr id="5" name="Picture 4" descr="photo_timetravel.png"/>
           <p:cNvPicPr>
             <a:picLocks noChangeAspect="1"/>
           </p:cNvPicPr>
@@ -4214,8 +4918,8 @@
         </p:blipFill>
         <p:spPr>
           <a:xfrm>
-            <a:off x="777240" y="1417320"/>
-            <a:ext cx="4892040" cy="4892040"/>
+            <a:off x="822960" y="1371600"/>
+            <a:ext cx="3291840" cy="4389120"/>
           </a:xfrm>
           <a:prstGeom prst="rect">
             <a:avLst/>
@@ -4224,14 +4928,14 @@
       </p:pic>
       <p:sp>
         <p:nvSpPr>
-          <p:cNvPr id="5" name="TextBox 4"/>
+          <p:cNvPr id="6" name="TextBox 5"/>
           <p:cNvSpPr txBox="1"/>
           <p:nvPr/>
         </p:nvSpPr>
         <p:spPr>
           <a:xfrm>
-            <a:off x="6263640" y="1600200"/>
-            <a:ext cx="5120640" cy="1280160"/>
+            <a:off x="822960" y="5870448"/>
+            <a:ext cx="3291840" cy="548640"/>
           </a:xfrm>
           <a:prstGeom prst="rect">
             <a:avLst/>
@@ -4244,53 +4948,73 @@
           </a:bodyPr>
           <a:lstStyle/>
           <a:p>
-            <a:pPr algn="l">
+            <a:pPr algn="ctr">
               <a:spcAft>
-                <a:spcPts val="400"/>
+                <a:spcPts val="200"/>
               </a:spcAft>
             </a:pPr>
             <a:r>
-              <a:rPr sz="1800" b="1" i="0">
-                <a:solidFill>
-                  <a:srgbClr val="F9C46B"/>
-                </a:solidFill>
-                <a:latin typeface="Meiryo"/>
-                <a:ea typeface="Meiryo"/>
-                <a:cs typeface="Meiryo"/>
-              </a:rPr>
-              <a:t>毎秒、空の色を計算する</a:t>
-            </a:r>
-          </a:p>
-          <a:p>
-            <a:pPr algn="l">
-              <a:lnSpc>
-                <a:spcPct val="125000"/>
-              </a:lnSpc>
-            </a:pPr>
-            <a:r>
-              <a:rPr sz="1450" b="0" i="0">
-                <a:solidFill>
-                  <a:srgbClr val="F2F4FF"/>
-                </a:solidFill>
-                <a:latin typeface="Meiryo"/>
-                <a:ea typeface="Meiryo"/>
-                <a:cs typeface="Meiryo"/>
-              </a:rPr>
-              <a:t>14のキーカラーを線形補間し、朝焼けから夕闇へ。縁のリングに1日分の色が並び、白いマーカーが「いま」を指す。</a:t>
-            </a:r>
-          </a:p>
-        </p:txBody>
-      </p:sp>
-      <p:sp>
-        <p:nvSpPr>
-          <p:cNvPr id="6" name="TextBox 5"/>
+              <a:rPr sz="1250" b="0" i="0">
+                <a:solidFill>
+                  <a:srgbClr val="A9B4D6"/>
+                </a:solidFill>
+                <a:latin typeface="Meiryo"/>
+                <a:ea typeface="Meiryo"/>
+                <a:cs typeface="Meiryo"/>
+              </a:rPr>
+              <a:t>タイムトラベル — 指でなぞって朝焼けへ</a:t>
+            </a:r>
+          </a:p>
+          <a:p>
+            <a:pPr algn="ctr"/>
+            <a:r>
+              <a:rPr sz="1050" b="0" i="1">
+                <a:solidFill>
+                  <a:srgbClr val="A9B4D6"/>
+                </a:solidFill>
+                <a:latin typeface="Meiryo"/>
+                <a:ea typeface="Meiryo"/>
+                <a:cs typeface="Meiryo"/>
+              </a:rPr>
+              <a:t>Time Travel — drag to sunrise</a:t>
+            </a:r>
+          </a:p>
+        </p:txBody>
+      </p:sp>
+      <p:pic>
+        <p:nvPicPr>
+          <p:cNvPr id="7" name="Picture 6" descr="photo_tilt.png"/>
+          <p:cNvPicPr>
+            <a:picLocks noChangeAspect="1"/>
+          </p:cNvPicPr>
+          <p:nvPr/>
+        </p:nvPicPr>
+        <p:blipFill>
+          <a:blip r:embed="rId3"/>
+          <a:stretch>
+            <a:fillRect/>
+          </a:stretch>
+        </p:blipFill>
+        <p:spPr>
+          <a:xfrm>
+            <a:off x="4498848" y="1371600"/>
+            <a:ext cx="3291840" cy="4389120"/>
+          </a:xfrm>
+          <a:prstGeom prst="rect">
+            <a:avLst/>
+          </a:prstGeom>
+        </p:spPr>
+      </p:pic>
+      <p:sp>
+        <p:nvSpPr>
+          <p:cNvPr id="8" name="TextBox 7"/>
           <p:cNvSpPr txBox="1"/>
           <p:nvPr/>
         </p:nvSpPr>
         <p:spPr>
           <a:xfrm>
-            <a:off x="6263640" y="3246120"/>
-            <a:ext cx="5120640" cy="1280160"/>
+            <a:off x="4498848" y="5870448"/>
+            <a:ext cx="3291840" cy="548640"/>
           </a:xfrm>
           <a:prstGeom prst="rect">
             <a:avLst/>
@@ -4303,53 +5027,73 @@
           </a:bodyPr>
           <a:lstStyle/>
           <a:p>
-            <a:pPr algn="l">
+            <a:pPr algn="ctr">
               <a:spcAft>
-                <a:spcPts val="400"/>
+                <a:spcPts val="200"/>
               </a:spcAft>
             </a:pPr>
             <a:r>
-              <a:rPr sz="1800" b="1" i="0">
-                <a:solidFill>
-                  <a:srgbClr val="F9C46B"/>
-                </a:solidFill>
-                <a:latin typeface="Meiryo"/>
-                <a:ea typeface="Meiryo"/>
-                <a:cs typeface="Meiryo"/>
-              </a:rPr>
-              <a:t>タイムトラベル (タッチ)</a:t>
-            </a:r>
-          </a:p>
-          <a:p>
-            <a:pPr algn="l">
-              <a:lnSpc>
-                <a:spcPct val="125000"/>
-              </a:lnSpc>
-            </a:pPr>
-            <a:r>
-              <a:rPr sz="1450" b="0" i="0">
-                <a:solidFill>
-                  <a:srgbClr val="F2F4FF"/>
-                </a:solidFill>
-                <a:latin typeface="Meiryo"/>
-                <a:ea typeface="Meiryo"/>
-                <a:cs typeface="Meiryo"/>
-              </a:rPr>
-              <a:t>文字盤=24時間。画面をなぞると、その角度の時刻の色へ瞬間移動。時を越えるたびに音が鳴る。</a:t>
-            </a:r>
-          </a:p>
-        </p:txBody>
-      </p:sp>
-      <p:sp>
-        <p:nvSpPr>
-          <p:cNvPr id="7" name="TextBox 6"/>
+              <a:rPr sz="1250" b="0" i="0">
+                <a:solidFill>
+                  <a:srgbClr val="A9B4D6"/>
+                </a:solidFill>
+                <a:latin typeface="Meiryo"/>
+                <a:ea typeface="Meiryo"/>
+                <a:cs typeface="Meiryo"/>
+              </a:rPr>
+              <a:t>傾き絵の具 — 傾けて、にじませる</a:t>
+            </a:r>
+          </a:p>
+          <a:p>
+            <a:pPr algn="ctr"/>
+            <a:r>
+              <a:rPr sz="1050" b="0" i="1">
+                <a:solidFill>
+                  <a:srgbClr val="A9B4D6"/>
+                </a:solidFill>
+                <a:latin typeface="Meiryo"/>
+                <a:ea typeface="Meiryo"/>
+                <a:cs typeface="Meiryo"/>
+              </a:rPr>
+              <a:t>Tilt Paint — watercolor by gravity</a:t>
+            </a:r>
+          </a:p>
+        </p:txBody>
+      </p:sp>
+      <p:pic>
+        <p:nvPicPr>
+          <p:cNvPr id="9" name="Picture 8" descr="photo_mixer.png"/>
+          <p:cNvPicPr>
+            <a:picLocks noChangeAspect="1"/>
+          </p:cNvPicPr>
+          <p:nvPr/>
+        </p:nvPicPr>
+        <p:blipFill>
+          <a:blip r:embed="rId4"/>
+          <a:stretch>
+            <a:fillRect/>
+          </a:stretch>
+        </p:blipFill>
+        <p:spPr>
+          <a:xfrm>
+            <a:off x="8174736" y="1371600"/>
+            <a:ext cx="3291840" cy="4389120"/>
+          </a:xfrm>
+          <a:prstGeom prst="rect">
+            <a:avLst/>
+          </a:prstGeom>
+        </p:spPr>
+      </p:pic>
+      <p:sp>
+        <p:nvSpPr>
+          <p:cNvPr id="10" name="TextBox 9"/>
           <p:cNvSpPr txBox="1"/>
           <p:nvPr/>
         </p:nvSpPr>
         <p:spPr>
           <a:xfrm>
-            <a:off x="6263640" y="4892040"/>
-            <a:ext cx="5120640" cy="1280160"/>
+            <a:off x="8174736" y="5870448"/>
+            <a:ext cx="3291840" cy="548640"/>
           </a:xfrm>
           <a:prstGeom prst="rect">
             <a:avLst/>
@@ -4362,39 +5106,35 @@
           </a:bodyPr>
           <a:lstStyle/>
           <a:p>
-            <a:pPr algn="l">
+            <a:pPr algn="ctr">
               <a:spcAft>
-                <a:spcPts val="400"/>
+                <a:spcPts val="200"/>
               </a:spcAft>
             </a:pPr>
             <a:r>
-              <a:rPr sz="1800" b="1" i="0">
-                <a:solidFill>
-                  <a:srgbClr val="F9C46B"/>
-                </a:solidFill>
-                <a:latin typeface="Meiryo"/>
-                <a:ea typeface="Meiryo"/>
-                <a:cs typeface="Meiryo"/>
-              </a:rPr>
-              <a:t>1日を48秒で再生</a:t>
-            </a:r>
-          </a:p>
-          <a:p>
-            <a:pPr algn="l">
-              <a:lnSpc>
-                <a:spcPct val="125000"/>
-              </a:lnSpc>
-            </a:pPr>
-            <a:r>
-              <a:rPr sz="1450" b="0" i="0">
-                <a:solidFill>
-                  <a:srgbClr val="F2F4FF"/>
-                </a:solidFill>
-                <a:latin typeface="Meiryo"/>
-                <a:ea typeface="Meiryo"/>
-                <a:cs typeface="Meiryo"/>
-              </a:rPr>
-              <a:t>右長押しで24時間の色の旅をタイムラプス再生。1時間ごとにその色の音 — 1日が色とメロディになる。</a:t>
+              <a:rPr sz="1250" b="0" i="0">
+                <a:solidFill>
+                  <a:srgbClr val="A9B4D6"/>
+                </a:solidFill>
+                <a:latin typeface="Meiryo"/>
+                <a:ea typeface="Meiryo"/>
+                <a:cs typeface="Meiryo"/>
+              </a:rPr>
+              <a:t>色づくり — 混ぜて、聴く</a:t>
+            </a:r>
+          </a:p>
+          <a:p>
+            <a:pPr algn="ctr"/>
+            <a:r>
+              <a:rPr sz="1050" b="0" i="1">
+                <a:solidFill>
+                  <a:srgbClr val="A9B4D6"/>
+                </a:solidFill>
+                <a:latin typeface="Meiryo"/>
+                <a:ea typeface="Meiryo"/>
+                <a:cs typeface="Meiryo"/>
+              </a:rPr>
+              <a:t>Color Maker — mix it, hear it</a:t>
             </a:r>
           </a:p>
         </p:txBody>
@@ -4493,7 +5233,7 @@
                 <a:ea typeface="Meiryo"/>
                 <a:cs typeface="Meiryo"/>
               </a:rPr>
-              <a:t>②  </a:t>
+              <a:t>①  </a:t>
             </a:r>
             <a:r>
               <a:rPr sz="3000" b="1" i="0">
@@ -4504,14 +5244,51 @@
                 <a:ea typeface="Meiryo"/>
                 <a:cs typeface="Meiryo"/>
               </a:rPr>
-              <a:t>色づくり — 混ぜて、聴く</a:t>
+              <a:t>色時計 — 空を写す文字盤</a:t>
+            </a:r>
+          </a:p>
+        </p:txBody>
+      </p:sp>
+      <p:sp>
+        <p:nvSpPr>
+          <p:cNvPr id="4" name="TextBox 3"/>
+          <p:cNvSpPr txBox="1"/>
+          <p:nvPr/>
+        </p:nvSpPr>
+        <p:spPr>
+          <a:xfrm>
+            <a:off x="822960" y="969264"/>
+            <a:ext cx="10515600" cy="365760"/>
+          </a:xfrm>
+          <a:prstGeom prst="rect">
+            <a:avLst/>
+          </a:prstGeom>
+          <a:noFill/>
+        </p:spPr>
+        <p:txBody>
+          <a:bodyPr wrap="square" anchor="t" lIns="0" rIns="0" tIns="0" bIns="0">
+            <a:spAutoFit/>
+          </a:bodyPr>
+          <a:lstStyle/>
+          <a:p>
+            <a:pPr algn="l"/>
+            <a:r>
+              <a:rPr sz="1400" b="0" i="1">
+                <a:solidFill>
+                  <a:srgbClr val="A9B4D6"/>
+                </a:solidFill>
+                <a:latin typeface="Meiryo"/>
+                <a:ea typeface="Meiryo"/>
+                <a:cs typeface="Meiryo"/>
+              </a:rPr>
+              <a:t>Color Clock — a dial that mirrors the sky</a:t>
             </a:r>
           </a:p>
         </p:txBody>
       </p:sp>
       <p:pic>
         <p:nvPicPr>
-          <p:cNvPr id="4" name="Picture 3" descr="mock_mixer.png"/>
+          <p:cNvPr id="5" name="Picture 4" descr="mock_clock.png"/>
           <p:cNvPicPr>
             <a:picLocks noChangeAspect="1"/>
           </p:cNvPicPr>
@@ -4525,8 +5302,8 @@
         </p:blipFill>
         <p:spPr>
           <a:xfrm>
-            <a:off x="6537960" y="1417320"/>
-            <a:ext cx="4892040" cy="4892040"/>
+            <a:off x="777240" y="1508760"/>
+            <a:ext cx="4754880" cy="4754880"/>
           </a:xfrm>
           <a:prstGeom prst="rect">
             <a:avLst/>
@@ -4535,14 +5312,14 @@
       </p:pic>
       <p:sp>
         <p:nvSpPr>
-          <p:cNvPr id="5" name="TextBox 4"/>
+          <p:cNvPr id="6" name="TextBox 5"/>
           <p:cNvSpPr txBox="1"/>
           <p:nvPr/>
         </p:nvSpPr>
         <p:spPr>
           <a:xfrm>
-            <a:off x="822960" y="1600200"/>
-            <a:ext cx="5120640" cy="1280160"/>
+            <a:off x="6263640" y="1645920"/>
+            <a:ext cx="5120640" cy="1463040"/>
           </a:xfrm>
           <a:prstGeom prst="rect">
             <a:avLst/>
@@ -4557,11 +5334,11 @@
           <a:p>
             <a:pPr algn="l">
               <a:spcAft>
-                <a:spcPts val="400"/>
+                <a:spcPts val="300"/>
               </a:spcAft>
             </a:pPr>
             <a:r>
-              <a:rPr sz="1800" b="1" i="0">
+              <a:rPr sz="1750" b="1" i="0">
                 <a:solidFill>
                   <a:srgbClr val="F9C46B"/>
                 </a:solidFill>
@@ -4569,17 +5346,20 @@
                 <a:ea typeface="Meiryo"/>
                 <a:cs typeface="Meiryo"/>
               </a:rPr>
-              <a:t>左で選ぶ、右で混ぜる</a:t>
+              <a:t>毎秒、空の色を計算する</a:t>
             </a:r>
           </a:p>
           <a:p>
             <a:pPr algn="l">
               <a:lnSpc>
-                <a:spcPct val="125000"/>
+                <a:spcPct val="120000"/>
               </a:lnSpc>
-            </a:pPr>
-            <a:r>
-              <a:rPr sz="1450" b="0" i="0">
+              <a:spcAft>
+                <a:spcPts val="300"/>
+              </a:spcAft>
+            </a:pPr>
+            <a:r>
+              <a:rPr sz="1350" b="0" i="0">
                 <a:solidFill>
                   <a:srgbClr val="F2F4FF"/>
                 </a:solidFill>
@@ -4587,21 +5367,39 @@
                 <a:ea typeface="Meiryo"/>
                 <a:cs typeface="Meiryo"/>
               </a:rPr>
-              <a:t>混色は累積平均 — 足すほど1滴が繊細になる絵の具の感覚。理論上1,677万色のどの色にも。</a:t>
-            </a:r>
-          </a:p>
-        </p:txBody>
-      </p:sp>
-      <p:sp>
-        <p:nvSpPr>
-          <p:cNvPr id="6" name="TextBox 5"/>
+              <a:t>14のキーカラーを線形補間し、朝焼けから夕闇へ。縁のリングに1日分の色が並び、白いマーカーが「いま」を指す。</a:t>
+            </a:r>
+          </a:p>
+          <a:p>
+            <a:pPr algn="l">
+              <a:lnSpc>
+                <a:spcPct val="115000"/>
+              </a:lnSpc>
+            </a:pPr>
+            <a:r>
+              <a:rPr sz="1150" b="0" i="0">
+                <a:solidFill>
+                  <a:srgbClr val="A9B4D6"/>
+                </a:solidFill>
+                <a:latin typeface="Meiryo"/>
+                <a:ea typeface="Meiryo"/>
+                <a:cs typeface="Meiryo"/>
+              </a:rPr>
+              <a:t>14 key colors interpolated every second; the bezel ring previews the whole day.</a:t>
+            </a:r>
+          </a:p>
+        </p:txBody>
+      </p:sp>
+      <p:sp>
+        <p:nvSpPr>
+          <p:cNvPr id="7" name="TextBox 6"/>
           <p:cNvSpPr txBox="1"/>
           <p:nvPr/>
         </p:nvSpPr>
         <p:spPr>
           <a:xfrm>
-            <a:off x="822960" y="3246120"/>
-            <a:ext cx="5120640" cy="1280160"/>
+            <a:off x="6263640" y="3291840"/>
+            <a:ext cx="5120640" cy="1463040"/>
           </a:xfrm>
           <a:prstGeom prst="rect">
             <a:avLst/>
@@ -4616,11 +5414,11 @@
           <a:p>
             <a:pPr algn="l">
               <a:spcAft>
-                <a:spcPts val="400"/>
+                <a:spcPts val="300"/>
               </a:spcAft>
             </a:pPr>
             <a:r>
-              <a:rPr sz="1800" b="1" i="0">
+              <a:rPr sz="1750" b="1" i="0">
                 <a:solidFill>
                   <a:srgbClr val="F9C46B"/>
                 </a:solidFill>
@@ -4628,17 +5426,20 @@
                 <a:ea typeface="Meiryo"/>
                 <a:cs typeface="Meiryo"/>
               </a:rPr>
-              <a:t>できた色が、音になる</a:t>
+              <a:t>タイムトラベル (タッチ)</a:t>
             </a:r>
           </a:p>
           <a:p>
             <a:pPr algn="l">
               <a:lnSpc>
-                <a:spcPct val="125000"/>
+                <a:spcPct val="120000"/>
               </a:lnSpc>
-            </a:pPr>
-            <a:r>
-              <a:rPr sz="1450" b="0" i="0">
+              <a:spcAft>
+                <a:spcPts val="300"/>
+              </a:spcAft>
+            </a:pPr>
+            <a:r>
+              <a:rPr sz="1350" b="0" i="0">
                 <a:solidFill>
                   <a:srgbClr val="F2F4FF"/>
                 </a:solidFill>
@@ -4646,21 +5447,39 @@
                 <a:ea typeface="Meiryo"/>
                 <a:cs typeface="Meiryo"/>
               </a:rPr>
-              <a:t>色相をペンタトニック音階にマッピング。赤は低く、紫は高く。「好きな色の音」を探すあそび。</a:t>
-            </a:r>
-          </a:p>
-        </p:txBody>
-      </p:sp>
-      <p:sp>
-        <p:nvSpPr>
-          <p:cNvPr id="7" name="TextBox 6"/>
+              <a:t>文字盤=24時間。画面をなぞると、その角度の時刻の色へ瞬間移動。時を越えるたびに音が鳴る。</a:t>
+            </a:r>
+          </a:p>
+          <a:p>
+            <a:pPr algn="l">
+              <a:lnSpc>
+                <a:spcPct val="115000"/>
+              </a:lnSpc>
+            </a:pPr>
+            <a:r>
+              <a:rPr sz="1150" b="0" i="0">
+                <a:solidFill>
+                  <a:srgbClr val="A9B4D6"/>
+                </a:solidFill>
+                <a:latin typeface="Meiryo"/>
+                <a:ea typeface="Meiryo"/>
+                <a:cs typeface="Meiryo"/>
+              </a:rPr>
+              <a:t>Touch and drag around the dial to visit any hour's color — with a note per hour.</a:t>
+            </a:r>
+          </a:p>
+        </p:txBody>
+      </p:sp>
+      <p:sp>
+        <p:nvSpPr>
+          <p:cNvPr id="8" name="TextBox 7"/>
           <p:cNvSpPr txBox="1"/>
           <p:nvPr/>
         </p:nvSpPr>
         <p:spPr>
           <a:xfrm>
-            <a:off x="822960" y="4892040"/>
-            <a:ext cx="5120640" cy="1280160"/>
+            <a:off x="6263640" y="4937760"/>
+            <a:ext cx="5120640" cy="1463040"/>
           </a:xfrm>
           <a:prstGeom prst="rect">
             <a:avLst/>
@@ -4675,11 +5494,11 @@
           <a:p>
             <a:pPr algn="l">
               <a:spcAft>
-                <a:spcPts val="400"/>
+                <a:spcPts val="300"/>
               </a:spcAft>
             </a:pPr>
             <a:r>
-              <a:rPr sz="1800" b="1" i="0">
+              <a:rPr sz="1750" b="1" i="0">
                 <a:solidFill>
                   <a:srgbClr val="F9C46B"/>
                 </a:solidFill>
@@ -4687,17 +5506,20 @@
                 <a:ea typeface="Meiryo"/>
                 <a:cs typeface="Meiryo"/>
               </a:rPr>
-              <a:t>振れば、偶然の色</a:t>
+              <a:t>1日を48秒で再生</a:t>
             </a:r>
           </a:p>
           <a:p>
             <a:pPr algn="l">
               <a:lnSpc>
-                <a:spcPct val="125000"/>
+                <a:spcPct val="120000"/>
               </a:lnSpc>
-            </a:pPr>
-            <a:r>
-              <a:rPr sz="1450" b="0" i="0">
+              <a:spcAft>
+                <a:spcPts val="300"/>
+              </a:spcAft>
+            </a:pPr>
+            <a:r>
+              <a:rPr sz="1350" b="0" i="0">
                 <a:solidFill>
                   <a:srgbClr val="F2F4FF"/>
                 </a:solidFill>
@@ -4705,7 +5527,25 @@
                 <a:ea typeface="Meiryo"/>
                 <a:cs typeface="Meiryo"/>
               </a:rPr>
-              <a:t>本体をシェイクすると1,677万色からランダムな一色。気に入ればそこから混ぜて調整。</a:t>
+              <a:t>右長押しで24時間の色の旅をタイムラプス再生。1時間ごとにその色の音 — 1日が色とメロディになる。</a:t>
+            </a:r>
+          </a:p>
+          <a:p>
+            <a:pPr algn="l">
+              <a:lnSpc>
+                <a:spcPct val="115000"/>
+              </a:lnSpc>
+            </a:pPr>
+            <a:r>
+              <a:rPr sz="1150" b="0" i="0">
+                <a:solidFill>
+                  <a:srgbClr val="A9B4D6"/>
+                </a:solidFill>
+                <a:latin typeface="Meiryo"/>
+                <a:ea typeface="Meiryo"/>
+                <a:cs typeface="Meiryo"/>
+              </a:rPr>
+              <a:t>Long-press to replay 24 hours in 48 seconds — the day becomes color and melody.</a:t>
             </a:r>
           </a:p>
         </p:txBody>
@@ -4804,7 +5644,7 @@
                 <a:ea typeface="Meiryo"/>
                 <a:cs typeface="Meiryo"/>
               </a:rPr>
-              <a:t>③  </a:t>
+              <a:t>②  </a:t>
             </a:r>
             <a:r>
               <a:rPr sz="3000" b="1" i="0">
@@ -4815,14 +5655,51 @@
                 <a:ea typeface="Meiryo"/>
                 <a:cs typeface="Meiryo"/>
               </a:rPr>
-              <a:t>傾き絵の具 — かたむけて、にじませる</a:t>
+              <a:t>色づくり — 混ぜて、聴く</a:t>
+            </a:r>
+          </a:p>
+        </p:txBody>
+      </p:sp>
+      <p:sp>
+        <p:nvSpPr>
+          <p:cNvPr id="4" name="TextBox 3"/>
+          <p:cNvSpPr txBox="1"/>
+          <p:nvPr/>
+        </p:nvSpPr>
+        <p:spPr>
+          <a:xfrm>
+            <a:off x="822960" y="969264"/>
+            <a:ext cx="10515600" cy="365760"/>
+          </a:xfrm>
+          <a:prstGeom prst="rect">
+            <a:avLst/>
+          </a:prstGeom>
+          <a:noFill/>
+        </p:spPr>
+        <p:txBody>
+          <a:bodyPr wrap="square" anchor="t" lIns="0" rIns="0" tIns="0" bIns="0">
+            <a:spAutoFit/>
+          </a:bodyPr>
+          <a:lstStyle/>
+          <a:p>
+            <a:pPr algn="l"/>
+            <a:r>
+              <a:rPr sz="1400" b="0" i="1">
+                <a:solidFill>
+                  <a:srgbClr val="A9B4D6"/>
+                </a:solidFill>
+                <a:latin typeface="Meiryo"/>
+                <a:ea typeface="Meiryo"/>
+                <a:cs typeface="Meiryo"/>
+              </a:rPr>
+              <a:t>Color Maker — mix it, hear it</a:t>
             </a:r>
           </a:p>
         </p:txBody>
       </p:sp>
       <p:pic>
         <p:nvPicPr>
-          <p:cNvPr id="4" name="Picture 3" descr="mock_tilt.png"/>
+          <p:cNvPr id="5" name="Picture 4" descr="mock_mixer.png"/>
           <p:cNvPicPr>
             <a:picLocks noChangeAspect="1"/>
           </p:cNvPicPr>
@@ -4836,8 +5713,8 @@
         </p:blipFill>
         <p:spPr>
           <a:xfrm>
-            <a:off x="6537960" y="1417320"/>
-            <a:ext cx="4892040" cy="4892040"/>
+            <a:off x="6537960" y="1508760"/>
+            <a:ext cx="4754880" cy="4754880"/>
           </a:xfrm>
           <a:prstGeom prst="rect">
             <a:avLst/>
@@ -4846,14 +5723,14 @@
       </p:pic>
       <p:sp>
         <p:nvSpPr>
-          <p:cNvPr id="5" name="TextBox 4"/>
+          <p:cNvPr id="6" name="TextBox 5"/>
           <p:cNvSpPr txBox="1"/>
           <p:nvPr/>
         </p:nvSpPr>
         <p:spPr>
           <a:xfrm>
-            <a:off x="822960" y="1600200"/>
-            <a:ext cx="5120640" cy="1280160"/>
+            <a:off x="822960" y="1645920"/>
+            <a:ext cx="5120640" cy="1463040"/>
           </a:xfrm>
           <a:prstGeom prst="rect">
             <a:avLst/>
@@ -4868,11 +5745,11 @@
           <a:p>
             <a:pPr algn="l">
               <a:spcAft>
-                <a:spcPts val="400"/>
+                <a:spcPts val="300"/>
               </a:spcAft>
             </a:pPr>
             <a:r>
-              <a:rPr sz="1800" b="1" i="0">
+              <a:rPr sz="1750" b="1" i="0">
                 <a:solidFill>
                   <a:srgbClr val="F9C46B"/>
                 </a:solidFill>
@@ -4880,17 +5757,20 @@
                 <a:ea typeface="Meiryo"/>
                 <a:cs typeface="Meiryo"/>
               </a:rPr>
-              <a:t>傾けると、絵の具が流れる</a:t>
+              <a:t>左で選ぶ、右で混ぜる</a:t>
             </a:r>
           </a:p>
           <a:p>
             <a:pPr algn="l">
               <a:lnSpc>
-                <a:spcPct val="125000"/>
+                <a:spcPct val="120000"/>
               </a:lnSpc>
-            </a:pPr>
-            <a:r>
-              <a:rPr sz="1450" b="0" i="0">
+              <a:spcAft>
+                <a:spcPts val="300"/>
+              </a:spcAft>
+            </a:pPr>
+            <a:r>
+              <a:rPr sz="1350" b="0" i="0">
                 <a:solidFill>
                   <a:srgbClr val="F2F4FF"/>
                 </a:solidFill>
@@ -4898,21 +5778,39 @@
                 <a:ea typeface="Meiryo"/>
                 <a:cs typeface="Meiryo"/>
               </a:rPr>
-              <a:t>IMU (BMI270) が傾きを検出。傾けた側へ色が流れ込み、低い側ほど濃く積もる — 色の強い場所と弱い場所。</a:t>
-            </a:r>
-          </a:p>
-        </p:txBody>
-      </p:sp>
-      <p:sp>
-        <p:nvSpPr>
-          <p:cNvPr id="6" name="TextBox 5"/>
+              <a:t>混色は累積平均 — 足すほど1滴が繊細になる絵の具の感覚。理論上1,677万色のどの色にも。</a:t>
+            </a:r>
+          </a:p>
+          <a:p>
+            <a:pPr algn="l">
+              <a:lnSpc>
+                <a:spcPct val="115000"/>
+              </a:lnSpc>
+            </a:pPr>
+            <a:r>
+              <a:rPr sz="1150" b="0" i="0">
+                <a:solidFill>
+                  <a:srgbClr val="A9B4D6"/>
+                </a:solidFill>
+                <a:latin typeface="Meiryo"/>
+                <a:ea typeface="Meiryo"/>
+                <a:cs typeface="Meiryo"/>
+              </a:rPr>
+              <a:t>Running-average mixing feels like real paint — 16.7M colors within reach.</a:t>
+            </a:r>
+          </a:p>
+        </p:txBody>
+      </p:sp>
+      <p:sp>
+        <p:nvSpPr>
+          <p:cNvPr id="7" name="TextBox 6"/>
           <p:cNvSpPr txBox="1"/>
           <p:nvPr/>
         </p:nvSpPr>
         <p:spPr>
           <a:xfrm>
-            <a:off x="822960" y="3246120"/>
-            <a:ext cx="5120640" cy="1280160"/>
+            <a:off x="822960" y="3291840"/>
+            <a:ext cx="5120640" cy="1463040"/>
           </a:xfrm>
           <a:prstGeom prst="rect">
             <a:avLst/>
@@ -4927,11 +5825,11 @@
           <a:p>
             <a:pPr algn="l">
               <a:spcAft>
-                <a:spcPts val="400"/>
+                <a:spcPts val="300"/>
               </a:spcAft>
             </a:pPr>
             <a:r>
-              <a:rPr sz="1800" b="1" i="0">
+              <a:rPr sz="1750" b="1" i="0">
                 <a:solidFill>
                   <a:srgbClr val="F9C46B"/>
                 </a:solidFill>
@@ -4939,17 +5837,20 @@
                 <a:ea typeface="Meiryo"/>
                 <a:cs typeface="Meiryo"/>
               </a:rPr>
-              <a:t>水彩のようなにじみ</a:t>
+              <a:t>できた色が、音になる</a:t>
             </a:r>
           </a:p>
           <a:p>
             <a:pPr algn="l">
               <a:lnSpc>
-                <a:spcPct val="125000"/>
+                <a:spcPct val="120000"/>
               </a:lnSpc>
-            </a:pPr>
-            <a:r>
-              <a:rPr sz="1450" b="0" i="0">
+              <a:spcAft>
+                <a:spcPts val="300"/>
+              </a:spcAft>
+            </a:pPr>
+            <a:r>
+              <a:rPr sz="1350" b="0" i="0">
                 <a:solidFill>
                   <a:srgbClr val="F2F4FF"/>
                 </a:solidFill>
@@ -4957,21 +5858,39 @@
                 <a:ea typeface="Meiryo"/>
                 <a:cs typeface="Meiryo"/>
               </a:rPr>
-              <a:t>毎フレームの拡散処理で、隣りあう色がじわっと混ざる。左右のボタンで2つの絵の具つぼの色を選ぶ。</a:t>
-            </a:r>
-          </a:p>
-        </p:txBody>
-      </p:sp>
-      <p:sp>
-        <p:nvSpPr>
-          <p:cNvPr id="7" name="TextBox 6"/>
+              <a:t>色相をペンタトニック音階にマッピング。赤は低く、紫は高く。「好きな色の音」を探すあそび。</a:t>
+            </a:r>
+          </a:p>
+          <a:p>
+            <a:pPr algn="l">
+              <a:lnSpc>
+                <a:spcPct val="115000"/>
+              </a:lnSpc>
+            </a:pPr>
+            <a:r>
+              <a:rPr sz="1150" b="0" i="0">
+                <a:solidFill>
+                  <a:srgbClr val="A9B4D6"/>
+                </a:solidFill>
+                <a:latin typeface="Meiryo"/>
+                <a:ea typeface="Meiryo"/>
+                <a:cs typeface="Meiryo"/>
+              </a:rPr>
+              <a:t>Every mix plays its own note: hue maps to a pentatonic scale, red low, violet high.</a:t>
+            </a:r>
+          </a:p>
+        </p:txBody>
+      </p:sp>
+      <p:sp>
+        <p:nvSpPr>
+          <p:cNvPr id="8" name="TextBox 7"/>
           <p:cNvSpPr txBox="1"/>
           <p:nvPr/>
         </p:nvSpPr>
         <p:spPr>
           <a:xfrm>
-            <a:off x="822960" y="4892040"/>
-            <a:ext cx="5120640" cy="1280160"/>
+            <a:off x="822960" y="4937760"/>
+            <a:ext cx="5120640" cy="1463040"/>
           </a:xfrm>
           <a:prstGeom prst="rect">
             <a:avLst/>
@@ -4986,11 +5905,11 @@
           <a:p>
             <a:pPr algn="l">
               <a:spcAft>
-                <a:spcPts val="400"/>
+                <a:spcPts val="300"/>
               </a:spcAft>
             </a:pPr>
             <a:r>
-              <a:rPr sz="1800" b="1" i="0">
+              <a:rPr sz="1750" b="1" i="0">
                 <a:solidFill>
                   <a:srgbClr val="F9C46B"/>
                 </a:solidFill>
@@ -4998,17 +5917,20 @@
                 <a:ea typeface="Meiryo"/>
                 <a:cs typeface="Meiryo"/>
               </a:rPr>
-              <a:t>星屑のようなキラキラ音</a:t>
+              <a:t>振れば、偶然の色</a:t>
             </a:r>
           </a:p>
           <a:p>
             <a:pPr algn="l">
               <a:lnSpc>
-                <a:spcPct val="125000"/>
+                <a:spcPct val="120000"/>
               </a:lnSpc>
-            </a:pPr>
-            <a:r>
-              <a:rPr sz="1450" b="0" i="0">
+              <a:spcAft>
+                <a:spcPts val="300"/>
+              </a:spcAft>
+            </a:pPr>
+            <a:r>
+              <a:rPr sz="1350" b="0" i="0">
                 <a:solidFill>
                   <a:srgbClr val="F2F4FF"/>
                 </a:solidFill>
@@ -5016,7 +5938,25 @@
                 <a:ea typeface="Meiryo"/>
                 <a:cs typeface="Meiryo"/>
               </a:rPr>
-              <a:t>傾けている間、高音のペンタトニックがランダムにまたたく。傾きが強いほど、大きく・速く。</a:t>
+              <a:t>本体をシェイクすると1,677万色からランダムな一色。気に入ればそこから混ぜて調整。</a:t>
+            </a:r>
+          </a:p>
+          <a:p>
+            <a:pPr algn="l">
+              <a:lnSpc>
+                <a:spcPct val="115000"/>
+              </a:lnSpc>
+            </a:pPr>
+            <a:r>
+              <a:rPr sz="1150" b="0" i="0">
+                <a:solidFill>
+                  <a:srgbClr val="A9B4D6"/>
+                </a:solidFill>
+                <a:latin typeface="Meiryo"/>
+                <a:ea typeface="Meiryo"/>
+                <a:cs typeface="Meiryo"/>
+              </a:rPr>
+              <a:t>Shake the device for a random color, then refine it by mixing.</a:t>
             </a:r>
           </a:p>
         </p:txBody>
@@ -5115,7 +6055,7 @@
                 <a:ea typeface="Meiryo"/>
                 <a:cs typeface="Meiryo"/>
               </a:rPr>
-              <a:t>④  </a:t>
+              <a:t>③  </a:t>
             </a:r>
             <a:r>
               <a:rPr sz="3000" b="1" i="0">
@@ -5126,14 +6066,51 @@
                 <a:ea typeface="Meiryo"/>
                 <a:cs typeface="Meiryo"/>
               </a:rPr>
-              <a:t>声の色 — あなたの声は何色?</a:t>
+              <a:t>傾き絵の具 — かたむけて、にじませる</a:t>
+            </a:r>
+          </a:p>
+        </p:txBody>
+      </p:sp>
+      <p:sp>
+        <p:nvSpPr>
+          <p:cNvPr id="4" name="TextBox 3"/>
+          <p:cNvSpPr txBox="1"/>
+          <p:nvPr/>
+        </p:nvSpPr>
+        <p:spPr>
+          <a:xfrm>
+            <a:off x="822960" y="969264"/>
+            <a:ext cx="10515600" cy="365760"/>
+          </a:xfrm>
+          <a:prstGeom prst="rect">
+            <a:avLst/>
+          </a:prstGeom>
+          <a:noFill/>
+        </p:spPr>
+        <p:txBody>
+          <a:bodyPr wrap="square" anchor="t" lIns="0" rIns="0" tIns="0" bIns="0">
+            <a:spAutoFit/>
+          </a:bodyPr>
+          <a:lstStyle/>
+          <a:p>
+            <a:pPr algn="l"/>
+            <a:r>
+              <a:rPr sz="1400" b="0" i="1">
+                <a:solidFill>
+                  <a:srgbClr val="A9B4D6"/>
+                </a:solidFill>
+                <a:latin typeface="Meiryo"/>
+                <a:ea typeface="Meiryo"/>
+                <a:cs typeface="Meiryo"/>
+              </a:rPr>
+              <a:t>Tilt Paint — watercolor by gravity</a:t>
             </a:r>
           </a:p>
         </p:txBody>
       </p:sp>
       <p:pic>
         <p:nvPicPr>
-          <p:cNvPr id="4" name="Picture 3" descr="mock_voice.png"/>
+          <p:cNvPr id="5" name="Picture 4" descr="mock_tilt.png"/>
           <p:cNvPicPr>
             <a:picLocks noChangeAspect="1"/>
           </p:cNvPicPr>
@@ -5147,8 +6124,8 @@
         </p:blipFill>
         <p:spPr>
           <a:xfrm>
-            <a:off x="6537960" y="1417320"/>
-            <a:ext cx="4892040" cy="4892040"/>
+            <a:off x="6537960" y="1508760"/>
+            <a:ext cx="4754880" cy="4754880"/>
           </a:xfrm>
           <a:prstGeom prst="rect">
             <a:avLst/>
@@ -5157,14 +6134,14 @@
       </p:pic>
       <p:sp>
         <p:nvSpPr>
-          <p:cNvPr id="5" name="TextBox 4"/>
+          <p:cNvPr id="6" name="TextBox 5"/>
           <p:cNvSpPr txBox="1"/>
           <p:nvPr/>
         </p:nvSpPr>
         <p:spPr>
           <a:xfrm>
-            <a:off x="822960" y="1600200"/>
-            <a:ext cx="5120640" cy="1280160"/>
+            <a:off x="822960" y="1645920"/>
+            <a:ext cx="5120640" cy="1463040"/>
           </a:xfrm>
           <a:prstGeom prst="rect">
             <a:avLst/>
@@ -5179,11 +6156,11 @@
           <a:p>
             <a:pPr algn="l">
               <a:spcAft>
-                <a:spcPts val="400"/>
+                <a:spcPts val="300"/>
               </a:spcAft>
             </a:pPr>
             <a:r>
-              <a:rPr sz="1800" b="1" i="0">
+              <a:rPr sz="1750" b="1" i="0">
                 <a:solidFill>
                   <a:srgbClr val="F9C46B"/>
                 </a:solidFill>
@@ -5191,17 +6168,20 @@
                 <a:ea typeface="Meiryo"/>
                 <a:cs typeface="Meiryo"/>
               </a:rPr>
-              <a:t>話しかけると、色になる</a:t>
+              <a:t>傾けると、絵の具が流れる</a:t>
             </a:r>
           </a:p>
           <a:p>
             <a:pPr algn="l">
               <a:lnSpc>
-                <a:spcPct val="125000"/>
+                <a:spcPct val="120000"/>
               </a:lnSpc>
-            </a:pPr>
-            <a:r>
-              <a:rPr sz="1450" b="0" i="0">
+              <a:spcAft>
+                <a:spcPts val="300"/>
+              </a:spcAft>
+            </a:pPr>
+            <a:r>
+              <a:rPr sz="1350" b="0" i="0">
                 <a:solidFill>
                   <a:srgbClr val="F2F4FF"/>
                 </a:solidFill>
@@ -5209,21 +6189,39 @@
                 <a:ea typeface="Meiryo"/>
                 <a:cs typeface="Meiryo"/>
               </a:rPr>
-              <a:t>マイクが声をリアルタイムに色へ。声の高さ→色相 (低い声は赤、高い声は紫)、大きさ→明るさ。</a:t>
-            </a:r>
-          </a:p>
-        </p:txBody>
-      </p:sp>
-      <p:sp>
-        <p:nvSpPr>
-          <p:cNvPr id="6" name="TextBox 5"/>
+              <a:t>IMU (BMI270) が傾きを検出。傾けた側へ色が流れ込み、低い側ほど濃く積もる — 色の強い場所と弱い場所。</a:t>
+            </a:r>
+          </a:p>
+          <a:p>
+            <a:pPr algn="l">
+              <a:lnSpc>
+                <a:spcPct val="115000"/>
+              </a:lnSpc>
+            </a:pPr>
+            <a:r>
+              <a:rPr sz="1150" b="0" i="0">
+                <a:solidFill>
+                  <a:srgbClr val="A9B4D6"/>
+                </a:solidFill>
+                <a:latin typeface="Meiryo"/>
+                <a:ea typeface="Meiryo"/>
+                <a:cs typeface="Meiryo"/>
+              </a:rPr>
+              <a:t>The IMU pours color toward the low side — pooling dark, thinning light.</a:t>
+            </a:r>
+          </a:p>
+        </p:txBody>
+      </p:sp>
+      <p:sp>
+        <p:nvSpPr>
+          <p:cNvPr id="7" name="TextBox 6"/>
           <p:cNvSpPr txBox="1"/>
           <p:nvPr/>
         </p:nvSpPr>
         <p:spPr>
           <a:xfrm>
-            <a:off x="822960" y="3246120"/>
-            <a:ext cx="5120640" cy="1280160"/>
+            <a:off x="822960" y="3291840"/>
+            <a:ext cx="5120640" cy="1463040"/>
           </a:xfrm>
           <a:prstGeom prst="rect">
             <a:avLst/>
@@ -5238,11 +6236,11 @@
           <a:p>
             <a:pPr algn="l">
               <a:spcAft>
-                <a:spcPts val="400"/>
+                <a:spcPts val="300"/>
               </a:spcAft>
             </a:pPr>
             <a:r>
-              <a:rPr sz="1800" b="1" i="0">
+              <a:rPr sz="1750" b="1" i="0">
                 <a:solidFill>
                   <a:srgbClr val="F9C46B"/>
                 </a:solidFill>
@@ -5250,17 +6248,20 @@
                 <a:ea typeface="Meiryo"/>
                 <a:cs typeface="Meiryo"/>
               </a:rPr>
-              <a:t>声の色が、返事をする</a:t>
+              <a:t>水彩のようなにじみ</a:t>
             </a:r>
           </a:p>
           <a:p>
             <a:pPr algn="l">
               <a:lnSpc>
-                <a:spcPct val="125000"/>
+                <a:spcPct val="120000"/>
               </a:lnSpc>
-            </a:pPr>
-            <a:r>
-              <a:rPr sz="1450" b="0" i="0">
+              <a:spcAft>
+                <a:spcPts val="300"/>
+              </a:spcAft>
+            </a:pPr>
+            <a:r>
+              <a:rPr sz="1350" b="0" i="0">
                 <a:solidFill>
                   <a:srgbClr val="F2F4FF"/>
                 </a:solidFill>
@@ -5268,21 +6269,39 @@
                 <a:ea typeface="Meiryo"/>
                 <a:cs typeface="Meiryo"/>
               </a:rPr>
-              <a:t>話し終わると、デバイスが「あなたの声の色の音」を鳴らして返す。歌えば色が踊る。</a:t>
-            </a:r>
-          </a:p>
-        </p:txBody>
-      </p:sp>
-      <p:sp>
-        <p:nvSpPr>
-          <p:cNvPr id="7" name="TextBox 6"/>
+              <a:t>毎フレームの拡散処理で、隣りあう色がじわっと混ざる。左右のボタンで2つの絵の具つぼの色を選ぶ。</a:t>
+            </a:r>
+          </a:p>
+          <a:p>
+            <a:pPr algn="l">
+              <a:lnSpc>
+                <a:spcPct val="115000"/>
+              </a:lnSpc>
+            </a:pPr>
+            <a:r>
+              <a:rPr sz="1150" b="0" i="0">
+                <a:solidFill>
+                  <a:srgbClr val="A9B4D6"/>
+                </a:solidFill>
+                <a:latin typeface="Meiryo"/>
+                <a:ea typeface="Meiryo"/>
+                <a:cs typeface="Meiryo"/>
+              </a:rPr>
+              <a:t>A per-frame diffusion pass bleeds neighboring colors like wet-on-wet paper.</a:t>
+            </a:r>
+          </a:p>
+        </p:txBody>
+      </p:sp>
+      <p:sp>
+        <p:nvSpPr>
+          <p:cNvPr id="8" name="TextBox 7"/>
           <p:cNvSpPr txBox="1"/>
           <p:nvPr/>
         </p:nvSpPr>
         <p:spPr>
           <a:xfrm>
-            <a:off x="822960" y="4892040"/>
-            <a:ext cx="5120640" cy="1280160"/>
+            <a:off x="822960" y="4937760"/>
+            <a:ext cx="5120640" cy="1463040"/>
           </a:xfrm>
           <a:prstGeom prst="rect">
             <a:avLst/>
@@ -5297,11 +6316,11 @@
           <a:p>
             <a:pPr algn="l">
               <a:spcAft>
-                <a:spcPts val="400"/>
+                <a:spcPts val="300"/>
               </a:spcAft>
             </a:pPr>
             <a:r>
-              <a:rPr sz="1800" b="1" i="0">
+              <a:rPr sz="1750" b="1" i="0">
                 <a:solidFill>
                   <a:srgbClr val="F9C46B"/>
                 </a:solidFill>
@@ -5309,17 +6328,20 @@
                 <a:ea typeface="Meiryo"/>
                 <a:cs typeface="Meiryo"/>
               </a:rPr>
-              <a:t>マイクとスピーカーの自動交代</a:t>
+              <a:t>星屑のようなキラキラ音</a:t>
             </a:r>
           </a:p>
           <a:p>
             <a:pPr algn="l">
               <a:lnSpc>
-                <a:spcPct val="125000"/>
+                <a:spcPct val="120000"/>
               </a:lnSpc>
-            </a:pPr>
-            <a:r>
-              <a:rPr sz="1450" b="0" i="0">
+              <a:spcAft>
+                <a:spcPts val="300"/>
+              </a:spcAft>
+            </a:pPr>
+            <a:r>
+              <a:rPr sz="1350" b="0" i="0">
                 <a:solidFill>
                   <a:srgbClr val="F2F4FF"/>
                 </a:solidFill>
@@ -5327,7 +6349,25 @@
                 <a:ea typeface="Meiryo"/>
                 <a:cs typeface="Meiryo"/>
               </a:rPr>
-              <a:t>共有コーデック (ES8311) を、聴くとき=マイク、鳴らすとき=スピーカーへ自動で切り替え。</a:t>
+              <a:t>傾けている間、高音のペンタトニックがランダムにまたたく。傾きが強いほど、大きく・速く。</a:t>
+            </a:r>
+          </a:p>
+          <a:p>
+            <a:pPr algn="l">
+              <a:lnSpc>
+                <a:spcPct val="115000"/>
+              </a:lnSpc>
+            </a:pPr>
+            <a:r>
+              <a:rPr sz="1150" b="0" i="0">
+                <a:solidFill>
+                  <a:srgbClr val="A9B4D6"/>
+                </a:solidFill>
+                <a:latin typeface="Meiryo"/>
+                <a:ea typeface="Meiryo"/>
+                <a:cs typeface="Meiryo"/>
+              </a:rPr>
+              <a:t>Pentatonic sparkles twinkle louder and faster the harder you tilt.</a:t>
             </a:r>
           </a:p>
         </p:txBody>
@@ -5426,7 +6466,7 @@
                 <a:ea typeface="Meiryo"/>
                 <a:cs typeface="Meiryo"/>
               </a:rPr>
-              <a:t>⑤  </a:t>
+              <a:t>④  </a:t>
             </a:r>
             <a:r>
               <a:rPr sz="3000" b="1" i="0">
@@ -5437,14 +6477,51 @@
                 <a:ea typeface="Meiryo"/>
                 <a:cs typeface="Meiryo"/>
               </a:rPr>
-              <a:t>部屋の空気も、その色に — 環境光</a:t>
+              <a:t>声の色 — あなたの声は何色?</a:t>
+            </a:r>
+          </a:p>
+        </p:txBody>
+      </p:sp>
+      <p:sp>
+        <p:nvSpPr>
+          <p:cNvPr id="4" name="TextBox 3"/>
+          <p:cNvSpPr txBox="1"/>
+          <p:nvPr/>
+        </p:nvSpPr>
+        <p:spPr>
+          <a:xfrm>
+            <a:off x="822960" y="969264"/>
+            <a:ext cx="10515600" cy="365760"/>
+          </a:xfrm>
+          <a:prstGeom prst="rect">
+            <a:avLst/>
+          </a:prstGeom>
+          <a:noFill/>
+        </p:spPr>
+        <p:txBody>
+          <a:bodyPr wrap="square" anchor="t" lIns="0" rIns="0" tIns="0" bIns="0">
+            <a:spAutoFit/>
+          </a:bodyPr>
+          <a:lstStyle/>
+          <a:p>
+            <a:pPr algn="l"/>
+            <a:r>
+              <a:rPr sz="1400" b="0" i="1">
+                <a:solidFill>
+                  <a:srgbClr val="A9B4D6"/>
+                </a:solidFill>
+                <a:latin typeface="Meiryo"/>
+                <a:ea typeface="Meiryo"/>
+                <a:cs typeface="Meiryo"/>
+              </a:rPr>
+              <a:t>Voice Color — what does your voice look like?</a:t>
             </a:r>
           </a:p>
         </p:txBody>
       </p:sp>
       <p:pic>
         <p:nvPicPr>
-          <p:cNvPr id="4" name="Picture 3" descr="mock_hexled.png"/>
+          <p:cNvPr id="5" name="Picture 4" descr="mock_voice.png"/>
           <p:cNvPicPr>
             <a:picLocks noChangeAspect="1"/>
           </p:cNvPicPr>
@@ -5458,8 +6535,8 @@
         </p:blipFill>
         <p:spPr>
           <a:xfrm>
-            <a:off x="6720840" y="1417320"/>
-            <a:ext cx="4572000" cy="4572000"/>
+            <a:off x="6537960" y="1508760"/>
+            <a:ext cx="4754880" cy="4754880"/>
           </a:xfrm>
           <a:prstGeom prst="rect">
             <a:avLst/>
@@ -5468,14 +6545,14 @@
       </p:pic>
       <p:sp>
         <p:nvSpPr>
-          <p:cNvPr id="5" name="TextBox 4"/>
+          <p:cNvPr id="6" name="TextBox 5"/>
           <p:cNvSpPr txBox="1"/>
           <p:nvPr/>
         </p:nvSpPr>
         <p:spPr>
           <a:xfrm>
-            <a:off x="822960" y="1600200"/>
-            <a:ext cx="5394960" cy="1280160"/>
+            <a:off x="822960" y="1645920"/>
+            <a:ext cx="5120640" cy="1463040"/>
           </a:xfrm>
           <a:prstGeom prst="rect">
             <a:avLst/>
@@ -5490,11 +6567,11 @@
           <a:p>
             <a:pPr algn="l">
               <a:spcAft>
-                <a:spcPts val="400"/>
+                <a:spcPts val="300"/>
               </a:spcAft>
             </a:pPr>
             <a:r>
-              <a:rPr sz="1800" b="1" i="0">
+              <a:rPr sz="1750" b="1" i="0">
                 <a:solidFill>
                   <a:srgbClr val="F9C46B"/>
                 </a:solidFill>
@@ -5502,17 +6579,20 @@
                 <a:ea typeface="Meiryo"/>
                 <a:cs typeface="Meiryo"/>
               </a:rPr>
-              <a:t>Unit Hex (LED×37) と連動</a:t>
+              <a:t>話しかけると、色になる</a:t>
             </a:r>
           </a:p>
           <a:p>
             <a:pPr algn="l">
               <a:lnSpc>
-                <a:spcPct val="125000"/>
+                <a:spcPct val="120000"/>
               </a:lnSpc>
-            </a:pPr>
-            <a:r>
-              <a:rPr sz="1450" b="0" i="0">
+              <a:spcAft>
+                <a:spcPts val="300"/>
+              </a:spcAft>
+            </a:pPr>
+            <a:r>
+              <a:rPr sz="1350" b="0" i="0">
                 <a:solidFill>
                   <a:srgbClr val="F2F4FF"/>
                 </a:solidFill>
@@ -5520,21 +6600,39 @@
                 <a:ea typeface="Meiryo"/>
                 <a:cs typeface="Meiryo"/>
               </a:rPr>
-              <a:t>つなぐだけで、37個のLEDが全モードの「いまの色」と同期。空の色が部屋ににじみ出す。</a:t>
-            </a:r>
-          </a:p>
-        </p:txBody>
-      </p:sp>
-      <p:sp>
-        <p:nvSpPr>
-          <p:cNvPr id="6" name="TextBox 5"/>
+              <a:t>マイクが声をリアルタイムに色へ。声の高さ→色相 (低い声は赤、高い声は紫)、大きさ→明るさ。</a:t>
+            </a:r>
+          </a:p>
+          <a:p>
+            <a:pPr algn="l">
+              <a:lnSpc>
+                <a:spcPct val="115000"/>
+              </a:lnSpc>
+            </a:pPr>
+            <a:r>
+              <a:rPr sz="1150" b="0" i="0">
+                <a:solidFill>
+                  <a:srgbClr val="A9B4D6"/>
+                </a:solidFill>
+                <a:latin typeface="Meiryo"/>
+                <a:ea typeface="Meiryo"/>
+                <a:cs typeface="Meiryo"/>
+              </a:rPr>
+              <a:t>Pitch becomes hue, loudness becomes brightness — in real time.</a:t>
+            </a:r>
+          </a:p>
+        </p:txBody>
+      </p:sp>
+      <p:sp>
+        <p:nvSpPr>
+          <p:cNvPr id="7" name="TextBox 6"/>
           <p:cNvSpPr txBox="1"/>
           <p:nvPr/>
         </p:nvSpPr>
         <p:spPr>
           <a:xfrm>
-            <a:off x="822960" y="3246120"/>
-            <a:ext cx="5394960" cy="1280160"/>
+            <a:off x="822960" y="3291840"/>
+            <a:ext cx="5120640" cy="1463040"/>
           </a:xfrm>
           <a:prstGeom prst="rect">
             <a:avLst/>
@@ -5549,11 +6647,11 @@
           <a:p>
             <a:pPr algn="l">
               <a:spcAft>
-                <a:spcPts val="400"/>
+                <a:spcPts val="300"/>
               </a:spcAft>
             </a:pPr>
             <a:r>
-              <a:rPr sz="1800" b="1" i="0">
+              <a:rPr sz="1750" b="1" i="0">
                 <a:solidFill>
                   <a:srgbClr val="F9C46B"/>
                 </a:solidFill>
@@ -5561,17 +6659,20 @@
                 <a:ea typeface="Meiryo"/>
                 <a:cs typeface="Meiryo"/>
               </a:rPr>
-              <a:t>本体だけで細かく調整</a:t>
+              <a:t>声の色が、返事をする</a:t>
             </a:r>
           </a:p>
           <a:p>
             <a:pPr algn="l">
               <a:lnSpc>
-                <a:spcPct val="125000"/>
+                <a:spcPct val="120000"/>
               </a:lnSpc>
-            </a:pPr>
-            <a:r>
-              <a:rPr sz="1450" b="0" i="0">
+              <a:spcAft>
+                <a:spcPts val="300"/>
+              </a:spcAft>
+            </a:pPr>
+            <a:r>
+              <a:rPr sz="1350" b="0" i="0">
                 <a:solidFill>
                   <a:srgbClr val="F2F4FF"/>
                 </a:solidFill>
@@ -5579,21 +6680,39 @@
                 <a:ea typeface="Meiryo"/>
                 <a:cs typeface="Meiryo"/>
               </a:rPr>
-              <a:t>LEDのオン/オフ・明るさ (2〜100%)・音量まで、ボタンとゲージ画面で調整。設定は保存。</a:t>
-            </a:r>
-          </a:p>
-        </p:txBody>
-      </p:sp>
-      <p:sp>
-        <p:nvSpPr>
-          <p:cNvPr id="7" name="TextBox 6"/>
+              <a:t>話し終わると、デバイスが「あなたの声の色の音」を鳴らして返す。歌えば色が踊る。</a:t>
+            </a:r>
+          </a:p>
+          <a:p>
+            <a:pPr algn="l">
+              <a:lnSpc>
+                <a:spcPct val="115000"/>
+              </a:lnSpc>
+            </a:pPr>
+            <a:r>
+              <a:rPr sz="1150" b="0" i="0">
+                <a:solidFill>
+                  <a:srgbClr val="A9B4D6"/>
+                </a:solidFill>
+                <a:latin typeface="Meiryo"/>
+                <a:ea typeface="Meiryo"/>
+                <a:cs typeface="Meiryo"/>
+              </a:rPr>
+              <a:t>Stop talking, and the device answers with the sound of your color.</a:t>
+            </a:r>
+          </a:p>
+        </p:txBody>
+      </p:sp>
+      <p:sp>
+        <p:nvSpPr>
+          <p:cNvPr id="8" name="TextBox 7"/>
           <p:cNvSpPr txBox="1"/>
           <p:nvPr/>
         </p:nvSpPr>
         <p:spPr>
           <a:xfrm>
-            <a:off x="822960" y="4892040"/>
-            <a:ext cx="5394960" cy="1280160"/>
+            <a:off x="822960" y="4937760"/>
+            <a:ext cx="5120640" cy="1463040"/>
           </a:xfrm>
           <a:prstGeom prst="rect">
             <a:avLst/>
@@ -5608,11 +6727,11 @@
           <a:p>
             <a:pPr algn="l">
               <a:spcAft>
-                <a:spcPts val="400"/>
+                <a:spcPts val="300"/>
               </a:spcAft>
             </a:pPr>
             <a:r>
-              <a:rPr sz="1800" b="1" i="0">
+              <a:rPr sz="1750" b="1" i="0">
                 <a:solidFill>
                   <a:srgbClr val="F9C46B"/>
                 </a:solidFill>
@@ -5620,17 +6739,20 @@
                 <a:ea typeface="Meiryo"/>
                 <a:cs typeface="Meiryo"/>
               </a:rPr>
-              <a:t>色ランダムモード</a:t>
+              <a:t>マイクとスピーカーの自動交代</a:t>
             </a:r>
           </a:p>
           <a:p>
             <a:pPr algn="l">
               <a:lnSpc>
-                <a:spcPct val="125000"/>
+                <a:spcPct val="120000"/>
               </a:lnSpc>
-            </a:pPr>
-            <a:r>
-              <a:rPr sz="1450" b="0" i="0">
+              <a:spcAft>
+                <a:spcPts val="300"/>
+              </a:spcAft>
+            </a:pPr>
+            <a:r>
+              <a:rPr sz="1350" b="0" i="0">
                 <a:solidFill>
                   <a:srgbClr val="F2F4FF"/>
                 </a:solidFill>
@@ -5638,7 +6760,25 @@
                 <a:ea typeface="Meiryo"/>
                 <a:cs typeface="Meiryo"/>
               </a:rPr>
-              <a:t>時計を動かしたまま、背景色がランダムに漂う。LEDは37個バラバラにきらめく星空になる。</a:t>
+              <a:t>共有コーデック (ES8311) を、聴くとき=マイク、鳴らすとき=スピーカーへ自動で切り替え。</a:t>
+            </a:r>
+          </a:p>
+          <a:p>
+            <a:pPr algn="l">
+              <a:lnSpc>
+                <a:spcPct val="115000"/>
+              </a:lnSpc>
+            </a:pPr>
+            <a:r>
+              <a:rPr sz="1150" b="0" i="0">
+                <a:solidFill>
+                  <a:srgbClr val="A9B4D6"/>
+                </a:solidFill>
+                <a:latin typeface="Meiryo"/>
+                <a:ea typeface="Meiryo"/>
+                <a:cs typeface="Meiryo"/>
+              </a:rPr>
+              <a:t>The shared ES8311 codec swaps between mic and speaker automatically.</a:t>
             </a:r>
           </a:p>
         </p:txBody>
@@ -5737,7 +6877,7 @@
                 <a:ea typeface="Meiryo"/>
                 <a:cs typeface="Meiryo"/>
               </a:rPr>
-              <a:t>⑥  </a:t>
+              <a:t>⑤  </a:t>
             </a:r>
             <a:r>
               <a:rPr sz="3000" b="1" i="0">
@@ -5748,14 +6888,51 @@
                 <a:ea typeface="Meiryo"/>
                 <a:cs typeface="Meiryo"/>
               </a:rPr>
-              <a:t>ストップウォッチ &amp; 星空のサウンド</a:t>
+              <a:t>部屋の空気も、その色に — 環境光</a:t>
+            </a:r>
+          </a:p>
+        </p:txBody>
+      </p:sp>
+      <p:sp>
+        <p:nvSpPr>
+          <p:cNvPr id="4" name="TextBox 3"/>
+          <p:cNvSpPr txBox="1"/>
+          <p:nvPr/>
+        </p:nvSpPr>
+        <p:spPr>
+          <a:xfrm>
+            <a:off x="822960" y="969264"/>
+            <a:ext cx="10515600" cy="365760"/>
+          </a:xfrm>
+          <a:prstGeom prst="rect">
+            <a:avLst/>
+          </a:prstGeom>
+          <a:noFill/>
+        </p:spPr>
+        <p:txBody>
+          <a:bodyPr wrap="square" anchor="t" lIns="0" rIns="0" tIns="0" bIns="0">
+            <a:spAutoFit/>
+          </a:bodyPr>
+          <a:lstStyle/>
+          <a:p>
+            <a:pPr algn="l"/>
+            <a:r>
+              <a:rPr sz="1400" b="0" i="1">
+                <a:solidFill>
+                  <a:srgbClr val="A9B4D6"/>
+                </a:solidFill>
+                <a:latin typeface="Meiryo"/>
+                <a:ea typeface="Meiryo"/>
+                <a:cs typeface="Meiryo"/>
+              </a:rPr>
+              <a:t>Ambient Light — the room wears the color</a:t>
             </a:r>
           </a:p>
         </p:txBody>
       </p:sp>
       <p:pic>
         <p:nvPicPr>
-          <p:cNvPr id="4" name="Picture 3" descr="mock_stopwatch.png"/>
+          <p:cNvPr id="5" name="Picture 4" descr="mock_hexled.png"/>
           <p:cNvPicPr>
             <a:picLocks noChangeAspect="1"/>
           </p:cNvPicPr>
@@ -5769,8 +6946,8 @@
         </p:blipFill>
         <p:spPr>
           <a:xfrm>
-            <a:off x="777240" y="1600200"/>
-            <a:ext cx="4160520" cy="4160520"/>
+            <a:off x="6720840" y="1508760"/>
+            <a:ext cx="4480560" cy="4480560"/>
           </a:xfrm>
           <a:prstGeom prst="rect">
             <a:avLst/>
@@ -5779,60 +6956,14 @@
       </p:pic>
       <p:sp>
         <p:nvSpPr>
-          <p:cNvPr id="5" name="Rounded Rectangle 4"/>
-          <p:cNvSpPr/>
-          <p:nvPr/>
-        </p:nvSpPr>
-        <p:spPr>
-          <a:xfrm>
-            <a:off x="5440680" y="1463040"/>
-            <a:ext cx="5897880" cy="2377440"/>
-          </a:xfrm>
-          <a:prstGeom prst="roundRect">
-            <a:avLst>
-              <a:gd name="adj" fmla="val 4500"/>
-            </a:avLst>
-          </a:prstGeom>
-          <a:solidFill>
-            <a:srgbClr val="1B2248"/>
-          </a:solidFill>
-          <a:ln>
-            <a:noFill/>
-          </a:ln>
-          <a:effectLst/>
-        </p:spPr>
-        <p:style>
-          <a:lnRef idx="1">
-            <a:schemeClr val="accent1"/>
-          </a:lnRef>
-          <a:fillRef idx="3">
-            <a:schemeClr val="accent1"/>
-          </a:fillRef>
-          <a:effectRef idx="2">
-            <a:schemeClr val="accent1"/>
-          </a:effectRef>
-          <a:fontRef idx="minor">
-            <a:schemeClr val="lt1"/>
-          </a:fontRef>
-        </p:style>
-        <p:txBody>
-          <a:bodyPr rtlCol="0" anchor="ctr"/>
-          <a:lstStyle/>
-          <a:p>
-            <a:pPr algn="ctr"/>
-          </a:p>
-        </p:txBody>
-      </p:sp>
-      <p:sp>
-        <p:nvSpPr>
           <p:cNvPr id="6" name="TextBox 5"/>
           <p:cNvSpPr txBox="1"/>
           <p:nvPr/>
         </p:nvSpPr>
         <p:spPr>
           <a:xfrm>
-            <a:off x="5760720" y="1691640"/>
-            <a:ext cx="5257800" cy="2011680"/>
+            <a:off x="822960" y="1645920"/>
+            <a:ext cx="5394960" cy="1463040"/>
           </a:xfrm>
           <a:prstGeom prst="rect">
             <a:avLst/>
@@ -5847,11 +6978,11 @@
           <a:p>
             <a:pPr algn="l">
               <a:spcAft>
-                <a:spcPts val="800"/>
+                <a:spcPts val="300"/>
               </a:spcAft>
             </a:pPr>
             <a:r>
-              <a:rPr sz="1800" b="1" i="0">
+              <a:rPr sz="1750" b="1" i="0">
                 <a:solidFill>
                   <a:srgbClr val="F9C46B"/>
                 </a:solidFill>
@@ -5859,17 +6990,20 @@
                 <a:ea typeface="Meiryo"/>
                 <a:cs typeface="Meiryo"/>
               </a:rPr>
-              <a:t>星・空・地球をイメージした音</a:t>
+              <a:t>Unit Hex (LED×37) と連動</a:t>
             </a:r>
           </a:p>
           <a:p>
             <a:pPr algn="l">
+              <a:lnSpc>
+                <a:spcPct val="120000"/>
+              </a:lnSpc>
               <a:spcAft>
-                <a:spcPts val="400"/>
+                <a:spcPts val="300"/>
               </a:spcAft>
             </a:pPr>
             <a:r>
-              <a:rPr sz="1400" b="0" i="0">
+              <a:rPr sz="1350" b="0" i="0">
                 <a:solidFill>
                   <a:srgbClr val="F2F4FF"/>
                 </a:solidFill>
@@ -5877,117 +7011,39 @@
                 <a:ea typeface="Meiryo"/>
                 <a:cs typeface="Meiryo"/>
               </a:rPr>
-              <a:t>・モード切替 — 星のまたたきのような2音</a:t>
+              <a:t>つなぐだけで、37個のLEDが全モードの「いまの色」と同期。空の色が部屋ににじみ出す。</a:t>
             </a:r>
           </a:p>
           <a:p>
             <a:pPr algn="l">
-              <a:spcAft>
-                <a:spcPts val="400"/>
-              </a:spcAft>
-            </a:pPr>
-            <a:r>
-              <a:rPr sz="1400" b="0" i="0">
-                <a:solidFill>
-                  <a:srgbClr val="F2F4FF"/>
-                </a:solidFill>
-                <a:latin typeface="Meiryo"/>
-                <a:ea typeface="Meiryo"/>
-                <a:cs typeface="Meiryo"/>
-              </a:rPr>
-              <a:t>・毎正時 — 遠くの鐘のような上昇アルペジオ</a:t>
-            </a:r>
-          </a:p>
-          <a:p>
-            <a:pPr algn="l">
-              <a:spcAft>
-                <a:spcPts val="400"/>
-              </a:spcAft>
-            </a:pPr>
-            <a:r>
-              <a:rPr sz="1400" b="0" i="0">
-                <a:solidFill>
-                  <a:srgbClr val="F2F4FF"/>
-                </a:solidFill>
-                <a:latin typeface="Meiryo"/>
-                <a:ea typeface="Meiryo"/>
-                <a:cs typeface="Meiryo"/>
-              </a:rPr>
-              <a:t>・色を混ぜた瞬間 — その色自身の音</a:t>
-            </a:r>
-          </a:p>
-          <a:p>
-            <a:pPr algn="l"/>
-            <a:r>
-              <a:rPr sz="1400" b="0" i="0">
-                <a:solidFill>
-                  <a:srgbClr val="F2F4FF"/>
-                </a:solidFill>
-                <a:latin typeface="Meiryo"/>
-                <a:ea typeface="Meiryo"/>
-                <a:cs typeface="Meiryo"/>
-              </a:rPr>
-              <a:t>・消音 — 大地を思わせる低い一音。設定は本体に保存</a:t>
-            </a:r>
-          </a:p>
-        </p:txBody>
-      </p:sp>
-      <p:sp>
-        <p:nvSpPr>
-          <p:cNvPr id="7" name="Rounded Rectangle 6"/>
-          <p:cNvSpPr/>
-          <p:nvPr/>
-        </p:nvSpPr>
-        <p:spPr>
-          <a:xfrm>
-            <a:off x="5440680" y="4114800"/>
-            <a:ext cx="5897880" cy="1828800"/>
-          </a:xfrm>
-          <a:prstGeom prst="roundRect">
-            <a:avLst>
-              <a:gd name="adj" fmla="val 4500"/>
-            </a:avLst>
-          </a:prstGeom>
-          <a:solidFill>
-            <a:srgbClr val="1B2248"/>
-          </a:solidFill>
-          <a:ln>
-            <a:noFill/>
-          </a:ln>
-          <a:effectLst/>
-        </p:spPr>
-        <p:style>
-          <a:lnRef idx="1">
-            <a:schemeClr val="accent1"/>
-          </a:lnRef>
-          <a:fillRef idx="3">
-            <a:schemeClr val="accent1"/>
-          </a:fillRef>
-          <a:effectRef idx="2">
-            <a:schemeClr val="accent1"/>
-          </a:effectRef>
-          <a:fontRef idx="minor">
-            <a:schemeClr val="lt1"/>
-          </a:fontRef>
-        </p:style>
-        <p:txBody>
-          <a:bodyPr rtlCol="0" anchor="ctr"/>
-          <a:lstStyle/>
-          <a:p>
-            <a:pPr algn="ctr"/>
-          </a:p>
-        </p:txBody>
-      </p:sp>
-      <p:sp>
-        <p:nvSpPr>
-          <p:cNvPr id="8" name="TextBox 7"/>
+              <a:lnSpc>
+                <a:spcPct val="115000"/>
+              </a:lnSpc>
+            </a:pPr>
+            <a:r>
+              <a:rPr sz="1150" b="0" i="0">
+                <a:solidFill>
+                  <a:srgbClr val="A9B4D6"/>
+                </a:solidFill>
+                <a:latin typeface="Meiryo"/>
+                <a:ea typeface="Meiryo"/>
+                <a:cs typeface="Meiryo"/>
+              </a:rPr>
+              <a:t>37 NeoPixels mirror the current color of every mode — just plug it in.</a:t>
+            </a:r>
+          </a:p>
+        </p:txBody>
+      </p:sp>
+      <p:sp>
+        <p:nvSpPr>
+          <p:cNvPr id="7" name="TextBox 6"/>
           <p:cNvSpPr txBox="1"/>
           <p:nvPr/>
         </p:nvSpPr>
         <p:spPr>
           <a:xfrm>
-            <a:off x="5760720" y="4343400"/>
-            <a:ext cx="5257800" cy="1463040"/>
+            <a:off x="822960" y="3291840"/>
+            <a:ext cx="5394960" cy="1463040"/>
           </a:xfrm>
           <a:prstGeom prst="rect">
             <a:avLst/>
@@ -6002,11 +7058,11 @@
           <a:p>
             <a:pPr algn="l">
               <a:spcAft>
-                <a:spcPts val="800"/>
+                <a:spcPts val="300"/>
               </a:spcAft>
             </a:pPr>
             <a:r>
-              <a:rPr sz="1800" b="1" i="0">
+              <a:rPr sz="1750" b="1" i="0">
                 <a:solidFill>
                   <a:srgbClr val="F9C46B"/>
                 </a:solidFill>
@@ -6014,17 +7070,100 @@
                 <a:ea typeface="Meiryo"/>
                 <a:cs typeface="Meiryo"/>
               </a:rPr>
-              <a:t>1/100秒ストップウォッチ</a:t>
-            </a:r>
-          </a:p>
+              <a:t>本体だけで細かく調整</a:t>
+            </a:r>
+          </a:p>
+          <a:p>
+            <a:pPr algn="l">
+              <a:lnSpc>
+                <a:spcPct val="120000"/>
+              </a:lnSpc>
+              <a:spcAft>
+                <a:spcPts val="300"/>
+              </a:spcAft>
+            </a:pPr>
+            <a:r>
+              <a:rPr sz="1350" b="0" i="0">
+                <a:solidFill>
+                  <a:srgbClr val="F2F4FF"/>
+                </a:solidFill>
+                <a:latin typeface="Meiryo"/>
+                <a:ea typeface="Meiryo"/>
+                <a:cs typeface="Meiryo"/>
+              </a:rPr>
+              <a:t>LEDのオン/オフ・明るさ (2〜100%)・音量まで、ボタンとゲージ画面で調整。設定は保存。</a:t>
+            </a:r>
+          </a:p>
+          <a:p>
+            <a:pPr algn="l">
+              <a:lnSpc>
+                <a:spcPct val="115000"/>
+              </a:lnSpc>
+            </a:pPr>
+            <a:r>
+              <a:rPr sz="1150" b="0" i="0">
+                <a:solidFill>
+                  <a:srgbClr val="A9B4D6"/>
+                </a:solidFill>
+                <a:latin typeface="Meiryo"/>
+                <a:ea typeface="Meiryo"/>
+                <a:cs typeface="Meiryo"/>
+              </a:rPr>
+              <a:t>On-device gauge screens for LED brightness (2-100%) and volume; settings persist.</a:t>
+            </a:r>
+          </a:p>
+        </p:txBody>
+      </p:sp>
+      <p:sp>
+        <p:nvSpPr>
+          <p:cNvPr id="8" name="TextBox 7"/>
+          <p:cNvSpPr txBox="1"/>
+          <p:nvPr/>
+        </p:nvSpPr>
+        <p:spPr>
+          <a:xfrm>
+            <a:off x="822960" y="4937760"/>
+            <a:ext cx="5394960" cy="1463040"/>
+          </a:xfrm>
+          <a:prstGeom prst="rect">
+            <a:avLst/>
+          </a:prstGeom>
+          <a:noFill/>
+        </p:spPr>
+        <p:txBody>
+          <a:bodyPr wrap="square" anchor="t" lIns="0" rIns="0" tIns="0" bIns="0">
+            <a:spAutoFit/>
+          </a:bodyPr>
+          <a:lstStyle/>
           <a:p>
             <a:pPr algn="l">
               <a:spcAft>
-                <a:spcPts val="400"/>
+                <a:spcPts val="300"/>
               </a:spcAft>
             </a:pPr>
             <a:r>
-              <a:rPr sz="1400" b="0" i="0">
+              <a:rPr sz="1750" b="1" i="0">
+                <a:solidFill>
+                  <a:srgbClr val="F9C46B"/>
+                </a:solidFill>
+                <a:latin typeface="Meiryo"/>
+                <a:ea typeface="Meiryo"/>
+                <a:cs typeface="Meiryo"/>
+              </a:rPr>
+              <a:t>色ランダムモード</a:t>
+            </a:r>
+          </a:p>
+          <a:p>
+            <a:pPr algn="l">
+              <a:lnSpc>
+                <a:spcPct val="120000"/>
+              </a:lnSpc>
+              <a:spcAft>
+                <a:spcPts val="300"/>
+              </a:spcAft>
+            </a:pPr>
+            <a:r>
+              <a:rPr sz="1350" b="0" i="0">
                 <a:solidFill>
                   <a:srgbClr val="F2F4FF"/>
                 </a:solidFill>
@@ -6032,21 +7171,25 @@
                 <a:ea typeface="Meiryo"/>
                 <a:cs typeface="Meiryo"/>
               </a:rPr>
-              <a:t>・左ボタンでスタート/ストップ、右ボタンでラップ/リセット</a:t>
-            </a:r>
-          </a:p>
-          <a:p>
-            <a:pPr algn="l"/>
-            <a:r>
-              <a:rPr sz="1400" b="0" i="0">
-                <a:solidFill>
-                  <a:srgbClr val="F2F4FF"/>
-                </a:solidFill>
-                <a:latin typeface="Meiryo"/>
-                <a:ea typeface="Meiryo"/>
-                <a:cs typeface="Meiryo"/>
-              </a:rPr>
-              <a:t>・デバイス名 “StopWatch” への、まっすぐなリスペクト</a:t>
+              <a:t>時計を動かしたまま、背景色がランダムに漂う。LEDは37個バラバラにきらめく星空になる。</a:t>
+            </a:r>
+          </a:p>
+          <a:p>
+            <a:pPr algn="l">
+              <a:lnSpc>
+                <a:spcPct val="115000"/>
+              </a:lnSpc>
+            </a:pPr>
+            <a:r>
+              <a:rPr sz="1150" b="0" i="0">
+                <a:solidFill>
+                  <a:srgbClr val="A9B4D6"/>
+                </a:solidFill>
+                <a:latin typeface="Meiryo"/>
+                <a:ea typeface="Meiryo"/>
+                <a:cs typeface="Meiryo"/>
+              </a:rPr>
+              <a:t>Random mode drifts the clock's color and turns the panel into a twinkling starfield.</a:t>
             </a:r>
           </a:p>
         </p:txBody>
@@ -6139,27 +7282,99 @@
             <a:r>
               <a:rPr sz="3000" b="1" i="0">
                 <a:solidFill>
+                  <a:srgbClr val="FF6350"/>
+                </a:solidFill>
+                <a:latin typeface="Meiryo"/>
+                <a:ea typeface="Meiryo"/>
+                <a:cs typeface="Meiryo"/>
+              </a:rPr>
+              <a:t>⑥  </a:t>
+            </a:r>
+            <a:r>
+              <a:rPr sz="3000" b="1" i="0">
+                <a:solidFill>
                   <a:srgbClr val="F2F4FF"/>
                 </a:solidFill>
                 <a:latin typeface="Meiryo"/>
                 <a:ea typeface="Meiryo"/>
                 <a:cs typeface="Meiryo"/>
               </a:rPr>
-              <a:t>つくりかた — 技術構成</a:t>
-            </a:r>
-          </a:p>
-        </p:txBody>
-      </p:sp>
-      <p:sp>
-        <p:nvSpPr>
-          <p:cNvPr id="4" name="Rounded Rectangle 3"/>
+              <a:t>ストップウォッチ &amp; 星空のサウンド</a:t>
+            </a:r>
+          </a:p>
+        </p:txBody>
+      </p:sp>
+      <p:sp>
+        <p:nvSpPr>
+          <p:cNvPr id="4" name="TextBox 3"/>
+          <p:cNvSpPr txBox="1"/>
+          <p:nvPr/>
+        </p:nvSpPr>
+        <p:spPr>
+          <a:xfrm>
+            <a:off x="822960" y="969264"/>
+            <a:ext cx="10515600" cy="365760"/>
+          </a:xfrm>
+          <a:prstGeom prst="rect">
+            <a:avLst/>
+          </a:prstGeom>
+          <a:noFill/>
+        </p:spPr>
+        <p:txBody>
+          <a:bodyPr wrap="square" anchor="t" lIns="0" rIns="0" tIns="0" bIns="0">
+            <a:spAutoFit/>
+          </a:bodyPr>
+          <a:lstStyle/>
+          <a:p>
+            <a:pPr algn="l"/>
+            <a:r>
+              <a:rPr sz="1400" b="0" i="1">
+                <a:solidFill>
+                  <a:srgbClr val="A9B4D6"/>
+                </a:solidFill>
+                <a:latin typeface="Meiryo"/>
+                <a:ea typeface="Meiryo"/>
+                <a:cs typeface="Meiryo"/>
+              </a:rPr>
+              <a:t>Stopwatch &amp; the sounds of stars, sky and earth</a:t>
+            </a:r>
+          </a:p>
+        </p:txBody>
+      </p:sp>
+      <p:pic>
+        <p:nvPicPr>
+          <p:cNvPr id="5" name="Picture 4" descr="mock_stopwatch.png"/>
+          <p:cNvPicPr>
+            <a:picLocks noChangeAspect="1"/>
+          </p:cNvPicPr>
+          <p:nvPr/>
+        </p:nvPicPr>
+        <p:blipFill>
+          <a:blip r:embed="rId2"/>
+          <a:stretch>
+            <a:fillRect/>
+          </a:stretch>
+        </p:blipFill>
+        <p:spPr>
+          <a:xfrm>
+            <a:off x="777240" y="1691640"/>
+            <a:ext cx="4069080" cy="4069080"/>
+          </a:xfrm>
+          <a:prstGeom prst="rect">
+            <a:avLst/>
+          </a:prstGeom>
+        </p:spPr>
+      </p:pic>
+      <p:sp>
+        <p:nvSpPr>
+          <p:cNvPr id="6" name="Rounded Rectangle 5"/>
           <p:cNvSpPr/>
           <p:nvPr/>
         </p:nvSpPr>
         <p:spPr>
           <a:xfrm>
-            <a:off x="822960" y="1371600"/>
-            <a:ext cx="5257800" cy="4206240"/>
+            <a:off x="5440680" y="1554480"/>
+            <a:ext cx="5897880" cy="2514600"/>
           </a:xfrm>
           <a:prstGeom prst="roundRect">
             <a:avLst>
@@ -6198,14 +7413,14 @@
       </p:sp>
       <p:sp>
         <p:nvSpPr>
-          <p:cNvPr id="5" name="TextBox 4"/>
+          <p:cNvPr id="7" name="TextBox 6"/>
           <p:cNvSpPr txBox="1"/>
           <p:nvPr/>
         </p:nvSpPr>
         <p:spPr>
           <a:xfrm>
-            <a:off x="1188720" y="1645920"/>
-            <a:ext cx="4526280" cy="3657600"/>
+            <a:off x="5760720" y="1755648"/>
+            <a:ext cx="5257800" cy="2194560"/>
           </a:xfrm>
           <a:prstGeom prst="rect">
             <a:avLst/>
@@ -6220,11 +7435,11 @@
           <a:p>
             <a:pPr algn="l">
               <a:spcAft>
-                <a:spcPts val="1000"/>
+                <a:spcPts val="200"/>
               </a:spcAft>
             </a:pPr>
             <a:r>
-              <a:rPr sz="1900" b="1" i="0">
+              <a:rPr sz="1800" b="1" i="0">
                 <a:solidFill>
                   <a:srgbClr val="F9C46B"/>
                 </a:solidFill>
@@ -6232,20 +7447,35 @@
                 <a:ea typeface="Meiryo"/>
                 <a:cs typeface="Meiryo"/>
               </a:rPr>
-              <a:t>ハードウェア</a:t>
+              <a:t>星・空・地球をイメージした音</a:t>
             </a:r>
           </a:p>
           <a:p>
             <a:pPr algn="l">
-              <a:lnSpc>
-                <a:spcPct val="115000"/>
-              </a:lnSpc>
               <a:spcAft>
-                <a:spcPts val="600"/>
+                <a:spcPts val="700"/>
               </a:spcAft>
             </a:pPr>
             <a:r>
-              <a:rPr sz="1400" b="0" i="0">
+              <a:rPr sz="1150" b="0" i="1">
+                <a:solidFill>
+                  <a:srgbClr val="A9B4D6"/>
+                </a:solidFill>
+                <a:latin typeface="Meiryo"/>
+                <a:ea typeface="Meiryo"/>
+                <a:cs typeface="Meiryo"/>
+              </a:rPr>
+              <a:t>Every sound is celestial-themed</a:t>
+            </a:r>
+          </a:p>
+          <a:p>
+            <a:pPr algn="l">
+              <a:spcAft>
+                <a:spcPts val="400"/>
+              </a:spcAft>
+            </a:pPr>
+            <a:r>
+              <a:rPr sz="1350" b="0" i="0">
                 <a:solidFill>
                   <a:srgbClr val="F2F4FF"/>
                 </a:solidFill>
@@ -6253,20 +7483,17 @@
                 <a:ea typeface="Meiryo"/>
                 <a:cs typeface="Meiryo"/>
               </a:rPr>
-              <a:t>・M5Stack StopWatch (ESP32-S3R8, 240MHz)</a:t>
+              <a:t>・モード切替 — 星のまたたきのような2音 / star-twinkle</a:t>
             </a:r>
           </a:p>
           <a:p>
             <a:pPr algn="l">
-              <a:lnSpc>
-                <a:spcPct val="115000"/>
-              </a:lnSpc>
               <a:spcAft>
-                <a:spcPts val="600"/>
+                <a:spcPts val="400"/>
               </a:spcAft>
             </a:pPr>
             <a:r>
-              <a:rPr sz="1400" b="0" i="0">
+              <a:rPr sz="1350" b="0" i="0">
                 <a:solidFill>
                   <a:srgbClr val="F2F4FF"/>
                 </a:solidFill>
@@ -6274,20 +7501,17 @@
                 <a:ea typeface="Meiryo"/>
                 <a:cs typeface="Meiryo"/>
               </a:rPr>
-              <a:t>・1.75インチ 円形AMOLEDタッチ 466×466</a:t>
+              <a:t>・毎正時 — 遠くの鐘のような上昇アルペジオ / hourly bell</a:t>
             </a:r>
           </a:p>
           <a:p>
             <a:pPr algn="l">
-              <a:lnSpc>
-                <a:spcPct val="115000"/>
-              </a:lnSpc>
               <a:spcAft>
-                <a:spcPts val="600"/>
+                <a:spcPts val="400"/>
               </a:spcAft>
             </a:pPr>
             <a:r>
-              <a:rPr sz="1400" b="0" i="0">
+              <a:rPr sz="1350" b="0" i="0">
                 <a:solidFill>
                   <a:srgbClr val="F2F4FF"/>
                 </a:solidFill>
@@ -6295,20 +7519,13 @@
                 <a:ea typeface="Meiryo"/>
                 <a:cs typeface="Meiryo"/>
               </a:rPr>
-              <a:t>・IMU BMI270 — 傾き検出・シェイク検出</a:t>
-            </a:r>
-          </a:p>
-          <a:p>
-            <a:pPr algn="l">
-              <a:lnSpc>
-                <a:spcPct val="115000"/>
-              </a:lnSpc>
-              <a:spcAft>
-                <a:spcPts val="600"/>
-              </a:spcAft>
-            </a:pPr>
-            <a:r>
-              <a:rPr sz="1400" b="0" i="0">
+              <a:t>・色を混ぜた瞬間 — その色自身の音 / the color's own note</a:t>
+            </a:r>
+          </a:p>
+          <a:p>
+            <a:pPr algn="l"/>
+            <a:r>
+              <a:rPr sz="1350" b="0" i="0">
                 <a:solidFill>
                   <a:srgbClr val="F2F4FF"/>
                 </a:solidFill>
@@ -6316,63 +7533,21 @@
                 <a:ea typeface="Meiryo"/>
                 <a:cs typeface="Meiryo"/>
               </a:rPr>
-              <a:t>・ES8311 コーデック + 1Wスピーカー + マイク</a:t>
-            </a:r>
-          </a:p>
-          <a:p>
-            <a:pPr algn="l">
-              <a:lnSpc>
-                <a:spcPct val="115000"/>
-              </a:lnSpc>
-              <a:spcAft>
-                <a:spcPts val="600"/>
-              </a:spcAft>
-            </a:pPr>
-            <a:r>
-              <a:rPr sz="1400" b="0" i="0">
-                <a:solidFill>
-                  <a:srgbClr val="F2F4FF"/>
-                </a:solidFill>
-                <a:latin typeface="Meiryo"/>
-                <a:ea typeface="Meiryo"/>
-                <a:cs typeface="Meiryo"/>
-              </a:rPr>
-              <a:t>・RTC RX8130CE + Wi-Fi (時刻はNTPで自動同期)</a:t>
-            </a:r>
-          </a:p>
-          <a:p>
-            <a:pPr algn="l">
-              <a:lnSpc>
-                <a:spcPct val="115000"/>
-              </a:lnSpc>
-              <a:spcAft>
-                <a:spcPts val="600"/>
-              </a:spcAft>
-            </a:pPr>
-            <a:r>
-              <a:rPr sz="1400" b="0" i="0">
-                <a:solidFill>
-                  <a:srgbClr val="F2F4FF"/>
-                </a:solidFill>
-                <a:latin typeface="Meiryo"/>
-                <a:ea typeface="Meiryo"/>
-                <a:cs typeface="Meiryo"/>
-              </a:rPr>
-              <a:t>・Unit Hex (SK6812×37) をPortAに接続可</a:t>
-            </a:r>
-          </a:p>
-        </p:txBody>
-      </p:sp>
-      <p:sp>
-        <p:nvSpPr>
-          <p:cNvPr id="6" name="Rounded Rectangle 5"/>
+              <a:t>・消音 — 大地を思わせる低い一音 / a low "earth" tone</a:t>
+            </a:r>
+          </a:p>
+        </p:txBody>
+      </p:sp>
+      <p:sp>
+        <p:nvSpPr>
+          <p:cNvPr id="8" name="Rounded Rectangle 7"/>
           <p:cNvSpPr/>
           <p:nvPr/>
         </p:nvSpPr>
         <p:spPr>
           <a:xfrm>
-            <a:off x="6172200" y="1371600"/>
-            <a:ext cx="5257800" cy="4206240"/>
+            <a:off x="5440680" y="4251960"/>
+            <a:ext cx="5897880" cy="1783080"/>
           </a:xfrm>
           <a:prstGeom prst="roundRect">
             <a:avLst>
@@ -6411,14 +7586,14 @@
       </p:sp>
       <p:sp>
         <p:nvSpPr>
-          <p:cNvPr id="7" name="TextBox 6"/>
+          <p:cNvPr id="9" name="TextBox 8"/>
           <p:cNvSpPr txBox="1"/>
           <p:nvPr/>
         </p:nvSpPr>
         <p:spPr>
           <a:xfrm>
-            <a:off x="6537960" y="1645920"/>
-            <a:ext cx="4526280" cy="3657600"/>
+            <a:off x="5760720" y="4453128"/>
+            <a:ext cx="5257800" cy="1463040"/>
           </a:xfrm>
           <a:prstGeom prst="rect">
             <a:avLst/>
@@ -6433,11 +7608,11 @@
           <a:p>
             <a:pPr algn="l">
               <a:spcAft>
-                <a:spcPts val="1000"/>
+                <a:spcPts val="200"/>
               </a:spcAft>
             </a:pPr>
             <a:r>
-              <a:rPr sz="1900" b="1" i="0">
+              <a:rPr sz="1800" b="1" i="0">
                 <a:solidFill>
                   <a:srgbClr val="F9C46B"/>
                 </a:solidFill>
@@ -6445,20 +7620,35 @@
                 <a:ea typeface="Meiryo"/>
                 <a:cs typeface="Meiryo"/>
               </a:rPr>
-              <a:t>ソフトウェア</a:t>
+              <a:t>1/100秒ストップウォッチ</a:t>
             </a:r>
           </a:p>
           <a:p>
             <a:pPr algn="l">
-              <a:lnSpc>
-                <a:spcPct val="115000"/>
-              </a:lnSpc>
               <a:spcAft>
-                <a:spcPts val="600"/>
+                <a:spcPts val="700"/>
               </a:spcAft>
             </a:pPr>
             <a:r>
-              <a:rPr sz="1400" b="0" i="0">
+              <a:rPr sz="1150" b="0" i="1">
+                <a:solidFill>
+                  <a:srgbClr val="A9B4D6"/>
+                </a:solidFill>
+                <a:latin typeface="Meiryo"/>
+                <a:ea typeface="Meiryo"/>
+                <a:cs typeface="Meiryo"/>
+              </a:rPr>
+              <a:t>A lap-capable 1/100s stopwatch, true to the device's name</a:t>
+            </a:r>
+          </a:p>
+          <a:p>
+            <a:pPr algn="l">
+              <a:spcAft>
+                <a:spcPts val="400"/>
+              </a:spcAft>
+            </a:pPr>
+            <a:r>
+              <a:rPr sz="1350" b="0" i="0">
                 <a:solidFill>
                   <a:srgbClr val="F2F4FF"/>
                 </a:solidFill>
@@ -6466,20 +7656,13 @@
                 <a:ea typeface="Meiryo"/>
                 <a:cs typeface="Meiryo"/>
               </a:rPr>
-              <a:t>・PlatformIO + Arduino + M5Unified / FastLED</a:t>
-            </a:r>
-          </a:p>
-          <a:p>
-            <a:pPr algn="l">
-              <a:lnSpc>
-                <a:spcPct val="115000"/>
-              </a:lnSpc>
-              <a:spcAft>
-                <a:spcPts val="600"/>
-              </a:spcAft>
-            </a:pPr>
-            <a:r>
-              <a:rPr sz="1400" b="0" i="0">
+              <a:t>・左ボタンでスタート/ストップ、右ボタンでラップ/リセット</a:t>
+            </a:r>
+          </a:p>
+          <a:p>
+            <a:pPr algn="l"/>
+            <a:r>
+              <a:rPr sz="1350" b="0" i="0">
                 <a:solidFill>
                   <a:srgbClr val="F2F4FF"/>
                 </a:solidFill>
@@ -6487,128 +7670,7 @@
                 <a:ea typeface="Meiryo"/>
                 <a:cs typeface="Meiryo"/>
               </a:rPr>
-              <a:t>・カラーエンジン: 14キーフレームの線形補間</a:t>
-            </a:r>
-          </a:p>
-          <a:p>
-            <a:pPr algn="l">
-              <a:lnSpc>
-                <a:spcPct val="115000"/>
-              </a:lnSpc>
-              <a:spcAft>
-                <a:spcPts val="600"/>
-              </a:spcAft>
-            </a:pPr>
-            <a:r>
-              <a:rPr sz="1400" b="0" i="0">
-                <a:solidFill>
-                  <a:srgbClr val="F2F4FF"/>
-                </a:solidFill>
-                <a:latin typeface="Meiryo"/>
-                <a:ea typeface="Meiryo"/>
-                <a:cs typeface="Meiryo"/>
-              </a:rPr>
-              <a:t>・混色: 累積平均 / 水彩: 58×58格子の拡散 (15fps)</a:t>
-            </a:r>
-          </a:p>
-          <a:p>
-            <a:pPr algn="l">
-              <a:lnSpc>
-                <a:spcPct val="115000"/>
-              </a:lnSpc>
-              <a:spcAft>
-                <a:spcPts val="600"/>
-              </a:spcAft>
-            </a:pPr>
-            <a:r>
-              <a:rPr sz="1400" b="0" i="0">
-                <a:solidFill>
-                  <a:srgbClr val="F2F4FF"/>
-                </a:solidFill>
-                <a:latin typeface="Meiryo"/>
-                <a:ea typeface="Meiryo"/>
-                <a:cs typeface="Meiryo"/>
-              </a:rPr>
-              <a:t>・色→音: 色相→ペンタトニック2オクターブ</a:t>
-            </a:r>
-          </a:p>
-          <a:p>
-            <a:pPr algn="l">
-              <a:lnSpc>
-                <a:spcPct val="115000"/>
-              </a:lnSpc>
-              <a:spcAft>
-                <a:spcPts val="600"/>
-              </a:spcAft>
-            </a:pPr>
-            <a:r>
-              <a:rPr sz="1400" b="0" i="0">
-                <a:solidFill>
-                  <a:srgbClr val="F2F4FF"/>
-                </a:solidFill>
-                <a:latin typeface="Meiryo"/>
-                <a:ea typeface="Meiryo"/>
-                <a:cs typeface="Meiryo"/>
-              </a:rPr>
-              <a:t>・声→色: RMS (大きさ) + ゼロ交差率 (高さ)</a:t>
-            </a:r>
-          </a:p>
-          <a:p>
-            <a:pPr algn="l">
-              <a:lnSpc>
-                <a:spcPct val="115000"/>
-              </a:lnSpc>
-              <a:spcAft>
-                <a:spcPts val="600"/>
-              </a:spcAft>
-            </a:pPr>
-            <a:r>
-              <a:rPr sz="1400" b="0" i="0">
-                <a:solidFill>
-                  <a:srgbClr val="F2F4FF"/>
-                </a:solidFill>
-                <a:latin typeface="Meiryo"/>
-                <a:ea typeface="Meiryo"/>
-                <a:cs typeface="Meiryo"/>
-              </a:rPr>
-              <a:t>・Wi-Fi設定はスマホから / 設定はNVSへ永続化</a:t>
-            </a:r>
-          </a:p>
-        </p:txBody>
-      </p:sp>
-      <p:sp>
-        <p:nvSpPr>
-          <p:cNvPr id="8" name="TextBox 7"/>
-          <p:cNvSpPr txBox="1"/>
-          <p:nvPr/>
-        </p:nvSpPr>
-        <p:spPr>
-          <a:xfrm>
-            <a:off x="822960" y="5897880"/>
-            <a:ext cx="10607040" cy="457200"/>
-          </a:xfrm>
-          <a:prstGeom prst="rect">
-            <a:avLst/>
-          </a:prstGeom>
-          <a:noFill/>
-        </p:spPr>
-        <p:txBody>
-          <a:bodyPr wrap="square" anchor="t" lIns="0" rIns="0" tIns="0" bIns="0">
-            <a:spAutoFit/>
-          </a:bodyPr>
-          <a:lstStyle/>
-          <a:p>
-            <a:pPr algn="ctr"/>
-            <a:r>
-              <a:rPr sz="1400" b="0" i="0">
-                <a:solidFill>
-                  <a:srgbClr val="A9B4D6"/>
-                </a:solidFill>
-                <a:latin typeface="Meiryo"/>
-                <a:ea typeface="Meiryo"/>
-                <a:cs typeface="Meiryo"/>
-              </a:rPr>
-              <a:t>ソースコードは github.com/aokko2000/iroirotokei で全公開</a:t>
+              <a:t>・デバイス名 “StopWatch” への、まっすぐなリスペクト</a:t>
             </a:r>
           </a:p>
         </p:txBody>

</xml_diff>

<commit_message>
Fix demo slide wording and update clock mockup to current firmware UI
</commit_message>
<xml_diff>
--- a/docs/iroirotokei_contest_slides.pptx
+++ b/docs/iroirotokei_contest_slides.pptx
@@ -4860,7 +4860,7 @@
                 <a:ea typeface="Meiryo"/>
                 <a:cs typeface="Meiryo"/>
               </a:rPr>
-              <a:t>ぜんぶ、動いています — 実機デモ</a:t>
+              <a:t>実機デモ — すべて実際の動作画面</a:t>
             </a:r>
           </a:p>
         </p:txBody>
@@ -4897,7 +4897,7 @@
                 <a:ea typeface="Meiryo"/>
                 <a:cs typeface="Meiryo"/>
               </a:rPr>
-              <a:t>All of it, running — live demo</a:t>
+              <a:t>Live demo — every feature running on the real device</a:t>
             </a:r>
           </a:p>
         </p:txBody>

</xml_diff>

<commit_message>
Slides: add name wordplay (iro x iroiro) to title, add Moon Clock slide (12 slides)
</commit_message>
<xml_diff>
--- a/docs/iroirotokei_contest_slides.pptx
+++ b/docs/iroirotokei_contest_slides.pptx
@@ -16,6 +16,7 @@
     <p:sldId id="264" r:id="rId15"/>
     <p:sldId id="265" r:id="rId16"/>
     <p:sldId id="266" r:id="rId17"/>
+    <p:sldId id="267" r:id="rId18"/>
   </p:sldIdLst>
   <p:sldSz cx="12191695" cy="6858000" type="screen4x3"/>
   <p:notesSz cx="6858000" cy="9144000"/>
@@ -3154,8 +3155,8 @@
         </p:nvSpPr>
         <p:spPr>
           <a:xfrm>
-            <a:off x="868680" y="1874519"/>
-            <a:ext cx="6583680" cy="3291840"/>
+            <a:off x="868680" y="1691640"/>
+            <a:ext cx="6583680" cy="3840480"/>
           </a:xfrm>
           <a:prstGeom prst="rect">
             <a:avLst/>
@@ -3188,7 +3189,7 @@
           <a:p>
             <a:pPr algn="l">
               <a:spcAft>
-                <a:spcPts val="2000"/>
+                <a:spcPts val="2200"/>
               </a:spcAft>
             </a:pPr>
             <a:r>
@@ -3201,6 +3202,75 @@
                 <a:cs typeface="Meiryo"/>
               </a:rPr>
               <a:t>iroirotokei — A Color Clock That Paints Time</a:t>
+            </a:r>
+          </a:p>
+          <a:p>
+            <a:pPr algn="l">
+              <a:spcAft>
+                <a:spcPts val="600"/>
+              </a:spcAft>
+            </a:pPr>
+            <a:r>
+              <a:rPr sz="2400" b="1" i="0">
+                <a:solidFill>
+                  <a:srgbClr val="FF6350"/>
+                </a:solidFill>
+                <a:latin typeface="Meiryo"/>
+                <a:ea typeface="Meiryo"/>
+                <a:cs typeface="Meiryo"/>
+              </a:rPr>
+              <a:t>色</a:t>
+            </a:r>
+            <a:r>
+              <a:rPr sz="2000" b="0" i="0">
+                <a:solidFill>
+                  <a:srgbClr val="F2F4FF"/>
+                </a:solidFill>
+                <a:latin typeface="Meiryo"/>
+                <a:ea typeface="Meiryo"/>
+                <a:cs typeface="Meiryo"/>
+              </a:rPr>
+              <a:t> をかんじる。</a:t>
+            </a:r>
+            <a:r>
+              <a:rPr sz="2400" b="1" i="0">
+                <a:solidFill>
+                  <a:srgbClr val="F9C46B"/>
+                </a:solidFill>
+                <a:latin typeface="Meiryo"/>
+                <a:ea typeface="Meiryo"/>
+                <a:cs typeface="Meiryo"/>
+              </a:rPr>
+              <a:t>色々</a:t>
+            </a:r>
+            <a:r>
+              <a:rPr sz="2000" b="0" i="0">
+                <a:solidFill>
+                  <a:srgbClr val="F2F4FF"/>
+                </a:solidFill>
+                <a:latin typeface="Meiryo"/>
+                <a:ea typeface="Meiryo"/>
+                <a:cs typeface="Meiryo"/>
+              </a:rPr>
+              <a:t> できる。</a:t>
+            </a:r>
+          </a:p>
+          <a:p>
+            <a:pPr algn="l">
+              <a:spcAft>
+                <a:spcPts val="1600"/>
+              </a:spcAft>
+            </a:pPr>
+            <a:r>
+              <a:rPr sz="1300" b="0" i="0">
+                <a:solidFill>
+                  <a:srgbClr val="A9B4D6"/>
+                </a:solidFill>
+                <a:latin typeface="Meiryo"/>
+                <a:ea typeface="Meiryo"/>
+                <a:cs typeface="Meiryo"/>
+              </a:rPr>
+              <a:t>— 名前は「いろ」と「いろいろ」のかけことば。</a:t>
             </a:r>
           </a:p>
           <a:p>
@@ -3213,7 +3283,7 @@
               </a:spcAft>
             </a:pPr>
             <a:r>
-              <a:rPr sz="1700" b="0" i="0">
+              <a:rPr sz="1600" b="0" i="0">
                 <a:solidFill>
                   <a:srgbClr val="F2F4FF"/>
                 </a:solidFill>
@@ -3230,11 +3300,11 @@
                 <a:spcPct val="130000"/>
               </a:lnSpc>
               <a:spcAft>
-                <a:spcPts val="200"/>
+                <a:spcPts val="1200"/>
               </a:spcAft>
             </a:pPr>
             <a:r>
-              <a:rPr sz="1700" b="0" i="0">
+              <a:rPr sz="1600" b="0" i="0">
                 <a:solidFill>
                   <a:srgbClr val="F2F4FF"/>
                 </a:solidFill>
@@ -3242,28 +3312,7 @@
                 <a:ea typeface="Meiryo"/>
                 <a:cs typeface="Meiryo"/>
               </a:rPr>
-              <a:t>1,677万色から自分の色を混ぜて、その色を音で聴く。</a:t>
-            </a:r>
-          </a:p>
-          <a:p>
-            <a:pPr algn="l">
-              <a:lnSpc>
-                <a:spcPct val="130000"/>
-              </a:lnSpc>
-              <a:spcAft>
-                <a:spcPts val="1400"/>
-              </a:spcAft>
-            </a:pPr>
-            <a:r>
-              <a:rPr sz="1700" b="0" i="0">
-                <a:solidFill>
-                  <a:srgbClr val="F2F4FF"/>
-                </a:solidFill>
-                <a:latin typeface="Meiryo"/>
-                <a:ea typeface="Meiryo"/>
-                <a:cs typeface="Meiryo"/>
-              </a:rPr>
-              <a:t>かたむければ水彩のように混ざり、声さえも色になる。</a:t>
+              <a:t>混ぜて、聴いて、傾けて、話しかけて — 夜は月まで見上げられる。</a:t>
             </a:r>
           </a:p>
           <a:p>
@@ -3273,7 +3322,7 @@
               </a:lnSpc>
             </a:pPr>
             <a:r>
-              <a:rPr sz="1300" b="0" i="0">
+              <a:rPr sz="1250" b="0" i="0">
                 <a:solidFill>
                   <a:srgbClr val="A9B4D6"/>
                 </a:solidFill>
@@ -3281,7 +3330,7 @@
                 <a:ea typeface="Meiryo"/>
                 <a:cs typeface="Meiryo"/>
               </a:rPr>
-              <a:t>A clock that drifts through the sky's colors over 24 hours — mix colors, hear them as notes, paint by tilting, and even your voice becomes color.</a:t>
+              <a:t>"iro" means color, "iroiro" means all sorts of things — a color clock that feels color, and does a little of everything.</a:t>
             </a:r>
           </a:p>
         </p:txBody>
@@ -3411,13 +3460,24 @@
             <a:r>
               <a:rPr sz="3000" b="1" i="0">
                 <a:solidFill>
+                  <a:srgbClr val="FF6350"/>
+                </a:solidFill>
+                <a:latin typeface="Meiryo"/>
+                <a:ea typeface="Meiryo"/>
+                <a:cs typeface="Meiryo"/>
+              </a:rPr>
+              <a:t>⑦  </a:t>
+            </a:r>
+            <a:r>
+              <a:rPr sz="3000" b="1" i="0">
+                <a:solidFill>
                   <a:srgbClr val="F2F4FF"/>
                 </a:solidFill>
                 <a:latin typeface="Meiryo"/>
                 <a:ea typeface="Meiryo"/>
                 <a:cs typeface="Meiryo"/>
               </a:rPr>
-              <a:t>つくりかた — 技術構成</a:t>
+              <a:t>ストップウォッチ &amp; 星空のサウンド</a:t>
             </a:r>
           </a:p>
         </p:txBody>
@@ -3454,21 +3514,45 @@
                 <a:ea typeface="Meiryo"/>
                 <a:cs typeface="Meiryo"/>
               </a:rPr>
-              <a:t>How it works — hardware &amp; software</a:t>
-            </a:r>
-          </a:p>
-        </p:txBody>
-      </p:sp>
-      <p:sp>
-        <p:nvSpPr>
-          <p:cNvPr id="5" name="Rounded Rectangle 4"/>
+              <a:t>Stopwatch &amp; the sounds of stars, sky and earth</a:t>
+            </a:r>
+          </a:p>
+        </p:txBody>
+      </p:sp>
+      <p:pic>
+        <p:nvPicPr>
+          <p:cNvPr id="5" name="Picture 4" descr="mock_stopwatch.png"/>
+          <p:cNvPicPr>
+            <a:picLocks noChangeAspect="1"/>
+          </p:cNvPicPr>
+          <p:nvPr/>
+        </p:nvPicPr>
+        <p:blipFill>
+          <a:blip r:embed="rId2"/>
+          <a:stretch>
+            <a:fillRect/>
+          </a:stretch>
+        </p:blipFill>
+        <p:spPr>
+          <a:xfrm>
+            <a:off x="777240" y="1691640"/>
+            <a:ext cx="4069080" cy="4069080"/>
+          </a:xfrm>
+          <a:prstGeom prst="rect">
+            <a:avLst/>
+          </a:prstGeom>
+        </p:spPr>
+      </p:pic>
+      <p:sp>
+        <p:nvSpPr>
+          <p:cNvPr id="6" name="Rounded Rectangle 5"/>
           <p:cNvSpPr/>
           <p:nvPr/>
         </p:nvSpPr>
         <p:spPr>
           <a:xfrm>
-            <a:off x="822960" y="1371600"/>
-            <a:ext cx="5257800" cy="4206240"/>
+            <a:off x="5440680" y="1554480"/>
+            <a:ext cx="5897880" cy="2514600"/>
           </a:xfrm>
           <a:prstGeom prst="roundRect">
             <a:avLst>
@@ -3507,14 +3591,14 @@
       </p:sp>
       <p:sp>
         <p:nvSpPr>
-          <p:cNvPr id="6" name="TextBox 5"/>
+          <p:cNvPr id="7" name="TextBox 6"/>
           <p:cNvSpPr txBox="1"/>
           <p:nvPr/>
         </p:nvSpPr>
         <p:spPr>
           <a:xfrm>
-            <a:off x="1188720" y="1645920"/>
-            <a:ext cx="4526280" cy="3657600"/>
+            <a:off x="5760720" y="1755648"/>
+            <a:ext cx="5257800" cy="2194560"/>
           </a:xfrm>
           <a:prstGeom prst="rect">
             <a:avLst/>
@@ -3529,11 +3613,11 @@
           <a:p>
             <a:pPr algn="l">
               <a:spcAft>
-                <a:spcPts val="1000"/>
+                <a:spcPts val="200"/>
               </a:spcAft>
             </a:pPr>
             <a:r>
-              <a:rPr sz="1900" b="1" i="0">
+              <a:rPr sz="1800" b="1" i="0">
                 <a:solidFill>
                   <a:srgbClr val="F9C46B"/>
                 </a:solidFill>
@@ -3541,20 +3625,35 @@
                 <a:ea typeface="Meiryo"/>
                 <a:cs typeface="Meiryo"/>
               </a:rPr>
-              <a:t>ハードウェア / Hardware</a:t>
+              <a:t>星・空・地球をイメージした音</a:t>
             </a:r>
           </a:p>
           <a:p>
             <a:pPr algn="l">
-              <a:lnSpc>
-                <a:spcPct val="115000"/>
-              </a:lnSpc>
               <a:spcAft>
-                <a:spcPts val="600"/>
+                <a:spcPts val="700"/>
               </a:spcAft>
             </a:pPr>
             <a:r>
-              <a:rPr sz="1400" b="0" i="0">
+              <a:rPr sz="1150" b="0" i="1">
+                <a:solidFill>
+                  <a:srgbClr val="A9B4D6"/>
+                </a:solidFill>
+                <a:latin typeface="Meiryo"/>
+                <a:ea typeface="Meiryo"/>
+                <a:cs typeface="Meiryo"/>
+              </a:rPr>
+              <a:t>Every sound is celestial-themed</a:t>
+            </a:r>
+          </a:p>
+          <a:p>
+            <a:pPr algn="l">
+              <a:spcAft>
+                <a:spcPts val="400"/>
+              </a:spcAft>
+            </a:pPr>
+            <a:r>
+              <a:rPr sz="1350" b="0" i="0">
                 <a:solidFill>
                   <a:srgbClr val="F2F4FF"/>
                 </a:solidFill>
@@ -3562,20 +3661,17 @@
                 <a:ea typeface="Meiryo"/>
                 <a:cs typeface="Meiryo"/>
               </a:rPr>
-              <a:t>・M5Stack StopWatch (ESP32-S3R8, 240MHz)</a:t>
+              <a:t>・モード切替 — 星のまたたきのような2音 / star-twinkle</a:t>
             </a:r>
           </a:p>
           <a:p>
             <a:pPr algn="l">
-              <a:lnSpc>
-                <a:spcPct val="115000"/>
-              </a:lnSpc>
               <a:spcAft>
-                <a:spcPts val="600"/>
+                <a:spcPts val="400"/>
               </a:spcAft>
             </a:pPr>
             <a:r>
-              <a:rPr sz="1400" b="0" i="0">
+              <a:rPr sz="1350" b="0" i="0">
                 <a:solidFill>
                   <a:srgbClr val="F2F4FF"/>
                 </a:solidFill>
@@ -3583,20 +3679,17 @@
                 <a:ea typeface="Meiryo"/>
                 <a:cs typeface="Meiryo"/>
               </a:rPr>
-              <a:t>・1.75インチ 円形AMOLEDタッチ 466×466</a:t>
+              <a:t>・毎正時 — 遠くの鐘のような上昇アルペジオ / hourly bell</a:t>
             </a:r>
           </a:p>
           <a:p>
             <a:pPr algn="l">
-              <a:lnSpc>
-                <a:spcPct val="115000"/>
-              </a:lnSpc>
               <a:spcAft>
-                <a:spcPts val="600"/>
+                <a:spcPts val="400"/>
               </a:spcAft>
             </a:pPr>
             <a:r>
-              <a:rPr sz="1400" b="0" i="0">
+              <a:rPr sz="1350" b="0" i="0">
                 <a:solidFill>
                   <a:srgbClr val="F2F4FF"/>
                 </a:solidFill>
@@ -3604,20 +3697,13 @@
                 <a:ea typeface="Meiryo"/>
                 <a:cs typeface="Meiryo"/>
               </a:rPr>
-              <a:t>・IMU BMI270 — 傾き検出・シェイク検出</a:t>
-            </a:r>
-          </a:p>
-          <a:p>
-            <a:pPr algn="l">
-              <a:lnSpc>
-                <a:spcPct val="115000"/>
-              </a:lnSpc>
-              <a:spcAft>
-                <a:spcPts val="600"/>
-              </a:spcAft>
-            </a:pPr>
-            <a:r>
-              <a:rPr sz="1400" b="0" i="0">
+              <a:t>・色を混ぜた瞬間 — その色自身の音 / the color's own note</a:t>
+            </a:r>
+          </a:p>
+          <a:p>
+            <a:pPr algn="l"/>
+            <a:r>
+              <a:rPr sz="1350" b="0" i="0">
                 <a:solidFill>
                   <a:srgbClr val="F2F4FF"/>
                 </a:solidFill>
@@ -3625,84 +3711,21 @@
                 <a:ea typeface="Meiryo"/>
                 <a:cs typeface="Meiryo"/>
               </a:rPr>
-              <a:t>・ES8311 コーデック + 1Wスピーカー + マイク</a:t>
-            </a:r>
-          </a:p>
-          <a:p>
-            <a:pPr algn="l">
-              <a:lnSpc>
-                <a:spcPct val="115000"/>
-              </a:lnSpc>
-              <a:spcAft>
-                <a:spcPts val="600"/>
-              </a:spcAft>
-            </a:pPr>
-            <a:r>
-              <a:rPr sz="1400" b="0" i="0">
-                <a:solidFill>
-                  <a:srgbClr val="F2F4FF"/>
-                </a:solidFill>
-                <a:latin typeface="Meiryo"/>
-                <a:ea typeface="Meiryo"/>
-                <a:cs typeface="Meiryo"/>
-              </a:rPr>
-              <a:t>・RTC RX8130CE + Wi-Fi (時刻はNTPで自動同期)</a:t>
-            </a:r>
-          </a:p>
-          <a:p>
-            <a:pPr algn="l">
-              <a:lnSpc>
-                <a:spcPct val="115000"/>
-              </a:lnSpc>
-              <a:spcAft>
-                <a:spcPts val="600"/>
-              </a:spcAft>
-            </a:pPr>
-            <a:r>
-              <a:rPr sz="1400" b="0" i="0">
-                <a:solidFill>
-                  <a:srgbClr val="F2F4FF"/>
-                </a:solidFill>
-                <a:latin typeface="Meiryo"/>
-                <a:ea typeface="Meiryo"/>
-                <a:cs typeface="Meiryo"/>
-              </a:rPr>
-              <a:t>・Unit Hex (SK6812×37) をPortAに接続可</a:t>
-            </a:r>
-          </a:p>
-          <a:p>
-            <a:pPr algn="l">
-              <a:lnSpc>
-                <a:spcPct val="115000"/>
-              </a:lnSpc>
-              <a:spcAft>
-                <a:spcPts val="600"/>
-              </a:spcAft>
-            </a:pPr>
-            <a:r>
-              <a:rPr sz="1400" b="0" i="0">
-                <a:solidFill>
-                  <a:srgbClr val="F2F4FF"/>
-                </a:solidFill>
-                <a:latin typeface="Meiryo"/>
-                <a:ea typeface="Meiryo"/>
-                <a:cs typeface="Meiryo"/>
-              </a:rPr>
-              <a:t>・3Dプリント製スタンド (Unit Hex組み込み)</a:t>
-            </a:r>
-          </a:p>
-        </p:txBody>
-      </p:sp>
-      <p:sp>
-        <p:nvSpPr>
-          <p:cNvPr id="7" name="Rounded Rectangle 6"/>
+              <a:t>・消音 — 大地を思わせる低い一音 / a low "earth" tone</a:t>
+            </a:r>
+          </a:p>
+        </p:txBody>
+      </p:sp>
+      <p:sp>
+        <p:nvSpPr>
+          <p:cNvPr id="8" name="Rounded Rectangle 7"/>
           <p:cNvSpPr/>
           <p:nvPr/>
         </p:nvSpPr>
         <p:spPr>
           <a:xfrm>
-            <a:off x="6172200" y="1371600"/>
-            <a:ext cx="5257800" cy="4206240"/>
+            <a:off x="5440680" y="4251960"/>
+            <a:ext cx="5897880" cy="1783080"/>
           </a:xfrm>
           <a:prstGeom prst="roundRect">
             <a:avLst>
@@ -3741,14 +3764,14 @@
       </p:sp>
       <p:sp>
         <p:nvSpPr>
-          <p:cNvPr id="8" name="TextBox 7"/>
+          <p:cNvPr id="9" name="TextBox 8"/>
           <p:cNvSpPr txBox="1"/>
           <p:nvPr/>
         </p:nvSpPr>
         <p:spPr>
           <a:xfrm>
-            <a:off x="6537960" y="1645920"/>
-            <a:ext cx="4526280" cy="3657600"/>
+            <a:off x="5760720" y="4453128"/>
+            <a:ext cx="5257800" cy="1463040"/>
           </a:xfrm>
           <a:prstGeom prst="rect">
             <a:avLst/>
@@ -3763,11 +3786,11 @@
           <a:p>
             <a:pPr algn="l">
               <a:spcAft>
-                <a:spcPts val="1000"/>
+                <a:spcPts val="200"/>
               </a:spcAft>
             </a:pPr>
             <a:r>
-              <a:rPr sz="1900" b="1" i="0">
+              <a:rPr sz="1800" b="1" i="0">
                 <a:solidFill>
                   <a:srgbClr val="F9C46B"/>
                 </a:solidFill>
@@ -3775,20 +3798,35 @@
                 <a:ea typeface="Meiryo"/>
                 <a:cs typeface="Meiryo"/>
               </a:rPr>
-              <a:t>ソフトウェア / Software</a:t>
+              <a:t>1/100秒ストップウォッチ</a:t>
             </a:r>
           </a:p>
           <a:p>
             <a:pPr algn="l">
-              <a:lnSpc>
-                <a:spcPct val="115000"/>
-              </a:lnSpc>
               <a:spcAft>
-                <a:spcPts val="600"/>
+                <a:spcPts val="700"/>
               </a:spcAft>
             </a:pPr>
             <a:r>
-              <a:rPr sz="1400" b="0" i="0">
+              <a:rPr sz="1150" b="0" i="1">
+                <a:solidFill>
+                  <a:srgbClr val="A9B4D6"/>
+                </a:solidFill>
+                <a:latin typeface="Meiryo"/>
+                <a:ea typeface="Meiryo"/>
+                <a:cs typeface="Meiryo"/>
+              </a:rPr>
+              <a:t>A lap-capable 1/100s stopwatch, true to the device's name</a:t>
+            </a:r>
+          </a:p>
+          <a:p>
+            <a:pPr algn="l">
+              <a:spcAft>
+                <a:spcPts val="400"/>
+              </a:spcAft>
+            </a:pPr>
+            <a:r>
+              <a:rPr sz="1350" b="0" i="0">
                 <a:solidFill>
                   <a:srgbClr val="F2F4FF"/>
                 </a:solidFill>
@@ -3796,20 +3834,13 @@
                 <a:ea typeface="Meiryo"/>
                 <a:cs typeface="Meiryo"/>
               </a:rPr>
-              <a:t>・PlatformIO + Arduino + M5Unified / FastLED</a:t>
-            </a:r>
-          </a:p>
-          <a:p>
-            <a:pPr algn="l">
-              <a:lnSpc>
-                <a:spcPct val="115000"/>
-              </a:lnSpc>
-              <a:spcAft>
-                <a:spcPts val="600"/>
-              </a:spcAft>
-            </a:pPr>
-            <a:r>
-              <a:rPr sz="1400" b="0" i="0">
+              <a:t>・左ボタンでスタート/ストップ、右ボタンでラップ/リセット</a:t>
+            </a:r>
+          </a:p>
+          <a:p>
+            <a:pPr algn="l"/>
+            <a:r>
+              <a:rPr sz="1350" b="0" i="0">
                 <a:solidFill>
                   <a:srgbClr val="F2F4FF"/>
                 </a:solidFill>
@@ -3817,128 +3848,7 @@
                 <a:ea typeface="Meiryo"/>
                 <a:cs typeface="Meiryo"/>
               </a:rPr>
-              <a:t>・カラーエンジン: 14キーフレームの線形補間</a:t>
-            </a:r>
-          </a:p>
-          <a:p>
-            <a:pPr algn="l">
-              <a:lnSpc>
-                <a:spcPct val="115000"/>
-              </a:lnSpc>
-              <a:spcAft>
-                <a:spcPts val="600"/>
-              </a:spcAft>
-            </a:pPr>
-            <a:r>
-              <a:rPr sz="1400" b="0" i="0">
-                <a:solidFill>
-                  <a:srgbClr val="F2F4FF"/>
-                </a:solidFill>
-                <a:latin typeface="Meiryo"/>
-                <a:ea typeface="Meiryo"/>
-                <a:cs typeface="Meiryo"/>
-              </a:rPr>
-              <a:t>・混色: 累積平均 / 水彩: 58×58格子の拡散 (15fps)</a:t>
-            </a:r>
-          </a:p>
-          <a:p>
-            <a:pPr algn="l">
-              <a:lnSpc>
-                <a:spcPct val="115000"/>
-              </a:lnSpc>
-              <a:spcAft>
-                <a:spcPts val="600"/>
-              </a:spcAft>
-            </a:pPr>
-            <a:r>
-              <a:rPr sz="1400" b="0" i="0">
-                <a:solidFill>
-                  <a:srgbClr val="F2F4FF"/>
-                </a:solidFill>
-                <a:latin typeface="Meiryo"/>
-                <a:ea typeface="Meiryo"/>
-                <a:cs typeface="Meiryo"/>
-              </a:rPr>
-              <a:t>・色→音: 色相→ペンタトニック2オクターブ</a:t>
-            </a:r>
-          </a:p>
-          <a:p>
-            <a:pPr algn="l">
-              <a:lnSpc>
-                <a:spcPct val="115000"/>
-              </a:lnSpc>
-              <a:spcAft>
-                <a:spcPts val="600"/>
-              </a:spcAft>
-            </a:pPr>
-            <a:r>
-              <a:rPr sz="1400" b="0" i="0">
-                <a:solidFill>
-                  <a:srgbClr val="F2F4FF"/>
-                </a:solidFill>
-                <a:latin typeface="Meiryo"/>
-                <a:ea typeface="Meiryo"/>
-                <a:cs typeface="Meiryo"/>
-              </a:rPr>
-              <a:t>・声→色: RMS (大きさ) + ゼロ交差率 (高さ)</a:t>
-            </a:r>
-          </a:p>
-          <a:p>
-            <a:pPr algn="l">
-              <a:lnSpc>
-                <a:spcPct val="115000"/>
-              </a:lnSpc>
-              <a:spcAft>
-                <a:spcPts val="600"/>
-              </a:spcAft>
-            </a:pPr>
-            <a:r>
-              <a:rPr sz="1400" b="0" i="0">
-                <a:solidFill>
-                  <a:srgbClr val="F2F4FF"/>
-                </a:solidFill>
-                <a:latin typeface="Meiryo"/>
-                <a:ea typeface="Meiryo"/>
-                <a:cs typeface="Meiryo"/>
-              </a:rPr>
-              <a:t>・Wi-Fi設定はスマホから / 設定はNVSへ永続化</a:t>
-            </a:r>
-          </a:p>
-        </p:txBody>
-      </p:sp>
-      <p:sp>
-        <p:nvSpPr>
-          <p:cNvPr id="9" name="TextBox 8"/>
-          <p:cNvSpPr txBox="1"/>
-          <p:nvPr/>
-        </p:nvSpPr>
-        <p:spPr>
-          <a:xfrm>
-            <a:off x="822960" y="5897880"/>
-            <a:ext cx="10607040" cy="457200"/>
-          </a:xfrm>
-          <a:prstGeom prst="rect">
-            <a:avLst/>
-          </a:prstGeom>
-          <a:noFill/>
-        </p:spPr>
-        <p:txBody>
-          <a:bodyPr wrap="square" anchor="t" lIns="0" rIns="0" tIns="0" bIns="0">
-            <a:spAutoFit/>
-          </a:bodyPr>
-          <a:lstStyle/>
-          <a:p>
-            <a:pPr algn="ctr"/>
-            <a:r>
-              <a:rPr sz="1400" b="0" i="0">
-                <a:solidFill>
-                  <a:srgbClr val="A9B4D6"/>
-                </a:solidFill>
-                <a:latin typeface="Meiryo"/>
-                <a:ea typeface="Meiryo"/>
-                <a:cs typeface="Meiryo"/>
-              </a:rPr>
-              <a:t>ソースコード・ビルド手順・STLを全公開 / Full source, build steps &amp; STL: github.com/aokko2000/iroirotokei</a:t>
+              <a:t>・デバイス名 “StopWatch” への、まっすぐなリスペクト</a:t>
             </a:r>
           </a:p>
         </p:txBody>
@@ -3952,6 +3862,626 @@
 </file>
 
 <file path=ppt/slides/slide11.xml><?xml version="1.0" encoding="utf-8"?>
+<p:sld xmlns:a="http://schemas.openxmlformats.org/drawingml/2006/main" xmlns:p="http://schemas.openxmlformats.org/presentationml/2006/main" xmlns:r="http://schemas.openxmlformats.org/officeDocument/2006/relationships">
+  <p:cSld>
+    <p:spTree>
+      <p:nvGrpSpPr>
+        <p:cNvPr id="1" name=""/>
+        <p:cNvGrpSpPr/>
+        <p:nvPr/>
+      </p:nvGrpSpPr>
+      <p:grpSpPr/>
+      <p:sp>
+        <p:nvSpPr>
+          <p:cNvPr id="2" name="Rectangle 1"/>
+          <p:cNvSpPr/>
+          <p:nvPr/>
+        </p:nvSpPr>
+        <p:spPr>
+          <a:xfrm>
+            <a:off x="0" y="0"/>
+            <a:ext cx="12191695" cy="6858000"/>
+          </a:xfrm>
+          <a:prstGeom prst="rect">
+            <a:avLst/>
+          </a:prstGeom>
+          <a:solidFill>
+            <a:srgbClr val="0F1430"/>
+          </a:solidFill>
+          <a:ln>
+            <a:noFill/>
+          </a:ln>
+          <a:effectLst/>
+        </p:spPr>
+        <p:style>
+          <a:lnRef idx="1">
+            <a:schemeClr val="accent1"/>
+          </a:lnRef>
+          <a:fillRef idx="3">
+            <a:schemeClr val="accent1"/>
+          </a:fillRef>
+          <a:effectRef idx="2">
+            <a:schemeClr val="accent1"/>
+          </a:effectRef>
+          <a:fontRef idx="minor">
+            <a:schemeClr val="lt1"/>
+          </a:fontRef>
+        </p:style>
+        <p:txBody>
+          <a:bodyPr rtlCol="0" anchor="ctr"/>
+          <a:lstStyle/>
+          <a:p>
+            <a:pPr algn="ctr"/>
+          </a:p>
+        </p:txBody>
+      </p:sp>
+      <p:sp>
+        <p:nvSpPr>
+          <p:cNvPr id="3" name="TextBox 2"/>
+          <p:cNvSpPr txBox="1"/>
+          <p:nvPr/>
+        </p:nvSpPr>
+        <p:spPr>
+          <a:xfrm>
+            <a:off x="822960" y="457200"/>
+            <a:ext cx="10515600" cy="731520"/>
+          </a:xfrm>
+          <a:prstGeom prst="rect">
+            <a:avLst/>
+          </a:prstGeom>
+          <a:noFill/>
+        </p:spPr>
+        <p:txBody>
+          <a:bodyPr wrap="square" anchor="t" lIns="0" rIns="0" tIns="0" bIns="0">
+            <a:spAutoFit/>
+          </a:bodyPr>
+          <a:lstStyle/>
+          <a:p>
+            <a:pPr algn="l"/>
+            <a:r>
+              <a:rPr sz="3000" b="1" i="0">
+                <a:solidFill>
+                  <a:srgbClr val="F2F4FF"/>
+                </a:solidFill>
+                <a:latin typeface="Meiryo"/>
+                <a:ea typeface="Meiryo"/>
+                <a:cs typeface="Meiryo"/>
+              </a:rPr>
+              <a:t>つくりかた — 技術構成</a:t>
+            </a:r>
+          </a:p>
+        </p:txBody>
+      </p:sp>
+      <p:sp>
+        <p:nvSpPr>
+          <p:cNvPr id="4" name="TextBox 3"/>
+          <p:cNvSpPr txBox="1"/>
+          <p:nvPr/>
+        </p:nvSpPr>
+        <p:spPr>
+          <a:xfrm>
+            <a:off x="822960" y="969264"/>
+            <a:ext cx="10515600" cy="365760"/>
+          </a:xfrm>
+          <a:prstGeom prst="rect">
+            <a:avLst/>
+          </a:prstGeom>
+          <a:noFill/>
+        </p:spPr>
+        <p:txBody>
+          <a:bodyPr wrap="square" anchor="t" lIns="0" rIns="0" tIns="0" bIns="0">
+            <a:spAutoFit/>
+          </a:bodyPr>
+          <a:lstStyle/>
+          <a:p>
+            <a:pPr algn="l"/>
+            <a:r>
+              <a:rPr sz="1400" b="0" i="1">
+                <a:solidFill>
+                  <a:srgbClr val="A9B4D6"/>
+                </a:solidFill>
+                <a:latin typeface="Meiryo"/>
+                <a:ea typeface="Meiryo"/>
+                <a:cs typeface="Meiryo"/>
+              </a:rPr>
+              <a:t>How it works — hardware &amp; software</a:t>
+            </a:r>
+          </a:p>
+        </p:txBody>
+      </p:sp>
+      <p:sp>
+        <p:nvSpPr>
+          <p:cNvPr id="5" name="Rounded Rectangle 4"/>
+          <p:cNvSpPr/>
+          <p:nvPr/>
+        </p:nvSpPr>
+        <p:spPr>
+          <a:xfrm>
+            <a:off x="822960" y="1371600"/>
+            <a:ext cx="5257800" cy="4206240"/>
+          </a:xfrm>
+          <a:prstGeom prst="roundRect">
+            <a:avLst>
+              <a:gd name="adj" fmla="val 4500"/>
+            </a:avLst>
+          </a:prstGeom>
+          <a:solidFill>
+            <a:srgbClr val="1B2248"/>
+          </a:solidFill>
+          <a:ln>
+            <a:noFill/>
+          </a:ln>
+          <a:effectLst/>
+        </p:spPr>
+        <p:style>
+          <a:lnRef idx="1">
+            <a:schemeClr val="accent1"/>
+          </a:lnRef>
+          <a:fillRef idx="3">
+            <a:schemeClr val="accent1"/>
+          </a:fillRef>
+          <a:effectRef idx="2">
+            <a:schemeClr val="accent1"/>
+          </a:effectRef>
+          <a:fontRef idx="minor">
+            <a:schemeClr val="lt1"/>
+          </a:fontRef>
+        </p:style>
+        <p:txBody>
+          <a:bodyPr rtlCol="0" anchor="ctr"/>
+          <a:lstStyle/>
+          <a:p>
+            <a:pPr algn="ctr"/>
+          </a:p>
+        </p:txBody>
+      </p:sp>
+      <p:sp>
+        <p:nvSpPr>
+          <p:cNvPr id="6" name="TextBox 5"/>
+          <p:cNvSpPr txBox="1"/>
+          <p:nvPr/>
+        </p:nvSpPr>
+        <p:spPr>
+          <a:xfrm>
+            <a:off x="1188720" y="1645920"/>
+            <a:ext cx="4526280" cy="3657600"/>
+          </a:xfrm>
+          <a:prstGeom prst="rect">
+            <a:avLst/>
+          </a:prstGeom>
+          <a:noFill/>
+        </p:spPr>
+        <p:txBody>
+          <a:bodyPr wrap="square" anchor="t" lIns="0" rIns="0" tIns="0" bIns="0">
+            <a:spAutoFit/>
+          </a:bodyPr>
+          <a:lstStyle/>
+          <a:p>
+            <a:pPr algn="l">
+              <a:spcAft>
+                <a:spcPts val="1000"/>
+              </a:spcAft>
+            </a:pPr>
+            <a:r>
+              <a:rPr sz="1900" b="1" i="0">
+                <a:solidFill>
+                  <a:srgbClr val="F9C46B"/>
+                </a:solidFill>
+                <a:latin typeface="Meiryo"/>
+                <a:ea typeface="Meiryo"/>
+                <a:cs typeface="Meiryo"/>
+              </a:rPr>
+              <a:t>ハードウェア / Hardware</a:t>
+            </a:r>
+          </a:p>
+          <a:p>
+            <a:pPr algn="l">
+              <a:lnSpc>
+                <a:spcPct val="115000"/>
+              </a:lnSpc>
+              <a:spcAft>
+                <a:spcPts val="600"/>
+              </a:spcAft>
+            </a:pPr>
+            <a:r>
+              <a:rPr sz="1400" b="0" i="0">
+                <a:solidFill>
+                  <a:srgbClr val="F2F4FF"/>
+                </a:solidFill>
+                <a:latin typeface="Meiryo"/>
+                <a:ea typeface="Meiryo"/>
+                <a:cs typeface="Meiryo"/>
+              </a:rPr>
+              <a:t>・M5Stack StopWatch (ESP32-S3R8, 240MHz)</a:t>
+            </a:r>
+          </a:p>
+          <a:p>
+            <a:pPr algn="l">
+              <a:lnSpc>
+                <a:spcPct val="115000"/>
+              </a:lnSpc>
+              <a:spcAft>
+                <a:spcPts val="600"/>
+              </a:spcAft>
+            </a:pPr>
+            <a:r>
+              <a:rPr sz="1400" b="0" i="0">
+                <a:solidFill>
+                  <a:srgbClr val="F2F4FF"/>
+                </a:solidFill>
+                <a:latin typeface="Meiryo"/>
+                <a:ea typeface="Meiryo"/>
+                <a:cs typeface="Meiryo"/>
+              </a:rPr>
+              <a:t>・1.75インチ 円形AMOLEDタッチ 466×466</a:t>
+            </a:r>
+          </a:p>
+          <a:p>
+            <a:pPr algn="l">
+              <a:lnSpc>
+                <a:spcPct val="115000"/>
+              </a:lnSpc>
+              <a:spcAft>
+                <a:spcPts val="600"/>
+              </a:spcAft>
+            </a:pPr>
+            <a:r>
+              <a:rPr sz="1400" b="0" i="0">
+                <a:solidFill>
+                  <a:srgbClr val="F2F4FF"/>
+                </a:solidFill>
+                <a:latin typeface="Meiryo"/>
+                <a:ea typeface="Meiryo"/>
+                <a:cs typeface="Meiryo"/>
+              </a:rPr>
+              <a:t>・IMU BMI270 — 傾き検出・シェイク検出</a:t>
+            </a:r>
+          </a:p>
+          <a:p>
+            <a:pPr algn="l">
+              <a:lnSpc>
+                <a:spcPct val="115000"/>
+              </a:lnSpc>
+              <a:spcAft>
+                <a:spcPts val="600"/>
+              </a:spcAft>
+            </a:pPr>
+            <a:r>
+              <a:rPr sz="1400" b="0" i="0">
+                <a:solidFill>
+                  <a:srgbClr val="F2F4FF"/>
+                </a:solidFill>
+                <a:latin typeface="Meiryo"/>
+                <a:ea typeface="Meiryo"/>
+                <a:cs typeface="Meiryo"/>
+              </a:rPr>
+              <a:t>・ES8311 コーデック + 1Wスピーカー + マイク</a:t>
+            </a:r>
+          </a:p>
+          <a:p>
+            <a:pPr algn="l">
+              <a:lnSpc>
+                <a:spcPct val="115000"/>
+              </a:lnSpc>
+              <a:spcAft>
+                <a:spcPts val="600"/>
+              </a:spcAft>
+            </a:pPr>
+            <a:r>
+              <a:rPr sz="1400" b="0" i="0">
+                <a:solidFill>
+                  <a:srgbClr val="F2F4FF"/>
+                </a:solidFill>
+                <a:latin typeface="Meiryo"/>
+                <a:ea typeface="Meiryo"/>
+                <a:cs typeface="Meiryo"/>
+              </a:rPr>
+              <a:t>・RTC RX8130CE + Wi-Fi (時刻はNTPで自動同期)</a:t>
+            </a:r>
+          </a:p>
+          <a:p>
+            <a:pPr algn="l">
+              <a:lnSpc>
+                <a:spcPct val="115000"/>
+              </a:lnSpc>
+              <a:spcAft>
+                <a:spcPts val="600"/>
+              </a:spcAft>
+            </a:pPr>
+            <a:r>
+              <a:rPr sz="1400" b="0" i="0">
+                <a:solidFill>
+                  <a:srgbClr val="F2F4FF"/>
+                </a:solidFill>
+                <a:latin typeface="Meiryo"/>
+                <a:ea typeface="Meiryo"/>
+                <a:cs typeface="Meiryo"/>
+              </a:rPr>
+              <a:t>・Unit Hex (SK6812×37) をPortAに接続可</a:t>
+            </a:r>
+          </a:p>
+          <a:p>
+            <a:pPr algn="l">
+              <a:lnSpc>
+                <a:spcPct val="115000"/>
+              </a:lnSpc>
+              <a:spcAft>
+                <a:spcPts val="600"/>
+              </a:spcAft>
+            </a:pPr>
+            <a:r>
+              <a:rPr sz="1400" b="0" i="0">
+                <a:solidFill>
+                  <a:srgbClr val="F2F4FF"/>
+                </a:solidFill>
+                <a:latin typeface="Meiryo"/>
+                <a:ea typeface="Meiryo"/>
+                <a:cs typeface="Meiryo"/>
+              </a:rPr>
+              <a:t>・3Dプリント製スタンド (Unit Hex組み込み)</a:t>
+            </a:r>
+          </a:p>
+        </p:txBody>
+      </p:sp>
+      <p:sp>
+        <p:nvSpPr>
+          <p:cNvPr id="7" name="Rounded Rectangle 6"/>
+          <p:cNvSpPr/>
+          <p:nvPr/>
+        </p:nvSpPr>
+        <p:spPr>
+          <a:xfrm>
+            <a:off x="6172200" y="1371600"/>
+            <a:ext cx="5257800" cy="4206240"/>
+          </a:xfrm>
+          <a:prstGeom prst="roundRect">
+            <a:avLst>
+              <a:gd name="adj" fmla="val 4500"/>
+            </a:avLst>
+          </a:prstGeom>
+          <a:solidFill>
+            <a:srgbClr val="1B2248"/>
+          </a:solidFill>
+          <a:ln>
+            <a:noFill/>
+          </a:ln>
+          <a:effectLst/>
+        </p:spPr>
+        <p:style>
+          <a:lnRef idx="1">
+            <a:schemeClr val="accent1"/>
+          </a:lnRef>
+          <a:fillRef idx="3">
+            <a:schemeClr val="accent1"/>
+          </a:fillRef>
+          <a:effectRef idx="2">
+            <a:schemeClr val="accent1"/>
+          </a:effectRef>
+          <a:fontRef idx="minor">
+            <a:schemeClr val="lt1"/>
+          </a:fontRef>
+        </p:style>
+        <p:txBody>
+          <a:bodyPr rtlCol="0" anchor="ctr"/>
+          <a:lstStyle/>
+          <a:p>
+            <a:pPr algn="ctr"/>
+          </a:p>
+        </p:txBody>
+      </p:sp>
+      <p:sp>
+        <p:nvSpPr>
+          <p:cNvPr id="8" name="TextBox 7"/>
+          <p:cNvSpPr txBox="1"/>
+          <p:nvPr/>
+        </p:nvSpPr>
+        <p:spPr>
+          <a:xfrm>
+            <a:off x="6537960" y="1645920"/>
+            <a:ext cx="4526280" cy="3657600"/>
+          </a:xfrm>
+          <a:prstGeom prst="rect">
+            <a:avLst/>
+          </a:prstGeom>
+          <a:noFill/>
+        </p:spPr>
+        <p:txBody>
+          <a:bodyPr wrap="square" anchor="t" lIns="0" rIns="0" tIns="0" bIns="0">
+            <a:spAutoFit/>
+          </a:bodyPr>
+          <a:lstStyle/>
+          <a:p>
+            <a:pPr algn="l">
+              <a:spcAft>
+                <a:spcPts val="1000"/>
+              </a:spcAft>
+            </a:pPr>
+            <a:r>
+              <a:rPr sz="1900" b="1" i="0">
+                <a:solidFill>
+                  <a:srgbClr val="F9C46B"/>
+                </a:solidFill>
+                <a:latin typeface="Meiryo"/>
+                <a:ea typeface="Meiryo"/>
+                <a:cs typeface="Meiryo"/>
+              </a:rPr>
+              <a:t>ソフトウェア / Software</a:t>
+            </a:r>
+          </a:p>
+          <a:p>
+            <a:pPr algn="l">
+              <a:lnSpc>
+                <a:spcPct val="115000"/>
+              </a:lnSpc>
+              <a:spcAft>
+                <a:spcPts val="600"/>
+              </a:spcAft>
+            </a:pPr>
+            <a:r>
+              <a:rPr sz="1400" b="0" i="0">
+                <a:solidFill>
+                  <a:srgbClr val="F2F4FF"/>
+                </a:solidFill>
+                <a:latin typeface="Meiryo"/>
+                <a:ea typeface="Meiryo"/>
+                <a:cs typeface="Meiryo"/>
+              </a:rPr>
+              <a:t>・PlatformIO + Arduino + M5Unified / FastLED</a:t>
+            </a:r>
+          </a:p>
+          <a:p>
+            <a:pPr algn="l">
+              <a:lnSpc>
+                <a:spcPct val="115000"/>
+              </a:lnSpc>
+              <a:spcAft>
+                <a:spcPts val="600"/>
+              </a:spcAft>
+            </a:pPr>
+            <a:r>
+              <a:rPr sz="1400" b="0" i="0">
+                <a:solidFill>
+                  <a:srgbClr val="F2F4FF"/>
+                </a:solidFill>
+                <a:latin typeface="Meiryo"/>
+                <a:ea typeface="Meiryo"/>
+                <a:cs typeface="Meiryo"/>
+              </a:rPr>
+              <a:t>・カラーエンジン: 14キーフレームの線形補間</a:t>
+            </a:r>
+          </a:p>
+          <a:p>
+            <a:pPr algn="l">
+              <a:lnSpc>
+                <a:spcPct val="115000"/>
+              </a:lnSpc>
+              <a:spcAft>
+                <a:spcPts val="600"/>
+              </a:spcAft>
+            </a:pPr>
+            <a:r>
+              <a:rPr sz="1400" b="0" i="0">
+                <a:solidFill>
+                  <a:srgbClr val="F2F4FF"/>
+                </a:solidFill>
+                <a:latin typeface="Meiryo"/>
+                <a:ea typeface="Meiryo"/>
+                <a:cs typeface="Meiryo"/>
+              </a:rPr>
+              <a:t>・混色: 累積平均 / 水彩: 58×58格子の拡散 (15fps)</a:t>
+            </a:r>
+          </a:p>
+          <a:p>
+            <a:pPr algn="l">
+              <a:lnSpc>
+                <a:spcPct val="115000"/>
+              </a:lnSpc>
+              <a:spcAft>
+                <a:spcPts val="600"/>
+              </a:spcAft>
+            </a:pPr>
+            <a:r>
+              <a:rPr sz="1400" b="0" i="0">
+                <a:solidFill>
+                  <a:srgbClr val="F2F4FF"/>
+                </a:solidFill>
+                <a:latin typeface="Meiryo"/>
+                <a:ea typeface="Meiryo"/>
+                <a:cs typeface="Meiryo"/>
+              </a:rPr>
+              <a:t>・色→音: 色相→ペンタトニック2オクターブ</a:t>
+            </a:r>
+          </a:p>
+          <a:p>
+            <a:pPr algn="l">
+              <a:lnSpc>
+                <a:spcPct val="115000"/>
+              </a:lnSpc>
+              <a:spcAft>
+                <a:spcPts val="600"/>
+              </a:spcAft>
+            </a:pPr>
+            <a:r>
+              <a:rPr sz="1400" b="0" i="0">
+                <a:solidFill>
+                  <a:srgbClr val="F2F4FF"/>
+                </a:solidFill>
+                <a:latin typeface="Meiryo"/>
+                <a:ea typeface="Meiryo"/>
+                <a:cs typeface="Meiryo"/>
+              </a:rPr>
+              <a:t>・声→色: RMS (大きさ) + ゼロ交差率 (高さ)</a:t>
+            </a:r>
+          </a:p>
+          <a:p>
+            <a:pPr algn="l">
+              <a:lnSpc>
+                <a:spcPct val="115000"/>
+              </a:lnSpc>
+              <a:spcAft>
+                <a:spcPts val="600"/>
+              </a:spcAft>
+            </a:pPr>
+            <a:r>
+              <a:rPr sz="1400" b="0" i="0">
+                <a:solidFill>
+                  <a:srgbClr val="F2F4FF"/>
+                </a:solidFill>
+                <a:latin typeface="Meiryo"/>
+                <a:ea typeface="Meiryo"/>
+                <a:cs typeface="Meiryo"/>
+              </a:rPr>
+              <a:t>・Wi-Fi設定はスマホから / 設定はNVSへ永続化</a:t>
+            </a:r>
+          </a:p>
+        </p:txBody>
+      </p:sp>
+      <p:sp>
+        <p:nvSpPr>
+          <p:cNvPr id="9" name="TextBox 8"/>
+          <p:cNvSpPr txBox="1"/>
+          <p:nvPr/>
+        </p:nvSpPr>
+        <p:spPr>
+          <a:xfrm>
+            <a:off x="822960" y="5897880"/>
+            <a:ext cx="10607040" cy="457200"/>
+          </a:xfrm>
+          <a:prstGeom prst="rect">
+            <a:avLst/>
+          </a:prstGeom>
+          <a:noFill/>
+        </p:spPr>
+        <p:txBody>
+          <a:bodyPr wrap="square" anchor="t" lIns="0" rIns="0" tIns="0" bIns="0">
+            <a:spAutoFit/>
+          </a:bodyPr>
+          <a:lstStyle/>
+          <a:p>
+            <a:pPr algn="ctr"/>
+            <a:r>
+              <a:rPr sz="1400" b="0" i="0">
+                <a:solidFill>
+                  <a:srgbClr val="A9B4D6"/>
+                </a:solidFill>
+                <a:latin typeface="Meiryo"/>
+                <a:ea typeface="Meiryo"/>
+                <a:cs typeface="Meiryo"/>
+              </a:rPr>
+              <a:t>ソースコード・ビルド手順・STLを全公開 / Full source, build steps &amp; STL: github.com/aokko2000/iroirotokei</a:t>
+            </a:r>
+          </a:p>
+        </p:txBody>
+      </p:sp>
+    </p:spTree>
+  </p:cSld>
+  <p:clrMapOvr>
+    <a:masterClrMapping/>
+  </p:clrMapOvr>
+</p:sld>
+</file>
+
+<file path=ppt/slides/slide12.xml><?xml version="1.0" encoding="utf-8"?>
 <p:sld xmlns:a="http://schemas.openxmlformats.org/drawingml/2006/main" xmlns:p="http://schemas.openxmlformats.org/presentationml/2006/main" xmlns:r="http://schemas.openxmlformats.org/officeDocument/2006/relationships">
   <p:cSld>
     <p:spTree>
@@ -5655,7 +6185,7 @@
                 <a:ea typeface="Meiryo"/>
                 <a:cs typeface="Meiryo"/>
               </a:rPr>
-              <a:t>色づくり — 混ぜて、聴く</a:t>
+              <a:t>月時計 — 夜は、月で時を知る</a:t>
             </a:r>
           </a:p>
         </p:txBody>
@@ -5692,14 +6222,14 @@
                 <a:ea typeface="Meiryo"/>
                 <a:cs typeface="Meiryo"/>
               </a:rPr>
-              <a:t>Color Maker — mix it, hear it</a:t>
+              <a:t>Moon Clock — at night, the moon tells the time</a:t>
             </a:r>
           </a:p>
         </p:txBody>
       </p:sp>
       <p:pic>
         <p:nvPicPr>
-          <p:cNvPr id="5" name="Picture 4" descr="mock_mixer.png"/>
+          <p:cNvPr id="5" name="Picture 4" descr="mock_moon.png"/>
           <p:cNvPicPr>
             <a:picLocks noChangeAspect="1"/>
           </p:cNvPicPr>
@@ -5713,7 +6243,7 @@
         </p:blipFill>
         <p:spPr>
           <a:xfrm>
-            <a:off x="6537960" y="1508760"/>
+            <a:off x="777240" y="1508760"/>
             <a:ext cx="4754880" cy="4754880"/>
           </a:xfrm>
           <a:prstGeom prst="rect">
@@ -5729,7 +6259,7 @@
         </p:nvSpPr>
         <p:spPr>
           <a:xfrm>
-            <a:off x="822960" y="1645920"/>
+            <a:off x="6263640" y="1645920"/>
             <a:ext cx="5120640" cy="1463040"/>
           </a:xfrm>
           <a:prstGeom prst="rect">
@@ -5757,7 +6287,7 @@
                 <a:ea typeface="Meiryo"/>
                 <a:cs typeface="Meiryo"/>
               </a:rPr>
-              <a:t>左で選ぶ、右で混ぜる</a:t>
+              <a:t>今夜の月が、そのまま浮かぶ</a:t>
             </a:r>
           </a:p>
           <a:p>
@@ -5778,7 +6308,7 @@
                 <a:ea typeface="Meiryo"/>
                 <a:cs typeface="Meiryo"/>
               </a:rPr>
-              <a:t>混色は累積平均 — 足すほど1滴が繊細になる絵の具の感覚。理論上1,677万色のどの色にも。</a:t>
+              <a:t>天文計算 (Meeus式) で月齢と欠け際まで正確に描画。月齢・名前 (十三夜、十六夜…)・輝面比・満月までの日数。</a:t>
             </a:r>
           </a:p>
           <a:p>
@@ -5796,7 +6326,7 @@
                 <a:ea typeface="Meiryo"/>
                 <a:cs typeface="Meiryo"/>
               </a:rPr>
-              <a:t>Running-average mixing feels like real paint — 16.7M colors within reach.</a:t>
+              <a:t>The real phase, computed astronomically — age, name, illumination, days to full.</a:t>
             </a:r>
           </a:p>
         </p:txBody>
@@ -5809,7 +6339,7 @@
         </p:nvSpPr>
         <p:spPr>
           <a:xfrm>
-            <a:off x="822960" y="3291840"/>
+            <a:off x="6263640" y="3291840"/>
             <a:ext cx="5120640" cy="1463040"/>
           </a:xfrm>
           <a:prstGeom prst="rect">
@@ -5837,7 +6367,7 @@
                 <a:ea typeface="Meiryo"/>
                 <a:cs typeface="Meiryo"/>
               </a:rPr>
-              <a:t>できた色が、音になる</a:t>
+              <a:t>月食も、赤銅色で</a:t>
             </a:r>
           </a:p>
           <a:p>
@@ -5858,7 +6388,7 @@
                 <a:ea typeface="Meiryo"/>
                 <a:cs typeface="Meiryo"/>
               </a:rPr>
-              <a:t>色相をペンタトニック音階にマッピング。赤は低く、紫は高く。「好きな色の音」を探すあそび。</a:t>
+              <a:t>日本で見られる月食を内蔵 (2026年3月3日の皆既月食は国立天文台の公表値)。当夜は画面の月とLEDが赤銅色に染まる。</a:t>
             </a:r>
           </a:p>
           <a:p>
@@ -5876,7 +6406,7 @@
                 <a:ea typeface="Meiryo"/>
                 <a:cs typeface="Meiryo"/>
               </a:rPr>
-              <a:t>Every mix plays its own note: hue maps to a pentatonic scale, red low, violet high.</a:t>
+              <a:t>A built-in eclipse table (NAOJ data) — on eclipse night the moon and LEDs turn copper-red.</a:t>
             </a:r>
           </a:p>
         </p:txBody>
@@ -5889,7 +6419,7 @@
         </p:nvSpPr>
         <p:spPr>
           <a:xfrm>
-            <a:off x="822960" y="4937760"/>
+            <a:off x="6263640" y="4937760"/>
             <a:ext cx="5120640" cy="1463040"/>
           </a:xfrm>
           <a:prstGeom prst="rect">
@@ -5917,7 +6447,7 @@
                 <a:ea typeface="Meiryo"/>
                 <a:cs typeface="Meiryo"/>
               </a:rPr>
-              <a:t>振れば、偶然の色</a:t>
+              <a:t>流星群の夜は、流れ星</a:t>
             </a:r>
           </a:p>
           <a:p>
@@ -5938,7 +6468,7 @@
                 <a:ea typeface="Meiryo"/>
                 <a:cs typeface="Meiryo"/>
               </a:rPr>
-              <a:t>本体をシェイクすると1,677万色からランダムな一色。気に入ればそこから混ぜて調整。</a:t>
+              <a:t>主要9流星群の極大日を内蔵。極大夜は画面を流れ星が横切り、LEDがきらめく。月明かりから観測条件◎○△も判定。</a:t>
             </a:r>
           </a:p>
           <a:p>
@@ -5956,7 +6486,7 @@
                 <a:ea typeface="Meiryo"/>
                 <a:cs typeface="Meiryo"/>
               </a:rPr>
-              <a:t>Shake the device for a random color, then refine it by mixing.</a:t>
+              <a:t>On meteor-shower peaks, shooting stars cross the screen — with viewing conditions judged from the moonlight.</a:t>
             </a:r>
           </a:p>
         </p:txBody>
@@ -6066,7 +6596,7 @@
                 <a:ea typeface="Meiryo"/>
                 <a:cs typeface="Meiryo"/>
               </a:rPr>
-              <a:t>傾き絵の具 — かたむけて、にじませる</a:t>
+              <a:t>色づくり — 混ぜて、聴く</a:t>
             </a:r>
           </a:p>
         </p:txBody>
@@ -6103,14 +6633,14 @@
                 <a:ea typeface="Meiryo"/>
                 <a:cs typeface="Meiryo"/>
               </a:rPr>
-              <a:t>Tilt Paint — watercolor by gravity</a:t>
+              <a:t>Color Maker — mix it, hear it</a:t>
             </a:r>
           </a:p>
         </p:txBody>
       </p:sp>
       <p:pic>
         <p:nvPicPr>
-          <p:cNvPr id="5" name="Picture 4" descr="mock_tilt.png"/>
+          <p:cNvPr id="5" name="Picture 4" descr="mock_mixer.png"/>
           <p:cNvPicPr>
             <a:picLocks noChangeAspect="1"/>
           </p:cNvPicPr>
@@ -6168,7 +6698,7 @@
                 <a:ea typeface="Meiryo"/>
                 <a:cs typeface="Meiryo"/>
               </a:rPr>
-              <a:t>傾けると、絵の具が流れる</a:t>
+              <a:t>左で選ぶ、右で混ぜる</a:t>
             </a:r>
           </a:p>
           <a:p>
@@ -6189,7 +6719,7 @@
                 <a:ea typeface="Meiryo"/>
                 <a:cs typeface="Meiryo"/>
               </a:rPr>
-              <a:t>IMU (BMI270) が傾きを検出。傾けた側へ色が流れ込み、低い側ほど濃く積もる — 色の強い場所と弱い場所。</a:t>
+              <a:t>混色は累積平均 — 足すほど1滴が繊細になる絵の具の感覚。理論上1,677万色のどの色にも。</a:t>
             </a:r>
           </a:p>
           <a:p>
@@ -6207,7 +6737,7 @@
                 <a:ea typeface="Meiryo"/>
                 <a:cs typeface="Meiryo"/>
               </a:rPr>
-              <a:t>The IMU pours color toward the low side — pooling dark, thinning light.</a:t>
+              <a:t>Running-average mixing feels like real paint — 16.7M colors within reach.</a:t>
             </a:r>
           </a:p>
         </p:txBody>
@@ -6248,7 +6778,7 @@
                 <a:ea typeface="Meiryo"/>
                 <a:cs typeface="Meiryo"/>
               </a:rPr>
-              <a:t>水彩のようなにじみ</a:t>
+              <a:t>できた色が、音になる</a:t>
             </a:r>
           </a:p>
           <a:p>
@@ -6269,7 +6799,7 @@
                 <a:ea typeface="Meiryo"/>
                 <a:cs typeface="Meiryo"/>
               </a:rPr>
-              <a:t>毎フレームの拡散処理で、隣りあう色がじわっと混ざる。左右のボタンで2つの絵の具つぼの色を選ぶ。</a:t>
+              <a:t>色相をペンタトニック音階にマッピング。赤は低く、紫は高く。「好きな色の音」を探すあそび。</a:t>
             </a:r>
           </a:p>
           <a:p>
@@ -6287,7 +6817,7 @@
                 <a:ea typeface="Meiryo"/>
                 <a:cs typeface="Meiryo"/>
               </a:rPr>
-              <a:t>A per-frame diffusion pass bleeds neighboring colors like wet-on-wet paper.</a:t>
+              <a:t>Every mix plays its own note: hue maps to a pentatonic scale, red low, violet high.</a:t>
             </a:r>
           </a:p>
         </p:txBody>
@@ -6328,7 +6858,7 @@
                 <a:ea typeface="Meiryo"/>
                 <a:cs typeface="Meiryo"/>
               </a:rPr>
-              <a:t>星屑のようなキラキラ音</a:t>
+              <a:t>振れば、偶然の色</a:t>
             </a:r>
           </a:p>
           <a:p>
@@ -6349,7 +6879,7 @@
                 <a:ea typeface="Meiryo"/>
                 <a:cs typeface="Meiryo"/>
               </a:rPr>
-              <a:t>傾けている間、高音のペンタトニックがランダムにまたたく。傾きが強いほど、大きく・速く。</a:t>
+              <a:t>本体をシェイクすると1,677万色からランダムな一色。気に入ればそこから混ぜて調整。</a:t>
             </a:r>
           </a:p>
           <a:p>
@@ -6367,7 +6897,7 @@
                 <a:ea typeface="Meiryo"/>
                 <a:cs typeface="Meiryo"/>
               </a:rPr>
-              <a:t>Pentatonic sparkles twinkle louder and faster the harder you tilt.</a:t>
+              <a:t>Shake the device for a random color, then refine it by mixing.</a:t>
             </a:r>
           </a:p>
         </p:txBody>
@@ -6477,7 +7007,7 @@
                 <a:ea typeface="Meiryo"/>
                 <a:cs typeface="Meiryo"/>
               </a:rPr>
-              <a:t>声の色 — あなたの声は何色?</a:t>
+              <a:t>傾き絵の具 — かたむけて、にじませる</a:t>
             </a:r>
           </a:p>
         </p:txBody>
@@ -6514,14 +7044,14 @@
                 <a:ea typeface="Meiryo"/>
                 <a:cs typeface="Meiryo"/>
               </a:rPr>
-              <a:t>Voice Color — what does your voice look like?</a:t>
+              <a:t>Tilt Paint — watercolor by gravity</a:t>
             </a:r>
           </a:p>
         </p:txBody>
       </p:sp>
       <p:pic>
         <p:nvPicPr>
-          <p:cNvPr id="5" name="Picture 4" descr="mock_voice.png"/>
+          <p:cNvPr id="5" name="Picture 4" descr="mock_tilt.png"/>
           <p:cNvPicPr>
             <a:picLocks noChangeAspect="1"/>
           </p:cNvPicPr>
@@ -6579,7 +7109,7 @@
                 <a:ea typeface="Meiryo"/>
                 <a:cs typeface="Meiryo"/>
               </a:rPr>
-              <a:t>話しかけると、色になる</a:t>
+              <a:t>傾けると、絵の具が流れる</a:t>
             </a:r>
           </a:p>
           <a:p>
@@ -6600,7 +7130,7 @@
                 <a:ea typeface="Meiryo"/>
                 <a:cs typeface="Meiryo"/>
               </a:rPr>
-              <a:t>マイクが声をリアルタイムに色へ。声の高さ→色相 (低い声は赤、高い声は紫)、大きさ→明るさ。</a:t>
+              <a:t>IMU (BMI270) が傾きを検出。傾けた側へ色が流れ込み、低い側ほど濃く積もる — 色の強い場所と弱い場所。</a:t>
             </a:r>
           </a:p>
           <a:p>
@@ -6618,7 +7148,7 @@
                 <a:ea typeface="Meiryo"/>
                 <a:cs typeface="Meiryo"/>
               </a:rPr>
-              <a:t>Pitch becomes hue, loudness becomes brightness — in real time.</a:t>
+              <a:t>The IMU pours color toward the low side — pooling dark, thinning light.</a:t>
             </a:r>
           </a:p>
         </p:txBody>
@@ -6659,7 +7189,7 @@
                 <a:ea typeface="Meiryo"/>
                 <a:cs typeface="Meiryo"/>
               </a:rPr>
-              <a:t>声の色が、返事をする</a:t>
+              <a:t>水彩のようなにじみ</a:t>
             </a:r>
           </a:p>
           <a:p>
@@ -6680,7 +7210,7 @@
                 <a:ea typeface="Meiryo"/>
                 <a:cs typeface="Meiryo"/>
               </a:rPr>
-              <a:t>話し終わると、デバイスが「あなたの声の色の音」を鳴らして返す。歌えば色が踊る。</a:t>
+              <a:t>毎フレームの拡散処理で、隣りあう色がじわっと混ざる。左右のボタンで2つの絵の具つぼの色を選ぶ。</a:t>
             </a:r>
           </a:p>
           <a:p>
@@ -6698,7 +7228,7 @@
                 <a:ea typeface="Meiryo"/>
                 <a:cs typeface="Meiryo"/>
               </a:rPr>
-              <a:t>Stop talking, and the device answers with the sound of your color.</a:t>
+              <a:t>A per-frame diffusion pass bleeds neighboring colors like wet-on-wet paper.</a:t>
             </a:r>
           </a:p>
         </p:txBody>
@@ -6739,7 +7269,7 @@
                 <a:ea typeface="Meiryo"/>
                 <a:cs typeface="Meiryo"/>
               </a:rPr>
-              <a:t>マイクとスピーカーの自動交代</a:t>
+              <a:t>星屑のようなキラキラ音</a:t>
             </a:r>
           </a:p>
           <a:p>
@@ -6760,7 +7290,7 @@
                 <a:ea typeface="Meiryo"/>
                 <a:cs typeface="Meiryo"/>
               </a:rPr>
-              <a:t>共有コーデック (ES8311) を、聴くとき=マイク、鳴らすとき=スピーカーへ自動で切り替え。</a:t>
+              <a:t>傾けている間、高音のペンタトニックがランダムにまたたく。傾きが強いほど、大きく・速く。</a:t>
             </a:r>
           </a:p>
           <a:p>
@@ -6778,7 +7308,7 @@
                 <a:ea typeface="Meiryo"/>
                 <a:cs typeface="Meiryo"/>
               </a:rPr>
-              <a:t>The shared ES8311 codec swaps between mic and speaker automatically.</a:t>
+              <a:t>Pentatonic sparkles twinkle louder and faster the harder you tilt.</a:t>
             </a:r>
           </a:p>
         </p:txBody>
@@ -6888,7 +7418,7 @@
                 <a:ea typeface="Meiryo"/>
                 <a:cs typeface="Meiryo"/>
               </a:rPr>
-              <a:t>部屋の空気も、その色に — 環境光</a:t>
+              <a:t>声の色 — あなたの声は何色?</a:t>
             </a:r>
           </a:p>
         </p:txBody>
@@ -6925,14 +7455,14 @@
                 <a:ea typeface="Meiryo"/>
                 <a:cs typeface="Meiryo"/>
               </a:rPr>
-              <a:t>Ambient Light — the room wears the color</a:t>
+              <a:t>Voice Color — what does your voice look like?</a:t>
             </a:r>
           </a:p>
         </p:txBody>
       </p:sp>
       <p:pic>
         <p:nvPicPr>
-          <p:cNvPr id="5" name="Picture 4" descr="mock_hexled.png"/>
+          <p:cNvPr id="5" name="Picture 4" descr="mock_voice.png"/>
           <p:cNvPicPr>
             <a:picLocks noChangeAspect="1"/>
           </p:cNvPicPr>
@@ -6946,8 +7476,8 @@
         </p:blipFill>
         <p:spPr>
           <a:xfrm>
-            <a:off x="6720840" y="1508760"/>
-            <a:ext cx="4480560" cy="4480560"/>
+            <a:off x="6537960" y="1508760"/>
+            <a:ext cx="4754880" cy="4754880"/>
           </a:xfrm>
           <a:prstGeom prst="rect">
             <a:avLst/>
@@ -6963,7 +7493,7 @@
         <p:spPr>
           <a:xfrm>
             <a:off x="822960" y="1645920"/>
-            <a:ext cx="5394960" cy="1463040"/>
+            <a:ext cx="5120640" cy="1463040"/>
           </a:xfrm>
           <a:prstGeom prst="rect">
             <a:avLst/>
@@ -6990,7 +7520,7 @@
                 <a:ea typeface="Meiryo"/>
                 <a:cs typeface="Meiryo"/>
               </a:rPr>
-              <a:t>Unit Hex (LED×37) と連動</a:t>
+              <a:t>話しかけると、色になる</a:t>
             </a:r>
           </a:p>
           <a:p>
@@ -7011,7 +7541,7 @@
                 <a:ea typeface="Meiryo"/>
                 <a:cs typeface="Meiryo"/>
               </a:rPr>
-              <a:t>つなぐだけで、37個のLEDが全モードの「いまの色」と同期。空の色が部屋ににじみ出す。</a:t>
+              <a:t>マイクが声をリアルタイムに色へ。声の高さ→色相 (低い声は赤、高い声は紫)、大きさ→明るさ。</a:t>
             </a:r>
           </a:p>
           <a:p>
@@ -7029,7 +7559,7 @@
                 <a:ea typeface="Meiryo"/>
                 <a:cs typeface="Meiryo"/>
               </a:rPr>
-              <a:t>37 NeoPixels mirror the current color of every mode — just plug it in.</a:t>
+              <a:t>Pitch becomes hue, loudness becomes brightness — in real time.</a:t>
             </a:r>
           </a:p>
         </p:txBody>
@@ -7043,7 +7573,7 @@
         <p:spPr>
           <a:xfrm>
             <a:off x="822960" y="3291840"/>
-            <a:ext cx="5394960" cy="1463040"/>
+            <a:ext cx="5120640" cy="1463040"/>
           </a:xfrm>
           <a:prstGeom prst="rect">
             <a:avLst/>
@@ -7070,7 +7600,7 @@
                 <a:ea typeface="Meiryo"/>
                 <a:cs typeface="Meiryo"/>
               </a:rPr>
-              <a:t>本体だけで細かく調整</a:t>
+              <a:t>声の色が、返事をする</a:t>
             </a:r>
           </a:p>
           <a:p>
@@ -7091,7 +7621,7 @@
                 <a:ea typeface="Meiryo"/>
                 <a:cs typeface="Meiryo"/>
               </a:rPr>
-              <a:t>LEDのオン/オフ・明るさ (2〜100%)・音量まで、ボタンとゲージ画面で調整。設定は保存。</a:t>
+              <a:t>話し終わると、デバイスが「あなたの声の色の音」を鳴らして返す。歌えば色が踊る。</a:t>
             </a:r>
           </a:p>
           <a:p>
@@ -7109,7 +7639,7 @@
                 <a:ea typeface="Meiryo"/>
                 <a:cs typeface="Meiryo"/>
               </a:rPr>
-              <a:t>On-device gauge screens for LED brightness (2-100%) and volume; settings persist.</a:t>
+              <a:t>Stop talking, and the device answers with the sound of your color.</a:t>
             </a:r>
           </a:p>
         </p:txBody>
@@ -7123,7 +7653,7 @@
         <p:spPr>
           <a:xfrm>
             <a:off x="822960" y="4937760"/>
-            <a:ext cx="5394960" cy="1463040"/>
+            <a:ext cx="5120640" cy="1463040"/>
           </a:xfrm>
           <a:prstGeom prst="rect">
             <a:avLst/>
@@ -7150,7 +7680,7 @@
                 <a:ea typeface="Meiryo"/>
                 <a:cs typeface="Meiryo"/>
               </a:rPr>
-              <a:t>色ランダムモード</a:t>
+              <a:t>マイクとスピーカーの自動交代</a:t>
             </a:r>
           </a:p>
           <a:p>
@@ -7171,7 +7701,7 @@
                 <a:ea typeface="Meiryo"/>
                 <a:cs typeface="Meiryo"/>
               </a:rPr>
-              <a:t>時計を動かしたまま、背景色がランダムに漂う。LEDは37個バラバラにきらめく星空になる。</a:t>
+              <a:t>共有コーデック (ES8311) を、聴くとき=マイク、鳴らすとき=スピーカーへ自動で切り替え。</a:t>
             </a:r>
           </a:p>
           <a:p>
@@ -7189,7 +7719,7 @@
                 <a:ea typeface="Meiryo"/>
                 <a:cs typeface="Meiryo"/>
               </a:rPr>
-              <a:t>Random mode drifts the clock's color and turns the panel into a twinkling starfield.</a:t>
+              <a:t>The shared ES8311 codec swaps between mic and speaker automatically.</a:t>
             </a:r>
           </a:p>
         </p:txBody>
@@ -7299,7 +7829,7 @@
                 <a:ea typeface="Meiryo"/>
                 <a:cs typeface="Meiryo"/>
               </a:rPr>
-              <a:t>ストップウォッチ &amp; 星空のサウンド</a:t>
+              <a:t>部屋の空気も、その色に — 環境光</a:t>
             </a:r>
           </a:p>
         </p:txBody>
@@ -7336,14 +7866,14 @@
                 <a:ea typeface="Meiryo"/>
                 <a:cs typeface="Meiryo"/>
               </a:rPr>
-              <a:t>Stopwatch &amp; the sounds of stars, sky and earth</a:t>
+              <a:t>Ambient Light — the room wears the color</a:t>
             </a:r>
           </a:p>
         </p:txBody>
       </p:sp>
       <p:pic>
         <p:nvPicPr>
-          <p:cNvPr id="5" name="Picture 4" descr="mock_stopwatch.png"/>
+          <p:cNvPr id="5" name="Picture 4" descr="mock_hexled.png"/>
           <p:cNvPicPr>
             <a:picLocks noChangeAspect="1"/>
           </p:cNvPicPr>
@@ -7357,8 +7887,8 @@
         </p:blipFill>
         <p:spPr>
           <a:xfrm>
-            <a:off x="777240" y="1691640"/>
-            <a:ext cx="4069080" cy="4069080"/>
+            <a:off x="6720840" y="1508760"/>
+            <a:ext cx="4480560" cy="4480560"/>
           </a:xfrm>
           <a:prstGeom prst="rect">
             <a:avLst/>
@@ -7367,60 +7897,14 @@
       </p:pic>
       <p:sp>
         <p:nvSpPr>
-          <p:cNvPr id="6" name="Rounded Rectangle 5"/>
-          <p:cNvSpPr/>
-          <p:nvPr/>
-        </p:nvSpPr>
-        <p:spPr>
-          <a:xfrm>
-            <a:off x="5440680" y="1554480"/>
-            <a:ext cx="5897880" cy="2514600"/>
-          </a:xfrm>
-          <a:prstGeom prst="roundRect">
-            <a:avLst>
-              <a:gd name="adj" fmla="val 4500"/>
-            </a:avLst>
-          </a:prstGeom>
-          <a:solidFill>
-            <a:srgbClr val="1B2248"/>
-          </a:solidFill>
-          <a:ln>
-            <a:noFill/>
-          </a:ln>
-          <a:effectLst/>
-        </p:spPr>
-        <p:style>
-          <a:lnRef idx="1">
-            <a:schemeClr val="accent1"/>
-          </a:lnRef>
-          <a:fillRef idx="3">
-            <a:schemeClr val="accent1"/>
-          </a:fillRef>
-          <a:effectRef idx="2">
-            <a:schemeClr val="accent1"/>
-          </a:effectRef>
-          <a:fontRef idx="minor">
-            <a:schemeClr val="lt1"/>
-          </a:fontRef>
-        </p:style>
-        <p:txBody>
-          <a:bodyPr rtlCol="0" anchor="ctr"/>
-          <a:lstStyle/>
-          <a:p>
-            <a:pPr algn="ctr"/>
-          </a:p>
-        </p:txBody>
-      </p:sp>
-      <p:sp>
-        <p:nvSpPr>
-          <p:cNvPr id="7" name="TextBox 6"/>
+          <p:cNvPr id="6" name="TextBox 5"/>
           <p:cNvSpPr txBox="1"/>
           <p:nvPr/>
         </p:nvSpPr>
         <p:spPr>
           <a:xfrm>
-            <a:off x="5760720" y="1755648"/>
-            <a:ext cx="5257800" cy="2194560"/>
+            <a:off x="822960" y="1645920"/>
+            <a:ext cx="5394960" cy="1463040"/>
           </a:xfrm>
           <a:prstGeom prst="rect">
             <a:avLst/>
@@ -7435,11 +7919,11 @@
           <a:p>
             <a:pPr algn="l">
               <a:spcAft>
-                <a:spcPts val="200"/>
+                <a:spcPts val="300"/>
               </a:spcAft>
             </a:pPr>
             <a:r>
-              <a:rPr sz="1800" b="1" i="0">
+              <a:rPr sz="1750" b="1" i="0">
                 <a:solidFill>
                   <a:srgbClr val="F9C46B"/>
                 </a:solidFill>
@@ -7447,17 +7931,38 @@
                 <a:ea typeface="Meiryo"/>
                 <a:cs typeface="Meiryo"/>
               </a:rPr>
-              <a:t>星・空・地球をイメージした音</a:t>
+              <a:t>Unit Hex (LED×37) と連動</a:t>
             </a:r>
           </a:p>
           <a:p>
             <a:pPr algn="l">
+              <a:lnSpc>
+                <a:spcPct val="120000"/>
+              </a:lnSpc>
               <a:spcAft>
-                <a:spcPts val="700"/>
+                <a:spcPts val="300"/>
               </a:spcAft>
             </a:pPr>
             <a:r>
-              <a:rPr sz="1150" b="0" i="1">
+              <a:rPr sz="1350" b="0" i="0">
+                <a:solidFill>
+                  <a:srgbClr val="F2F4FF"/>
+                </a:solidFill>
+                <a:latin typeface="Meiryo"/>
+                <a:ea typeface="Meiryo"/>
+                <a:cs typeface="Meiryo"/>
+              </a:rPr>
+              <a:t>つなぐだけで、37個のLEDが全モードの「いまの色」と同期。空の色が部屋ににじみ出す。</a:t>
+            </a:r>
+          </a:p>
+          <a:p>
+            <a:pPr algn="l">
+              <a:lnSpc>
+                <a:spcPct val="115000"/>
+              </a:lnSpc>
+            </a:pPr>
+            <a:r>
+              <a:rPr sz="1150" b="0" i="0">
                 <a:solidFill>
                   <a:srgbClr val="A9B4D6"/>
                 </a:solidFill>
@@ -7465,135 +7970,21 @@
                 <a:ea typeface="Meiryo"/>
                 <a:cs typeface="Meiryo"/>
               </a:rPr>
-              <a:t>Every sound is celestial-themed</a:t>
-            </a:r>
-          </a:p>
-          <a:p>
-            <a:pPr algn="l">
-              <a:spcAft>
-                <a:spcPts val="400"/>
-              </a:spcAft>
-            </a:pPr>
-            <a:r>
-              <a:rPr sz="1350" b="0" i="0">
-                <a:solidFill>
-                  <a:srgbClr val="F2F4FF"/>
-                </a:solidFill>
-                <a:latin typeface="Meiryo"/>
-                <a:ea typeface="Meiryo"/>
-                <a:cs typeface="Meiryo"/>
-              </a:rPr>
-              <a:t>・モード切替 — 星のまたたきのような2音 / star-twinkle</a:t>
-            </a:r>
-          </a:p>
-          <a:p>
-            <a:pPr algn="l">
-              <a:spcAft>
-                <a:spcPts val="400"/>
-              </a:spcAft>
-            </a:pPr>
-            <a:r>
-              <a:rPr sz="1350" b="0" i="0">
-                <a:solidFill>
-                  <a:srgbClr val="F2F4FF"/>
-                </a:solidFill>
-                <a:latin typeface="Meiryo"/>
-                <a:ea typeface="Meiryo"/>
-                <a:cs typeface="Meiryo"/>
-              </a:rPr>
-              <a:t>・毎正時 — 遠くの鐘のような上昇アルペジオ / hourly bell</a:t>
-            </a:r>
-          </a:p>
-          <a:p>
-            <a:pPr algn="l">
-              <a:spcAft>
-                <a:spcPts val="400"/>
-              </a:spcAft>
-            </a:pPr>
-            <a:r>
-              <a:rPr sz="1350" b="0" i="0">
-                <a:solidFill>
-                  <a:srgbClr val="F2F4FF"/>
-                </a:solidFill>
-                <a:latin typeface="Meiryo"/>
-                <a:ea typeface="Meiryo"/>
-                <a:cs typeface="Meiryo"/>
-              </a:rPr>
-              <a:t>・色を混ぜた瞬間 — その色自身の音 / the color's own note</a:t>
-            </a:r>
-          </a:p>
-          <a:p>
-            <a:pPr algn="l"/>
-            <a:r>
-              <a:rPr sz="1350" b="0" i="0">
-                <a:solidFill>
-                  <a:srgbClr val="F2F4FF"/>
-                </a:solidFill>
-                <a:latin typeface="Meiryo"/>
-                <a:ea typeface="Meiryo"/>
-                <a:cs typeface="Meiryo"/>
-              </a:rPr>
-              <a:t>・消音 — 大地を思わせる低い一音 / a low "earth" tone</a:t>
-            </a:r>
-          </a:p>
-        </p:txBody>
-      </p:sp>
-      <p:sp>
-        <p:nvSpPr>
-          <p:cNvPr id="8" name="Rounded Rectangle 7"/>
-          <p:cNvSpPr/>
-          <p:nvPr/>
-        </p:nvSpPr>
-        <p:spPr>
-          <a:xfrm>
-            <a:off x="5440680" y="4251960"/>
-            <a:ext cx="5897880" cy="1783080"/>
-          </a:xfrm>
-          <a:prstGeom prst="roundRect">
-            <a:avLst>
-              <a:gd name="adj" fmla="val 4500"/>
-            </a:avLst>
-          </a:prstGeom>
-          <a:solidFill>
-            <a:srgbClr val="1B2248"/>
-          </a:solidFill>
-          <a:ln>
-            <a:noFill/>
-          </a:ln>
-          <a:effectLst/>
-        </p:spPr>
-        <p:style>
-          <a:lnRef idx="1">
-            <a:schemeClr val="accent1"/>
-          </a:lnRef>
-          <a:fillRef idx="3">
-            <a:schemeClr val="accent1"/>
-          </a:fillRef>
-          <a:effectRef idx="2">
-            <a:schemeClr val="accent1"/>
-          </a:effectRef>
-          <a:fontRef idx="minor">
-            <a:schemeClr val="lt1"/>
-          </a:fontRef>
-        </p:style>
-        <p:txBody>
-          <a:bodyPr rtlCol="0" anchor="ctr"/>
-          <a:lstStyle/>
-          <a:p>
-            <a:pPr algn="ctr"/>
-          </a:p>
-        </p:txBody>
-      </p:sp>
-      <p:sp>
-        <p:nvSpPr>
-          <p:cNvPr id="9" name="TextBox 8"/>
+              <a:t>37 NeoPixels mirror the current color of every mode — just plug it in.</a:t>
+            </a:r>
+          </a:p>
+        </p:txBody>
+      </p:sp>
+      <p:sp>
+        <p:nvSpPr>
+          <p:cNvPr id="7" name="TextBox 6"/>
           <p:cNvSpPr txBox="1"/>
           <p:nvPr/>
         </p:nvSpPr>
         <p:spPr>
           <a:xfrm>
-            <a:off x="5760720" y="4453128"/>
-            <a:ext cx="5257800" cy="1463040"/>
+            <a:off x="822960" y="3291840"/>
+            <a:ext cx="5394960" cy="1463040"/>
           </a:xfrm>
           <a:prstGeom prst="rect">
             <a:avLst/>
@@ -7608,11 +7999,11 @@
           <a:p>
             <a:pPr algn="l">
               <a:spcAft>
-                <a:spcPts val="200"/>
+                <a:spcPts val="300"/>
               </a:spcAft>
             </a:pPr>
             <a:r>
-              <a:rPr sz="1800" b="1" i="0">
+              <a:rPr sz="1750" b="1" i="0">
                 <a:solidFill>
                   <a:srgbClr val="F9C46B"/>
                 </a:solidFill>
@@ -7620,17 +8011,118 @@
                 <a:ea typeface="Meiryo"/>
                 <a:cs typeface="Meiryo"/>
               </a:rPr>
-              <a:t>1/100秒ストップウォッチ</a:t>
-            </a:r>
-          </a:p>
+              <a:t>本体だけで細かく調整</a:t>
+            </a:r>
+          </a:p>
+          <a:p>
+            <a:pPr algn="l">
+              <a:lnSpc>
+                <a:spcPct val="120000"/>
+              </a:lnSpc>
+              <a:spcAft>
+                <a:spcPts val="300"/>
+              </a:spcAft>
+            </a:pPr>
+            <a:r>
+              <a:rPr sz="1350" b="0" i="0">
+                <a:solidFill>
+                  <a:srgbClr val="F2F4FF"/>
+                </a:solidFill>
+                <a:latin typeface="Meiryo"/>
+                <a:ea typeface="Meiryo"/>
+                <a:cs typeface="Meiryo"/>
+              </a:rPr>
+              <a:t>LEDのオン/オフ・明るさ (2〜100%)・音量まで、ボタンとゲージ画面で調整。設定は保存。</a:t>
+            </a:r>
+          </a:p>
+          <a:p>
+            <a:pPr algn="l">
+              <a:lnSpc>
+                <a:spcPct val="115000"/>
+              </a:lnSpc>
+            </a:pPr>
+            <a:r>
+              <a:rPr sz="1150" b="0" i="0">
+                <a:solidFill>
+                  <a:srgbClr val="A9B4D6"/>
+                </a:solidFill>
+                <a:latin typeface="Meiryo"/>
+                <a:ea typeface="Meiryo"/>
+                <a:cs typeface="Meiryo"/>
+              </a:rPr>
+              <a:t>On-device gauge screens for LED brightness (2-100%) and volume; settings persist.</a:t>
+            </a:r>
+          </a:p>
+        </p:txBody>
+      </p:sp>
+      <p:sp>
+        <p:nvSpPr>
+          <p:cNvPr id="8" name="TextBox 7"/>
+          <p:cNvSpPr txBox="1"/>
+          <p:nvPr/>
+        </p:nvSpPr>
+        <p:spPr>
+          <a:xfrm>
+            <a:off x="822960" y="4937760"/>
+            <a:ext cx="5394960" cy="1463040"/>
+          </a:xfrm>
+          <a:prstGeom prst="rect">
+            <a:avLst/>
+          </a:prstGeom>
+          <a:noFill/>
+        </p:spPr>
+        <p:txBody>
+          <a:bodyPr wrap="square" anchor="t" lIns="0" rIns="0" tIns="0" bIns="0">
+            <a:spAutoFit/>
+          </a:bodyPr>
+          <a:lstStyle/>
           <a:p>
             <a:pPr algn="l">
               <a:spcAft>
-                <a:spcPts val="700"/>
+                <a:spcPts val="300"/>
               </a:spcAft>
             </a:pPr>
             <a:r>
-              <a:rPr sz="1150" b="0" i="1">
+              <a:rPr sz="1750" b="1" i="0">
+                <a:solidFill>
+                  <a:srgbClr val="F9C46B"/>
+                </a:solidFill>
+                <a:latin typeface="Meiryo"/>
+                <a:ea typeface="Meiryo"/>
+                <a:cs typeface="Meiryo"/>
+              </a:rPr>
+              <a:t>色ランダムモード</a:t>
+            </a:r>
+          </a:p>
+          <a:p>
+            <a:pPr algn="l">
+              <a:lnSpc>
+                <a:spcPct val="120000"/>
+              </a:lnSpc>
+              <a:spcAft>
+                <a:spcPts val="300"/>
+              </a:spcAft>
+            </a:pPr>
+            <a:r>
+              <a:rPr sz="1350" b="0" i="0">
+                <a:solidFill>
+                  <a:srgbClr val="F2F4FF"/>
+                </a:solidFill>
+                <a:latin typeface="Meiryo"/>
+                <a:ea typeface="Meiryo"/>
+                <a:cs typeface="Meiryo"/>
+              </a:rPr>
+              <a:t>時計を動かしたまま、背景色がランダムに漂う。LEDは37個バラバラにきらめく星空になる。</a:t>
+            </a:r>
+          </a:p>
+          <a:p>
+            <a:pPr algn="l">
+              <a:lnSpc>
+                <a:spcPct val="115000"/>
+              </a:lnSpc>
+            </a:pPr>
+            <a:r>
+              <a:rPr sz="1150" b="0" i="0">
                 <a:solidFill>
                   <a:srgbClr val="A9B4D6"/>
                 </a:solidFill>
@@ -7638,39 +8130,7 @@
                 <a:ea typeface="Meiryo"/>
                 <a:cs typeface="Meiryo"/>
               </a:rPr>
-              <a:t>A lap-capable 1/100s stopwatch, true to the device's name</a:t>
-            </a:r>
-          </a:p>
-          <a:p>
-            <a:pPr algn="l">
-              <a:spcAft>
-                <a:spcPts val="400"/>
-              </a:spcAft>
-            </a:pPr>
-            <a:r>
-              <a:rPr sz="1350" b="0" i="0">
-                <a:solidFill>
-                  <a:srgbClr val="F2F4FF"/>
-                </a:solidFill>
-                <a:latin typeface="Meiryo"/>
-                <a:ea typeface="Meiryo"/>
-                <a:cs typeface="Meiryo"/>
-              </a:rPr>
-              <a:t>・左ボタンでスタート/ストップ、右ボタンでラップ/リセット</a:t>
-            </a:r>
-          </a:p>
-          <a:p>
-            <a:pPr algn="l"/>
-            <a:r>
-              <a:rPr sz="1350" b="0" i="0">
-                <a:solidFill>
-                  <a:srgbClr val="F2F4FF"/>
-                </a:solidFill>
-                <a:latin typeface="Meiryo"/>
-                <a:ea typeface="Meiryo"/>
-                <a:cs typeface="Meiryo"/>
-              </a:rPr>
-              <a:t>・デバイス名 “StopWatch” への、まっすぐなリスペクト</a:t>
+              <a:t>Random mode drifts the clock's color and turns the panel into a twinkling starfield.</a:t>
             </a:r>
           </a:p>
         </p:txBody>

</xml_diff>